<commit_message>
Correct Lecture 1 Cold War map and refresh images and reading
</commit_message>
<xml_diff>
--- a/teaching/macro-applications/downloads/lecture_1.pptx
+++ b/teaching/macro-applications/downloads/lecture_1.pptx
@@ -2,39 +2,39 @@
 <file path=ppt/presentation.xml><?xml version="1.0" encoding="utf-8"?>
 <p:presentation xmlns:p="http://schemas.openxmlformats.org/presentationml/2006/main">
   <p:sldMasterIdLst>
-    <p:sldMasterId xmlns:r="http://schemas.openxmlformats.org/officeDocument/2006/relationships" id="2147483648" r:id="R4ead73eef5d6444d"/>
+    <p:sldMasterId xmlns:r="http://schemas.openxmlformats.org/officeDocument/2006/relationships" id="2147483648" r:id="Rc3a66c52ef5e47f9"/>
   </p:sldMasterIdLst>
   <p:notesMasterIdLst>
-    <p:notesMasterId xmlns:r="http://schemas.openxmlformats.org/officeDocument/2006/relationships" r:id="Ra909c64b09924f0e"/>
+    <p:notesMasterId xmlns:r="http://schemas.openxmlformats.org/officeDocument/2006/relationships" r:id="R80cd14b302c541e9"/>
   </p:notesMasterIdLst>
   <p:sldIdLst>
-    <p:sldId xmlns:r="http://schemas.openxmlformats.org/officeDocument/2006/relationships" id="256" r:id="Rd780fdfb988a4ac9"/>
-    <p:sldId xmlns:r="http://schemas.openxmlformats.org/officeDocument/2006/relationships" id="257" r:id="R6860c5791c704156"/>
-    <p:sldId xmlns:r="http://schemas.openxmlformats.org/officeDocument/2006/relationships" id="258" r:id="R26b5d28970f04210"/>
-    <p:sldId xmlns:r="http://schemas.openxmlformats.org/officeDocument/2006/relationships" id="259" r:id="R9869eeeda04d433a"/>
-    <p:sldId xmlns:r="http://schemas.openxmlformats.org/officeDocument/2006/relationships" id="260" r:id="Rfa937f71e34a4c56"/>
-    <p:sldId xmlns:r="http://schemas.openxmlformats.org/officeDocument/2006/relationships" id="261" r:id="R43d5fe694e3c421a"/>
-    <p:sldId xmlns:r="http://schemas.openxmlformats.org/officeDocument/2006/relationships" id="262" r:id="Rf47c015f062148ef"/>
-    <p:sldId xmlns:r="http://schemas.openxmlformats.org/officeDocument/2006/relationships" id="263" r:id="Rb9b8914877274933"/>
-    <p:sldId xmlns:r="http://schemas.openxmlformats.org/officeDocument/2006/relationships" id="264" r:id="R4848f66b27eb4f37"/>
-    <p:sldId xmlns:r="http://schemas.openxmlformats.org/officeDocument/2006/relationships" id="265" r:id="R6c53e2c79ed94b17"/>
-    <p:sldId xmlns:r="http://schemas.openxmlformats.org/officeDocument/2006/relationships" id="266" r:id="R7823d12d1e0c4c4e"/>
-    <p:sldId xmlns:r="http://schemas.openxmlformats.org/officeDocument/2006/relationships" id="267" r:id="R6596170cfab14936"/>
-    <p:sldId xmlns:r="http://schemas.openxmlformats.org/officeDocument/2006/relationships" id="268" r:id="R709590b58dee4ade"/>
-    <p:sldId xmlns:r="http://schemas.openxmlformats.org/officeDocument/2006/relationships" id="269" r:id="R7cc45e9af77148ce"/>
-    <p:sldId xmlns:r="http://schemas.openxmlformats.org/officeDocument/2006/relationships" id="270" r:id="Rc0000a7e35bd4e3e"/>
-    <p:sldId xmlns:r="http://schemas.openxmlformats.org/officeDocument/2006/relationships" id="271" r:id="R21c7abd4c0e949e8"/>
-    <p:sldId xmlns:r="http://schemas.openxmlformats.org/officeDocument/2006/relationships" id="272" r:id="Rb33a128143aa4f08"/>
-    <p:sldId xmlns:r="http://schemas.openxmlformats.org/officeDocument/2006/relationships" id="273" r:id="Rcfa5a10f11574919"/>
-    <p:sldId xmlns:r="http://schemas.openxmlformats.org/officeDocument/2006/relationships" id="274" r:id="R87a51d80fc5e42da"/>
-    <p:sldId xmlns:r="http://schemas.openxmlformats.org/officeDocument/2006/relationships" id="275" r:id="R11961f197ca849fd"/>
-    <p:sldId xmlns:r="http://schemas.openxmlformats.org/officeDocument/2006/relationships" id="276" r:id="Rec7206a1b7cd47c1"/>
-    <p:sldId xmlns:r="http://schemas.openxmlformats.org/officeDocument/2006/relationships" id="277" r:id="Rc70c7102ffab4fe6"/>
-    <p:sldId xmlns:r="http://schemas.openxmlformats.org/officeDocument/2006/relationships" id="278" r:id="R408be4dc38704992"/>
-    <p:sldId xmlns:r="http://schemas.openxmlformats.org/officeDocument/2006/relationships" id="279" r:id="Re3babdb7686843f5"/>
-    <p:sldId xmlns:r="http://schemas.openxmlformats.org/officeDocument/2006/relationships" id="280" r:id="R715ee081247e4139"/>
-    <p:sldId xmlns:r="http://schemas.openxmlformats.org/officeDocument/2006/relationships" id="281" r:id="Rb9494f09d4644b77"/>
-    <p:sldId xmlns:r="http://schemas.openxmlformats.org/officeDocument/2006/relationships" id="282" r:id="R19beda911a044047"/>
+    <p:sldId xmlns:r="http://schemas.openxmlformats.org/officeDocument/2006/relationships" id="256" r:id="Rf77e8e824ec74b5e"/>
+    <p:sldId xmlns:r="http://schemas.openxmlformats.org/officeDocument/2006/relationships" id="257" r:id="Rd2f427d861644d9c"/>
+    <p:sldId xmlns:r="http://schemas.openxmlformats.org/officeDocument/2006/relationships" id="258" r:id="R1c314bc249d146cf"/>
+    <p:sldId xmlns:r="http://schemas.openxmlformats.org/officeDocument/2006/relationships" id="259" r:id="R78fb67a8ff2c4580"/>
+    <p:sldId xmlns:r="http://schemas.openxmlformats.org/officeDocument/2006/relationships" id="260" r:id="R8da4355344dc47aa"/>
+    <p:sldId xmlns:r="http://schemas.openxmlformats.org/officeDocument/2006/relationships" id="261" r:id="Rbda1fe62bfa14b8f"/>
+    <p:sldId xmlns:r="http://schemas.openxmlformats.org/officeDocument/2006/relationships" id="262" r:id="R30520f3584254bc3"/>
+    <p:sldId xmlns:r="http://schemas.openxmlformats.org/officeDocument/2006/relationships" id="263" r:id="R1c0390913b824167"/>
+    <p:sldId xmlns:r="http://schemas.openxmlformats.org/officeDocument/2006/relationships" id="264" r:id="Rcf2aedd048134c39"/>
+    <p:sldId xmlns:r="http://schemas.openxmlformats.org/officeDocument/2006/relationships" id="265" r:id="R1432646c98714fcc"/>
+    <p:sldId xmlns:r="http://schemas.openxmlformats.org/officeDocument/2006/relationships" id="266" r:id="R946409275b3a4310"/>
+    <p:sldId xmlns:r="http://schemas.openxmlformats.org/officeDocument/2006/relationships" id="267" r:id="R5a4a0dcde1584069"/>
+    <p:sldId xmlns:r="http://schemas.openxmlformats.org/officeDocument/2006/relationships" id="268" r:id="Reec13299c054413b"/>
+    <p:sldId xmlns:r="http://schemas.openxmlformats.org/officeDocument/2006/relationships" id="269" r:id="R4e98cde9367b449d"/>
+    <p:sldId xmlns:r="http://schemas.openxmlformats.org/officeDocument/2006/relationships" id="270" r:id="Ra60be4093ab54f2a"/>
+    <p:sldId xmlns:r="http://schemas.openxmlformats.org/officeDocument/2006/relationships" id="271" r:id="R45ff1e4e7b1d4a8a"/>
+    <p:sldId xmlns:r="http://schemas.openxmlformats.org/officeDocument/2006/relationships" id="272" r:id="R84dec8ea9bc34f30"/>
+    <p:sldId xmlns:r="http://schemas.openxmlformats.org/officeDocument/2006/relationships" id="273" r:id="R7ef0548a1ee24967"/>
+    <p:sldId xmlns:r="http://schemas.openxmlformats.org/officeDocument/2006/relationships" id="274" r:id="R7110caa6a7354a75"/>
+    <p:sldId xmlns:r="http://schemas.openxmlformats.org/officeDocument/2006/relationships" id="275" r:id="Ra2da69b8e5df4f15"/>
+    <p:sldId xmlns:r="http://schemas.openxmlformats.org/officeDocument/2006/relationships" id="276" r:id="Ra548e03faedc4407"/>
+    <p:sldId xmlns:r="http://schemas.openxmlformats.org/officeDocument/2006/relationships" id="277" r:id="Rf42dae14ee154834"/>
+    <p:sldId xmlns:r="http://schemas.openxmlformats.org/officeDocument/2006/relationships" id="278" r:id="Rabe223b186d0473f"/>
+    <p:sldId xmlns:r="http://schemas.openxmlformats.org/officeDocument/2006/relationships" id="279" r:id="Rec1f3b2f23c848ff"/>
+    <p:sldId xmlns:r="http://schemas.openxmlformats.org/officeDocument/2006/relationships" id="280" r:id="R5fc5e7637f334906"/>
+    <p:sldId xmlns:r="http://schemas.openxmlformats.org/officeDocument/2006/relationships" id="281" r:id="R09c542f907854b31"/>
+    <p:sldId xmlns:r="http://schemas.openxmlformats.org/officeDocument/2006/relationships" id="282" r:id="R9800b471a30f490a"/>
   </p:sldIdLst>
   <p:sldSz cx="12192000" cy="6858000"/>
   <p:notesSz cx="6858000" cy="9144000"/>
@@ -1808,17 +1808,27 @@
           </a:p>
           <a:p xmlns:a="http://schemas.openxmlformats.org/drawingml/2006/main">
             <a:r>
-              <a:t>A singer holding a microphone performs before a large crowd at night, with the Brandenburg Gate behind him.</a:t>
-            </a:r>
-          </a:p>
-          <a:p xmlns:a="http://schemas.openxmlformats.org/drawingml/2006/main">
-            <a:r>
-              <a:t/>
-            </a:r>
-          </a:p>
-          <a:p xmlns:a="http://schemas.openxmlformats.org/drawingml/2006/main">
-            <a:r>
-              <a:t/>
+              <a:t>David Hasselhoff, Berlin, 31 December 1989. Photograph: picture-alliance/dpa/H.-J. Wöstmann, via Deutsche Welle.</a:t>
+            </a:r>
+          </a:p>
+          <a:p xmlns:a="http://schemas.openxmlformats.org/drawingml/2006/main">
+            <a:r>
+              <a:t/>
+            </a:r>
+          </a:p>
+          <a:p xmlns:a="http://schemas.openxmlformats.org/drawingml/2006/main">
+            <a:r>
+              <a:t>David Hasselhoff performs at Berlin's New Year's Eve celebrations in 1989, wearing his leather jacket with small lights and a piano-keyboard scarf. The crowd is visible behind him.</a:t>
+            </a:r>
+          </a:p>
+          <a:p xmlns:a="http://schemas.openxmlformats.org/drawingml/2006/main">
+            <a:r>
+              <a:t/>
+            </a:r>
+          </a:p>
+          <a:p xmlns:a="http://schemas.openxmlformats.org/drawingml/2006/main">
+            <a:r>
+              <a:t>https://www.dw.com/en/why-germany-loves-david-hasselhoff/a-59048932</a:t>
             </a:r>
           </a:p>
         </p:txBody>
@@ -2948,7 +2958,17 @@
           </a:p>
           <a:p xmlns:a="http://schemas.openxmlformats.org/drawingml/2006/main">
             <a:r>
-              <a:t>Baldwin and Wyplosz (2022), The Economics of European Integration, Chapter 1.</a:t>
+              <a:t>Baldwin and Wyplosz, The Economics of European Integration, Chapter 1 (any edition).</a:t>
+            </a:r>
+          </a:p>
+          <a:p xmlns:a="http://schemas.openxmlformats.org/drawingml/2006/main">
+            <a:r>
+              <a:t/>
+            </a:r>
+          </a:p>
+          <a:p xmlns:a="http://schemas.openxmlformats.org/drawingml/2006/main">
+            <a:r>
+              <a:t>The Talis reading list links to the 2022 seventh edition online.</a:t>
             </a:r>
           </a:p>
           <a:p xmlns:a="http://schemas.openxmlformats.org/drawingml/2006/main">
@@ -2999,6 +3019,11 @@
           <a:p xmlns:a="http://schemas.openxmlformats.org/drawingml/2006/main">
             <a:r>
               <a:t/>
+            </a:r>
+          </a:p>
+          <a:p xmlns:a="http://schemas.openxmlformats.org/drawingml/2006/main">
+            <a:r>
+              <a:t>https://durham.rl.talis.com/modules/econ2271.html</a:t>
             </a:r>
           </a:p>
           <a:p xmlns:a="http://schemas.openxmlformats.org/drawingml/2006/main">
@@ -3998,17 +4023,77 @@
           </a:p>
           <a:p xmlns:a="http://schemas.openxmlformats.org/drawingml/2006/main">
             <a:r>
-              <a:t>Historical map of Cold War Europe. Blue marks the Western bloc and red the Eastern bloc, separated by the Iron Curtain. Germany is divided between the two blocs; several other countries are uncoloured.</a:t>
-            </a:r>
-          </a:p>
-          <a:p xmlns:a="http://schemas.openxmlformats.org/drawingml/2006/main">
-            <a:r>
-              <a:t/>
-            </a:r>
-          </a:p>
-          <a:p xmlns:a="http://schemas.openxmlformats.org/drawingml/2006/main">
-            <a:r>
-              <a:t/>
+              <a:t>Western bloc</a:t>
+            </a:r>
+          </a:p>
+          <a:p xmlns:a="http://schemas.openxmlformats.org/drawingml/2006/main">
+            <a:r>
+              <a:t>NATO</a:t>
+            </a:r>
+          </a:p>
+          <a:p xmlns:a="http://schemas.openxmlformats.org/drawingml/2006/main">
+            <a:r>
+              <a:t>Eastern bloc</a:t>
+            </a:r>
+          </a:p>
+          <a:p xmlns:a="http://schemas.openxmlformats.org/drawingml/2006/main">
+            <a:r>
+              <a:t>Warsaw Pact</a:t>
+            </a:r>
+          </a:p>
+          <a:p xmlns:a="http://schemas.openxmlformats.org/drawingml/2006/main">
+            <a:r>
+              <a:t>Neutral countries</a:t>
+            </a:r>
+          </a:p>
+          <a:p xmlns:a="http://schemas.openxmlformats.org/drawingml/2006/main">
+            <a:r>
+              <a:t>Non-aligned Yugoslavia</a:t>
+            </a:r>
+          </a:p>
+          <a:p xmlns:a="http://schemas.openxmlformats.org/drawingml/2006/main">
+            <a:r>
+              <a:t>Albania: left the Warsaw Pact in 1968</a:t>
+            </a:r>
+          </a:p>
+          <a:p xmlns:a="http://schemas.openxmlformats.org/drawingml/2006/main">
+            <a:r>
+              <a:t>Iron Curtain</a:t>
+            </a:r>
+          </a:p>
+          <a:p xmlns:a="http://schemas.openxmlformats.org/drawingml/2006/main">
+            <a:r>
+              <a:t/>
+            </a:r>
+          </a:p>
+          <a:p xmlns:a="http://schemas.openxmlformats.org/drawingml/2006/main">
+            <a:r>
+              <a:t>Later Cold War alignments; memberships changed over time. Map: Sémhur / Wikimedia Commons, CC BY-SA 4.0, unchanged.</a:t>
+            </a:r>
+          </a:p>
+          <a:p xmlns:a="http://schemas.openxmlformats.org/drawingml/2006/main">
+            <a:r>
+              <a:t/>
+            </a:r>
+          </a:p>
+          <a:p xmlns:a="http://schemas.openxmlformats.org/drawingml/2006/main">
+            <a:r>
+              <a:t>Vector map of Cold War Europe. NATO countries are blue and Warsaw Pact countries pink, with the Iron Curtain marked by a thick black line. Neutral countries are grey and non-aligned Yugoslavia is green. Germany is divided. Albania is striped to reflect its withdrawal from the Warsaw Pact.</a:t>
+            </a:r>
+          </a:p>
+          <a:p xmlns:a="http://schemas.openxmlformats.org/drawingml/2006/main">
+            <a:r>
+              <a:t/>
+            </a:r>
+          </a:p>
+          <a:p xmlns:a="http://schemas.openxmlformats.org/drawingml/2006/main">
+            <a:r>
+              <a:t>https://commons.wikimedia.org/wiki/File:Iron_Curtain_map.svg</a:t>
+            </a:r>
+          </a:p>
+          <a:p xmlns:a="http://schemas.openxmlformats.org/drawingml/2006/main">
+            <a:r>
+              <a:t>https://creativecommons.org/licenses/by-sa/4.0/</a:t>
             </a:r>
           </a:p>
         </p:txBody>
@@ -4076,7 +4161,7 @@
   </p:cSld>
   <p:clrMap bg1="lt1" tx1="dk1" bg2="lt2" tx2="dk2" accent1="accent1" accent2="accent2" accent3="accent3" accent4="accent4" accent5="accent5" accent6="accent6" hlink="hlink" folHlink="folHlink"/>
   <p:sldLayoutIdLst>
-    <p:sldLayoutId xmlns:r="http://schemas.openxmlformats.org/officeDocument/2006/relationships" id="2147483649" r:id="Reba4f873033c47a0"/>
+    <p:sldLayoutId xmlns:r="http://schemas.openxmlformats.org/officeDocument/2006/relationships" id="2147483649" r:id="Ra4d7740a96de480e"/>
   </p:sldLayoutIdLst>
   <p:txStyles>
     <p:titleStyle>
@@ -4624,7 +4709,7 @@
           <p:nvPr/>
         </p:nvPicPr>
         <p:blipFill>
-          <a:blip xmlns:r="http://schemas.openxmlformats.org/officeDocument/2006/relationships" xmlns:a="http://schemas.openxmlformats.org/drawingml/2006/main" r:embed="R7bf7afa9288f43c8"/>
+          <a:blip xmlns:r="http://schemas.openxmlformats.org/officeDocument/2006/relationships" xmlns:a="http://schemas.openxmlformats.org/drawingml/2006/main" r:embed="R3e8105c5a58845f1"/>
           <a:stretch xmlns:a="http://schemas.openxmlformats.org/drawingml/2006/main"/>
         </p:blipFill>
         <p:spPr>
@@ -4640,7 +4725,7 @@
     </p:spTree>
     <p:extLst>
       <p:ext uri="{BB962C8B-B14F-4D97-AF65-F5344CB8AC3E}">
-        <p14:creationId xmlns:p14="http://schemas.microsoft.com/office/powerpoint/2010/main" val="1268291807"/>
+        <p14:creationId xmlns:p14="http://schemas.microsoft.com/office/powerpoint/2010/main" val="152229726"/>
       </p:ext>
     </p:extLst>
   </p:cSld>
@@ -4668,7 +4753,7 @@
           <p:nvPr/>
         </p:nvPicPr>
         <p:blipFill>
-          <a:blip xmlns:r="http://schemas.openxmlformats.org/officeDocument/2006/relationships" xmlns:a="http://schemas.openxmlformats.org/drawingml/2006/main" r:embed="R103f427a12e5427f"/>
+          <a:blip xmlns:r="http://schemas.openxmlformats.org/officeDocument/2006/relationships" xmlns:a="http://schemas.openxmlformats.org/drawingml/2006/main" r:embed="Ra53faf33dc46419a"/>
           <a:stretch xmlns:a="http://schemas.openxmlformats.org/drawingml/2006/main"/>
         </p:blipFill>
         <p:spPr>
@@ -4684,7 +4769,7 @@
     </p:spTree>
     <p:extLst>
       <p:ext uri="{BB962C8B-B14F-4D97-AF65-F5344CB8AC3E}">
-        <p14:creationId xmlns:p14="http://schemas.microsoft.com/office/powerpoint/2010/main" val="94910008"/>
+        <p14:creationId xmlns:p14="http://schemas.microsoft.com/office/powerpoint/2010/main" val="1511968111"/>
       </p:ext>
     </p:extLst>
   </p:cSld>
@@ -4712,7 +4797,7 @@
           <p:nvPr/>
         </p:nvPicPr>
         <p:blipFill>
-          <a:blip xmlns:r="http://schemas.openxmlformats.org/officeDocument/2006/relationships" xmlns:a="http://schemas.openxmlformats.org/drawingml/2006/main" r:embed="R540390c0969f4434"/>
+          <a:blip xmlns:r="http://schemas.openxmlformats.org/officeDocument/2006/relationships" xmlns:a="http://schemas.openxmlformats.org/drawingml/2006/main" r:embed="R9482aa84e658445e"/>
           <a:stretch xmlns:a="http://schemas.openxmlformats.org/drawingml/2006/main"/>
         </p:blipFill>
         <p:spPr>
@@ -4728,7 +4813,7 @@
     </p:spTree>
     <p:extLst>
       <p:ext uri="{BB962C8B-B14F-4D97-AF65-F5344CB8AC3E}">
-        <p14:creationId xmlns:p14="http://schemas.microsoft.com/office/powerpoint/2010/main" val="191258608"/>
+        <p14:creationId xmlns:p14="http://schemas.microsoft.com/office/powerpoint/2010/main" val="1580560590"/>
       </p:ext>
     </p:extLst>
   </p:cSld>
@@ -4756,7 +4841,7 @@
           <p:nvPr/>
         </p:nvPicPr>
         <p:blipFill>
-          <a:blip xmlns:r="http://schemas.openxmlformats.org/officeDocument/2006/relationships" xmlns:a="http://schemas.openxmlformats.org/drawingml/2006/main" r:embed="Rae6da22959f24cca"/>
+          <a:blip xmlns:r="http://schemas.openxmlformats.org/officeDocument/2006/relationships" xmlns:a="http://schemas.openxmlformats.org/drawingml/2006/main" r:embed="Rb49561e4aaf64300"/>
           <a:stretch xmlns:a="http://schemas.openxmlformats.org/drawingml/2006/main"/>
         </p:blipFill>
         <p:spPr>
@@ -4772,7 +4857,7 @@
     </p:spTree>
     <p:extLst>
       <p:ext uri="{BB962C8B-B14F-4D97-AF65-F5344CB8AC3E}">
-        <p14:creationId xmlns:p14="http://schemas.microsoft.com/office/powerpoint/2010/main" val="233885190"/>
+        <p14:creationId xmlns:p14="http://schemas.microsoft.com/office/powerpoint/2010/main" val="1976159714"/>
       </p:ext>
     </p:extLst>
   </p:cSld>
@@ -4800,7 +4885,7 @@
           <p:nvPr/>
         </p:nvPicPr>
         <p:blipFill>
-          <a:blip xmlns:r="http://schemas.openxmlformats.org/officeDocument/2006/relationships" xmlns:a="http://schemas.openxmlformats.org/drawingml/2006/main" r:embed="Rd6458f9a5fcc4e5a"/>
+          <a:blip xmlns:r="http://schemas.openxmlformats.org/officeDocument/2006/relationships" xmlns:a="http://schemas.openxmlformats.org/drawingml/2006/main" r:embed="Rb004aa28e9594281"/>
           <a:stretch xmlns:a="http://schemas.openxmlformats.org/drawingml/2006/main"/>
         </p:blipFill>
         <p:spPr>
@@ -4816,7 +4901,7 @@
     </p:spTree>
     <p:extLst>
       <p:ext uri="{BB962C8B-B14F-4D97-AF65-F5344CB8AC3E}">
-        <p14:creationId xmlns:p14="http://schemas.microsoft.com/office/powerpoint/2010/main" val="2050270712"/>
+        <p14:creationId xmlns:p14="http://schemas.microsoft.com/office/powerpoint/2010/main" val="512888682"/>
       </p:ext>
     </p:extLst>
   </p:cSld>
@@ -4844,7 +4929,7 @@
           <p:nvPr/>
         </p:nvPicPr>
         <p:blipFill>
-          <a:blip xmlns:r="http://schemas.openxmlformats.org/officeDocument/2006/relationships" xmlns:a="http://schemas.openxmlformats.org/drawingml/2006/main" r:embed="Ra2597d36af8f40d3"/>
+          <a:blip xmlns:r="http://schemas.openxmlformats.org/officeDocument/2006/relationships" xmlns:a="http://schemas.openxmlformats.org/drawingml/2006/main" r:embed="Rdb3e32f0c2904d76"/>
           <a:stretch xmlns:a="http://schemas.openxmlformats.org/drawingml/2006/main"/>
         </p:blipFill>
         <p:spPr>
@@ -4860,7 +4945,7 @@
     </p:spTree>
     <p:extLst>
       <p:ext uri="{BB962C8B-B14F-4D97-AF65-F5344CB8AC3E}">
-        <p14:creationId xmlns:p14="http://schemas.microsoft.com/office/powerpoint/2010/main" val="739423159"/>
+        <p14:creationId xmlns:p14="http://schemas.microsoft.com/office/powerpoint/2010/main" val="420400100"/>
       </p:ext>
     </p:extLst>
   </p:cSld>
@@ -4888,7 +4973,7 @@
           <p:nvPr/>
         </p:nvPicPr>
         <p:blipFill>
-          <a:blip xmlns:r="http://schemas.openxmlformats.org/officeDocument/2006/relationships" xmlns:a="http://schemas.openxmlformats.org/drawingml/2006/main" r:embed="Rf8b8779d695d4945"/>
+          <a:blip xmlns:r="http://schemas.openxmlformats.org/officeDocument/2006/relationships" xmlns:a="http://schemas.openxmlformats.org/drawingml/2006/main" r:embed="R68150cb812664b03"/>
           <a:stretch xmlns:a="http://schemas.openxmlformats.org/drawingml/2006/main"/>
         </p:blipFill>
         <p:spPr>
@@ -4904,7 +4989,7 @@
     </p:spTree>
     <p:extLst>
       <p:ext uri="{BB962C8B-B14F-4D97-AF65-F5344CB8AC3E}">
-        <p14:creationId xmlns:p14="http://schemas.microsoft.com/office/powerpoint/2010/main" val="1641564783"/>
+        <p14:creationId xmlns:p14="http://schemas.microsoft.com/office/powerpoint/2010/main" val="1632220364"/>
       </p:ext>
     </p:extLst>
   </p:cSld>
@@ -4932,7 +5017,7 @@
           <p:nvPr/>
         </p:nvPicPr>
         <p:blipFill>
-          <a:blip xmlns:r="http://schemas.openxmlformats.org/officeDocument/2006/relationships" xmlns:a="http://schemas.openxmlformats.org/drawingml/2006/main" r:embed="R332ce147f3ae4618"/>
+          <a:blip xmlns:r="http://schemas.openxmlformats.org/officeDocument/2006/relationships" xmlns:a="http://schemas.openxmlformats.org/drawingml/2006/main" r:embed="Ra61f13210d0842e0"/>
           <a:stretch xmlns:a="http://schemas.openxmlformats.org/drawingml/2006/main"/>
         </p:blipFill>
         <p:spPr>
@@ -4948,7 +5033,7 @@
     </p:spTree>
     <p:extLst>
       <p:ext uri="{BB962C8B-B14F-4D97-AF65-F5344CB8AC3E}">
-        <p14:creationId xmlns:p14="http://schemas.microsoft.com/office/powerpoint/2010/main" val="1581196030"/>
+        <p14:creationId xmlns:p14="http://schemas.microsoft.com/office/powerpoint/2010/main" val="1938612159"/>
       </p:ext>
     </p:extLst>
   </p:cSld>
@@ -4976,7 +5061,7 @@
           <p:nvPr/>
         </p:nvPicPr>
         <p:blipFill>
-          <a:blip xmlns:r="http://schemas.openxmlformats.org/officeDocument/2006/relationships" xmlns:a="http://schemas.openxmlformats.org/drawingml/2006/main" r:embed="R883a29e0ca76493d"/>
+          <a:blip xmlns:r="http://schemas.openxmlformats.org/officeDocument/2006/relationships" xmlns:a="http://schemas.openxmlformats.org/drawingml/2006/main" r:embed="R960c12e980ea42aa"/>
           <a:stretch xmlns:a="http://schemas.openxmlformats.org/drawingml/2006/main"/>
         </p:blipFill>
         <p:spPr>
@@ -4992,7 +5077,7 @@
     </p:spTree>
     <p:extLst>
       <p:ext uri="{BB962C8B-B14F-4D97-AF65-F5344CB8AC3E}">
-        <p14:creationId xmlns:p14="http://schemas.microsoft.com/office/powerpoint/2010/main" val="767158014"/>
+        <p14:creationId xmlns:p14="http://schemas.microsoft.com/office/powerpoint/2010/main" val="826649630"/>
       </p:ext>
     </p:extLst>
   </p:cSld>
@@ -5020,7 +5105,7 @@
           <p:nvPr/>
         </p:nvPicPr>
         <p:blipFill>
-          <a:blip xmlns:r="http://schemas.openxmlformats.org/officeDocument/2006/relationships" xmlns:a="http://schemas.openxmlformats.org/drawingml/2006/main" r:embed="R8592e784588d4b9c"/>
+          <a:blip xmlns:r="http://schemas.openxmlformats.org/officeDocument/2006/relationships" xmlns:a="http://schemas.openxmlformats.org/drawingml/2006/main" r:embed="Rdcc8953ae31246a1"/>
           <a:stretch xmlns:a="http://schemas.openxmlformats.org/drawingml/2006/main"/>
         </p:blipFill>
         <p:spPr>
@@ -5036,7 +5121,7 @@
     </p:spTree>
     <p:extLst>
       <p:ext uri="{BB962C8B-B14F-4D97-AF65-F5344CB8AC3E}">
-        <p14:creationId xmlns:p14="http://schemas.microsoft.com/office/powerpoint/2010/main" val="504645082"/>
+        <p14:creationId xmlns:p14="http://schemas.microsoft.com/office/powerpoint/2010/main" val="947485940"/>
       </p:ext>
     </p:extLst>
   </p:cSld>
@@ -5064,7 +5149,7 @@
           <p:nvPr/>
         </p:nvPicPr>
         <p:blipFill>
-          <a:blip xmlns:r="http://schemas.openxmlformats.org/officeDocument/2006/relationships" xmlns:a="http://schemas.openxmlformats.org/drawingml/2006/main" r:embed="R3f0f24359aa347c5"/>
+          <a:blip xmlns:r="http://schemas.openxmlformats.org/officeDocument/2006/relationships" xmlns:a="http://schemas.openxmlformats.org/drawingml/2006/main" r:embed="R4eedd3f65e194f79"/>
           <a:stretch xmlns:a="http://schemas.openxmlformats.org/drawingml/2006/main"/>
         </p:blipFill>
         <p:spPr>
@@ -5080,7 +5165,7 @@
     </p:spTree>
     <p:extLst>
       <p:ext uri="{BB962C8B-B14F-4D97-AF65-F5344CB8AC3E}">
-        <p14:creationId xmlns:p14="http://schemas.microsoft.com/office/powerpoint/2010/main" val="1730022056"/>
+        <p14:creationId xmlns:p14="http://schemas.microsoft.com/office/powerpoint/2010/main" val="1523561383"/>
       </p:ext>
     </p:extLst>
   </p:cSld>
@@ -5108,7 +5193,7 @@
           <p:nvPr/>
         </p:nvPicPr>
         <p:blipFill>
-          <a:blip xmlns:r="http://schemas.openxmlformats.org/officeDocument/2006/relationships" xmlns:a="http://schemas.openxmlformats.org/drawingml/2006/main" r:embed="R8c40bb161f0a4af9"/>
+          <a:blip xmlns:r="http://schemas.openxmlformats.org/officeDocument/2006/relationships" xmlns:a="http://schemas.openxmlformats.org/drawingml/2006/main" r:embed="Rd87bd0f72ddf4e98"/>
           <a:stretch xmlns:a="http://schemas.openxmlformats.org/drawingml/2006/main"/>
         </p:blipFill>
         <p:spPr>
@@ -5124,7 +5209,7 @@
     </p:spTree>
     <p:extLst>
       <p:ext uri="{BB962C8B-B14F-4D97-AF65-F5344CB8AC3E}">
-        <p14:creationId xmlns:p14="http://schemas.microsoft.com/office/powerpoint/2010/main" val="1569790260"/>
+        <p14:creationId xmlns:p14="http://schemas.microsoft.com/office/powerpoint/2010/main" val="2006974241"/>
       </p:ext>
     </p:extLst>
   </p:cSld>
@@ -5152,7 +5237,7 @@
           <p:nvPr/>
         </p:nvPicPr>
         <p:blipFill>
-          <a:blip xmlns:r="http://schemas.openxmlformats.org/officeDocument/2006/relationships" xmlns:a="http://schemas.openxmlformats.org/drawingml/2006/main" r:embed="Rae0c6f4ff6db4bbd"/>
+          <a:blip xmlns:r="http://schemas.openxmlformats.org/officeDocument/2006/relationships" xmlns:a="http://schemas.openxmlformats.org/drawingml/2006/main" r:embed="R445961468fbd4ab4"/>
           <a:stretch xmlns:a="http://schemas.openxmlformats.org/drawingml/2006/main"/>
         </p:blipFill>
         <p:spPr>
@@ -5168,7 +5253,7 @@
     </p:spTree>
     <p:extLst>
       <p:ext uri="{BB962C8B-B14F-4D97-AF65-F5344CB8AC3E}">
-        <p14:creationId xmlns:p14="http://schemas.microsoft.com/office/powerpoint/2010/main" val="1422483802"/>
+        <p14:creationId xmlns:p14="http://schemas.microsoft.com/office/powerpoint/2010/main" val="1907312165"/>
       </p:ext>
     </p:extLst>
   </p:cSld>
@@ -5196,7 +5281,7 @@
           <p:nvPr/>
         </p:nvPicPr>
         <p:blipFill>
-          <a:blip xmlns:r="http://schemas.openxmlformats.org/officeDocument/2006/relationships" xmlns:a="http://schemas.openxmlformats.org/drawingml/2006/main" r:embed="Rde9f3c6ea91043dc"/>
+          <a:blip xmlns:r="http://schemas.openxmlformats.org/officeDocument/2006/relationships" xmlns:a="http://schemas.openxmlformats.org/drawingml/2006/main" r:embed="Rd84b5c0907f4414a"/>
           <a:stretch xmlns:a="http://schemas.openxmlformats.org/drawingml/2006/main"/>
         </p:blipFill>
         <p:spPr>
@@ -5212,7 +5297,7 @@
     </p:spTree>
     <p:extLst>
       <p:ext uri="{BB962C8B-B14F-4D97-AF65-F5344CB8AC3E}">
-        <p14:creationId xmlns:p14="http://schemas.microsoft.com/office/powerpoint/2010/main" val="1502904275"/>
+        <p14:creationId xmlns:p14="http://schemas.microsoft.com/office/powerpoint/2010/main" val="345234559"/>
       </p:ext>
     </p:extLst>
   </p:cSld>
@@ -5240,7 +5325,7 @@
           <p:nvPr/>
         </p:nvPicPr>
         <p:blipFill>
-          <a:blip xmlns:r="http://schemas.openxmlformats.org/officeDocument/2006/relationships" xmlns:a="http://schemas.openxmlformats.org/drawingml/2006/main" r:embed="Rae6683b541844bb5"/>
+          <a:blip xmlns:r="http://schemas.openxmlformats.org/officeDocument/2006/relationships" xmlns:a="http://schemas.openxmlformats.org/drawingml/2006/main" r:embed="R6b045f6bb41d4c6a"/>
           <a:stretch xmlns:a="http://schemas.openxmlformats.org/drawingml/2006/main"/>
         </p:blipFill>
         <p:spPr>
@@ -5256,7 +5341,7 @@
     </p:spTree>
     <p:extLst>
       <p:ext uri="{BB962C8B-B14F-4D97-AF65-F5344CB8AC3E}">
-        <p14:creationId xmlns:p14="http://schemas.microsoft.com/office/powerpoint/2010/main" val="539854170"/>
+        <p14:creationId xmlns:p14="http://schemas.microsoft.com/office/powerpoint/2010/main" val="579553167"/>
       </p:ext>
     </p:extLst>
   </p:cSld>
@@ -5284,7 +5369,7 @@
           <p:nvPr/>
         </p:nvPicPr>
         <p:blipFill>
-          <a:blip xmlns:r="http://schemas.openxmlformats.org/officeDocument/2006/relationships" xmlns:a="http://schemas.openxmlformats.org/drawingml/2006/main" r:embed="Re19effe873bd45d8"/>
+          <a:blip xmlns:r="http://schemas.openxmlformats.org/officeDocument/2006/relationships" xmlns:a="http://schemas.openxmlformats.org/drawingml/2006/main" r:embed="Rf3e07a7ed6d34bd5"/>
           <a:stretch xmlns:a="http://schemas.openxmlformats.org/drawingml/2006/main"/>
         </p:blipFill>
         <p:spPr>
@@ -5300,7 +5385,7 @@
     </p:spTree>
     <p:extLst>
       <p:ext uri="{BB962C8B-B14F-4D97-AF65-F5344CB8AC3E}">
-        <p14:creationId xmlns:p14="http://schemas.microsoft.com/office/powerpoint/2010/main" val="173002983"/>
+        <p14:creationId xmlns:p14="http://schemas.microsoft.com/office/powerpoint/2010/main" val="910910976"/>
       </p:ext>
     </p:extLst>
   </p:cSld>
@@ -5328,7 +5413,7 @@
           <p:nvPr/>
         </p:nvPicPr>
         <p:blipFill>
-          <a:blip xmlns:r="http://schemas.openxmlformats.org/officeDocument/2006/relationships" xmlns:a="http://schemas.openxmlformats.org/drawingml/2006/main" r:embed="R50a5de300efa46da"/>
+          <a:blip xmlns:r="http://schemas.openxmlformats.org/officeDocument/2006/relationships" xmlns:a="http://schemas.openxmlformats.org/drawingml/2006/main" r:embed="Reac819dbd6cd4970"/>
           <a:stretch xmlns:a="http://schemas.openxmlformats.org/drawingml/2006/main"/>
         </p:blipFill>
         <p:spPr>
@@ -5344,7 +5429,7 @@
     </p:spTree>
     <p:extLst>
       <p:ext uri="{BB962C8B-B14F-4D97-AF65-F5344CB8AC3E}">
-        <p14:creationId xmlns:p14="http://schemas.microsoft.com/office/powerpoint/2010/main" val="1554182892"/>
+        <p14:creationId xmlns:p14="http://schemas.microsoft.com/office/powerpoint/2010/main" val="277476872"/>
       </p:ext>
     </p:extLst>
   </p:cSld>
@@ -5372,7 +5457,7 @@
           <p:nvPr/>
         </p:nvPicPr>
         <p:blipFill>
-          <a:blip xmlns:r="http://schemas.openxmlformats.org/officeDocument/2006/relationships" xmlns:a="http://schemas.openxmlformats.org/drawingml/2006/main" r:embed="Re094db06321a48e8"/>
+          <a:blip xmlns:r="http://schemas.openxmlformats.org/officeDocument/2006/relationships" xmlns:a="http://schemas.openxmlformats.org/drawingml/2006/main" r:embed="Ra9ba233b53fb4a05"/>
           <a:stretch xmlns:a="http://schemas.openxmlformats.org/drawingml/2006/main"/>
         </p:blipFill>
         <p:spPr>
@@ -5388,7 +5473,7 @@
     </p:spTree>
     <p:extLst>
       <p:ext uri="{BB962C8B-B14F-4D97-AF65-F5344CB8AC3E}">
-        <p14:creationId xmlns:p14="http://schemas.microsoft.com/office/powerpoint/2010/main" val="1523837207"/>
+        <p14:creationId xmlns:p14="http://schemas.microsoft.com/office/powerpoint/2010/main" val="1428159975"/>
       </p:ext>
     </p:extLst>
   </p:cSld>
@@ -5416,7 +5501,7 @@
           <p:nvPr/>
         </p:nvPicPr>
         <p:blipFill>
-          <a:blip xmlns:r="http://schemas.openxmlformats.org/officeDocument/2006/relationships" xmlns:a="http://schemas.openxmlformats.org/drawingml/2006/main" r:embed="Ree7a3c73fb924b2a"/>
+          <a:blip xmlns:r="http://schemas.openxmlformats.org/officeDocument/2006/relationships" xmlns:a="http://schemas.openxmlformats.org/drawingml/2006/main" r:embed="R669469c0d7994677"/>
           <a:stretch xmlns:a="http://schemas.openxmlformats.org/drawingml/2006/main"/>
         </p:blipFill>
         <p:spPr>
@@ -5432,7 +5517,7 @@
     </p:spTree>
     <p:extLst>
       <p:ext uri="{BB962C8B-B14F-4D97-AF65-F5344CB8AC3E}">
-        <p14:creationId xmlns:p14="http://schemas.microsoft.com/office/powerpoint/2010/main" val="181600537"/>
+        <p14:creationId xmlns:p14="http://schemas.microsoft.com/office/powerpoint/2010/main" val="470571442"/>
       </p:ext>
     </p:extLst>
   </p:cSld>
@@ -5460,7 +5545,7 @@
           <p:nvPr/>
         </p:nvPicPr>
         <p:blipFill>
-          <a:blip xmlns:r="http://schemas.openxmlformats.org/officeDocument/2006/relationships" xmlns:a="http://schemas.openxmlformats.org/drawingml/2006/main" r:embed="R74cc71e1a5374b68"/>
+          <a:blip xmlns:r="http://schemas.openxmlformats.org/officeDocument/2006/relationships" xmlns:a="http://schemas.openxmlformats.org/drawingml/2006/main" r:embed="R752fdba9d53a4e17"/>
           <a:stretch xmlns:a="http://schemas.openxmlformats.org/drawingml/2006/main"/>
         </p:blipFill>
         <p:spPr>
@@ -5476,7 +5561,7 @@
     </p:spTree>
     <p:extLst>
       <p:ext uri="{BB962C8B-B14F-4D97-AF65-F5344CB8AC3E}">
-        <p14:creationId xmlns:p14="http://schemas.microsoft.com/office/powerpoint/2010/main" val="1700403561"/>
+        <p14:creationId xmlns:p14="http://schemas.microsoft.com/office/powerpoint/2010/main" val="1929073526"/>
       </p:ext>
     </p:extLst>
   </p:cSld>
@@ -5504,7 +5589,7 @@
           <p:nvPr/>
         </p:nvPicPr>
         <p:blipFill>
-          <a:blip xmlns:r="http://schemas.openxmlformats.org/officeDocument/2006/relationships" xmlns:a="http://schemas.openxmlformats.org/drawingml/2006/main" r:embed="R65942867d1cd4265"/>
+          <a:blip xmlns:r="http://schemas.openxmlformats.org/officeDocument/2006/relationships" xmlns:a="http://schemas.openxmlformats.org/drawingml/2006/main" r:embed="Rceb24fb162144c3a"/>
           <a:stretch xmlns:a="http://schemas.openxmlformats.org/drawingml/2006/main"/>
         </p:blipFill>
         <p:spPr>
@@ -5520,7 +5605,7 @@
     </p:spTree>
     <p:extLst>
       <p:ext uri="{BB962C8B-B14F-4D97-AF65-F5344CB8AC3E}">
-        <p14:creationId xmlns:p14="http://schemas.microsoft.com/office/powerpoint/2010/main" val="1786637560"/>
+        <p14:creationId xmlns:p14="http://schemas.microsoft.com/office/powerpoint/2010/main" val="1253569383"/>
       </p:ext>
     </p:extLst>
   </p:cSld>
@@ -5548,7 +5633,7 @@
           <p:nvPr/>
         </p:nvPicPr>
         <p:blipFill>
-          <a:blip xmlns:r="http://schemas.openxmlformats.org/officeDocument/2006/relationships" xmlns:a="http://schemas.openxmlformats.org/drawingml/2006/main" r:embed="Rbb59dcabd4c14eeb"/>
+          <a:blip xmlns:r="http://schemas.openxmlformats.org/officeDocument/2006/relationships" xmlns:a="http://schemas.openxmlformats.org/drawingml/2006/main" r:embed="R82c27776d63346d0"/>
           <a:stretch xmlns:a="http://schemas.openxmlformats.org/drawingml/2006/main"/>
         </p:blipFill>
         <p:spPr>
@@ -5564,7 +5649,7 @@
     </p:spTree>
     <p:extLst>
       <p:ext uri="{BB962C8B-B14F-4D97-AF65-F5344CB8AC3E}">
-        <p14:creationId xmlns:p14="http://schemas.microsoft.com/office/powerpoint/2010/main" val="2114654098"/>
+        <p14:creationId xmlns:p14="http://schemas.microsoft.com/office/powerpoint/2010/main" val="1858874278"/>
       </p:ext>
     </p:extLst>
   </p:cSld>
@@ -5592,7 +5677,7 @@
           <p:nvPr/>
         </p:nvPicPr>
         <p:blipFill>
-          <a:blip xmlns:r="http://schemas.openxmlformats.org/officeDocument/2006/relationships" xmlns:a="http://schemas.openxmlformats.org/drawingml/2006/main" r:embed="Rff0889f8a3c44e86"/>
+          <a:blip xmlns:r="http://schemas.openxmlformats.org/officeDocument/2006/relationships" xmlns:a="http://schemas.openxmlformats.org/drawingml/2006/main" r:embed="R0a4a65039ed04918"/>
           <a:stretch xmlns:a="http://schemas.openxmlformats.org/drawingml/2006/main"/>
         </p:blipFill>
         <p:spPr>
@@ -5608,7 +5693,7 @@
     </p:spTree>
     <p:extLst>
       <p:ext uri="{BB962C8B-B14F-4D97-AF65-F5344CB8AC3E}">
-        <p14:creationId xmlns:p14="http://schemas.microsoft.com/office/powerpoint/2010/main" val="1764998393"/>
+        <p14:creationId xmlns:p14="http://schemas.microsoft.com/office/powerpoint/2010/main" val="1167067331"/>
       </p:ext>
     </p:extLst>
   </p:cSld>
@@ -5636,7 +5721,7 @@
           <p:nvPr/>
         </p:nvPicPr>
         <p:blipFill>
-          <a:blip xmlns:r="http://schemas.openxmlformats.org/officeDocument/2006/relationships" xmlns:a="http://schemas.openxmlformats.org/drawingml/2006/main" r:embed="Red31063a209f49b6"/>
+          <a:blip xmlns:r="http://schemas.openxmlformats.org/officeDocument/2006/relationships" xmlns:a="http://schemas.openxmlformats.org/drawingml/2006/main" r:embed="Rf50806962adf47c7"/>
           <a:stretch xmlns:a="http://schemas.openxmlformats.org/drawingml/2006/main"/>
         </p:blipFill>
         <p:spPr>
@@ -5652,7 +5737,7 @@
     </p:spTree>
     <p:extLst>
       <p:ext uri="{BB962C8B-B14F-4D97-AF65-F5344CB8AC3E}">
-        <p14:creationId xmlns:p14="http://schemas.microsoft.com/office/powerpoint/2010/main" val="1181073570"/>
+        <p14:creationId xmlns:p14="http://schemas.microsoft.com/office/powerpoint/2010/main" val="107493978"/>
       </p:ext>
     </p:extLst>
   </p:cSld>
@@ -5680,7 +5765,7 @@
           <p:nvPr/>
         </p:nvPicPr>
         <p:blipFill>
-          <a:blip xmlns:r="http://schemas.openxmlformats.org/officeDocument/2006/relationships" xmlns:a="http://schemas.openxmlformats.org/drawingml/2006/main" r:embed="R899d23ee14414a1f"/>
+          <a:blip xmlns:r="http://schemas.openxmlformats.org/officeDocument/2006/relationships" xmlns:a="http://schemas.openxmlformats.org/drawingml/2006/main" r:embed="R3d11c6a1f4e54c80"/>
           <a:stretch xmlns:a="http://schemas.openxmlformats.org/drawingml/2006/main"/>
         </p:blipFill>
         <p:spPr>
@@ -5696,7 +5781,7 @@
     </p:spTree>
     <p:extLst>
       <p:ext uri="{BB962C8B-B14F-4D97-AF65-F5344CB8AC3E}">
-        <p14:creationId xmlns:p14="http://schemas.microsoft.com/office/powerpoint/2010/main" val="2079491752"/>
+        <p14:creationId xmlns:p14="http://schemas.microsoft.com/office/powerpoint/2010/main" val="72795023"/>
       </p:ext>
     </p:extLst>
   </p:cSld>
@@ -5724,7 +5809,7 @@
           <p:nvPr/>
         </p:nvPicPr>
         <p:blipFill>
-          <a:blip xmlns:r="http://schemas.openxmlformats.org/officeDocument/2006/relationships" xmlns:a="http://schemas.openxmlformats.org/drawingml/2006/main" r:embed="Rc9a22133b37f4837"/>
+          <a:blip xmlns:r="http://schemas.openxmlformats.org/officeDocument/2006/relationships" xmlns:a="http://schemas.openxmlformats.org/drawingml/2006/main" r:embed="Rbede1b531dcc42d9"/>
           <a:stretch xmlns:a="http://schemas.openxmlformats.org/drawingml/2006/main"/>
         </p:blipFill>
         <p:spPr>
@@ -5740,7 +5825,7 @@
     </p:spTree>
     <p:extLst>
       <p:ext uri="{BB962C8B-B14F-4D97-AF65-F5344CB8AC3E}">
-        <p14:creationId xmlns:p14="http://schemas.microsoft.com/office/powerpoint/2010/main" val="1865656996"/>
+        <p14:creationId xmlns:p14="http://schemas.microsoft.com/office/powerpoint/2010/main" val="30682631"/>
       </p:ext>
     </p:extLst>
   </p:cSld>
@@ -5768,7 +5853,7 @@
           <p:nvPr/>
         </p:nvPicPr>
         <p:blipFill>
-          <a:blip xmlns:r="http://schemas.openxmlformats.org/officeDocument/2006/relationships" xmlns:a="http://schemas.openxmlformats.org/drawingml/2006/main" r:embed="R3a88be9ea0b543da"/>
+          <a:blip xmlns:r="http://schemas.openxmlformats.org/officeDocument/2006/relationships" xmlns:a="http://schemas.openxmlformats.org/drawingml/2006/main" r:embed="R3ca8ef810b904b21"/>
           <a:stretch xmlns:a="http://schemas.openxmlformats.org/drawingml/2006/main"/>
         </p:blipFill>
         <p:spPr>
@@ -5784,7 +5869,7 @@
     </p:spTree>
     <p:extLst>
       <p:ext uri="{BB962C8B-B14F-4D97-AF65-F5344CB8AC3E}">
-        <p14:creationId xmlns:p14="http://schemas.microsoft.com/office/powerpoint/2010/main" val="1993880003"/>
+        <p14:creationId xmlns:p14="http://schemas.microsoft.com/office/powerpoint/2010/main" val="1670561483"/>
       </p:ext>
     </p:extLst>
   </p:cSld>

</xml_diff>

<commit_message>
Clarify historical images and add trade-bloc map explanations
</commit_message>
<xml_diff>
--- a/teaching/macro-applications/downloads/lecture_1.pptx
+++ b/teaching/macro-applications/downloads/lecture_1.pptx
@@ -2,39 +2,39 @@
 <file path=ppt/presentation.xml><?xml version="1.0" encoding="utf-8"?>
 <p:presentation xmlns:p="http://schemas.openxmlformats.org/presentationml/2006/main">
   <p:sldMasterIdLst>
-    <p:sldMasterId xmlns:r="http://schemas.openxmlformats.org/officeDocument/2006/relationships" id="2147483648" r:id="Rc3a66c52ef5e47f9"/>
+    <p:sldMasterId xmlns:r="http://schemas.openxmlformats.org/officeDocument/2006/relationships" id="2147483648" r:id="R027a5d4d101146f3"/>
   </p:sldMasterIdLst>
   <p:notesMasterIdLst>
-    <p:notesMasterId xmlns:r="http://schemas.openxmlformats.org/officeDocument/2006/relationships" r:id="R80cd14b302c541e9"/>
+    <p:notesMasterId xmlns:r="http://schemas.openxmlformats.org/officeDocument/2006/relationships" r:id="R159b2fdf43ca4590"/>
   </p:notesMasterIdLst>
   <p:sldIdLst>
-    <p:sldId xmlns:r="http://schemas.openxmlformats.org/officeDocument/2006/relationships" id="256" r:id="Rf77e8e824ec74b5e"/>
-    <p:sldId xmlns:r="http://schemas.openxmlformats.org/officeDocument/2006/relationships" id="257" r:id="Rd2f427d861644d9c"/>
-    <p:sldId xmlns:r="http://schemas.openxmlformats.org/officeDocument/2006/relationships" id="258" r:id="R1c314bc249d146cf"/>
-    <p:sldId xmlns:r="http://schemas.openxmlformats.org/officeDocument/2006/relationships" id="259" r:id="R78fb67a8ff2c4580"/>
-    <p:sldId xmlns:r="http://schemas.openxmlformats.org/officeDocument/2006/relationships" id="260" r:id="R8da4355344dc47aa"/>
-    <p:sldId xmlns:r="http://schemas.openxmlformats.org/officeDocument/2006/relationships" id="261" r:id="Rbda1fe62bfa14b8f"/>
-    <p:sldId xmlns:r="http://schemas.openxmlformats.org/officeDocument/2006/relationships" id="262" r:id="R30520f3584254bc3"/>
-    <p:sldId xmlns:r="http://schemas.openxmlformats.org/officeDocument/2006/relationships" id="263" r:id="R1c0390913b824167"/>
-    <p:sldId xmlns:r="http://schemas.openxmlformats.org/officeDocument/2006/relationships" id="264" r:id="Rcf2aedd048134c39"/>
-    <p:sldId xmlns:r="http://schemas.openxmlformats.org/officeDocument/2006/relationships" id="265" r:id="R1432646c98714fcc"/>
-    <p:sldId xmlns:r="http://schemas.openxmlformats.org/officeDocument/2006/relationships" id="266" r:id="R946409275b3a4310"/>
-    <p:sldId xmlns:r="http://schemas.openxmlformats.org/officeDocument/2006/relationships" id="267" r:id="R5a4a0dcde1584069"/>
-    <p:sldId xmlns:r="http://schemas.openxmlformats.org/officeDocument/2006/relationships" id="268" r:id="Reec13299c054413b"/>
-    <p:sldId xmlns:r="http://schemas.openxmlformats.org/officeDocument/2006/relationships" id="269" r:id="R4e98cde9367b449d"/>
-    <p:sldId xmlns:r="http://schemas.openxmlformats.org/officeDocument/2006/relationships" id="270" r:id="Ra60be4093ab54f2a"/>
-    <p:sldId xmlns:r="http://schemas.openxmlformats.org/officeDocument/2006/relationships" id="271" r:id="R45ff1e4e7b1d4a8a"/>
-    <p:sldId xmlns:r="http://schemas.openxmlformats.org/officeDocument/2006/relationships" id="272" r:id="R84dec8ea9bc34f30"/>
-    <p:sldId xmlns:r="http://schemas.openxmlformats.org/officeDocument/2006/relationships" id="273" r:id="R7ef0548a1ee24967"/>
-    <p:sldId xmlns:r="http://schemas.openxmlformats.org/officeDocument/2006/relationships" id="274" r:id="R7110caa6a7354a75"/>
-    <p:sldId xmlns:r="http://schemas.openxmlformats.org/officeDocument/2006/relationships" id="275" r:id="Ra2da69b8e5df4f15"/>
-    <p:sldId xmlns:r="http://schemas.openxmlformats.org/officeDocument/2006/relationships" id="276" r:id="Ra548e03faedc4407"/>
-    <p:sldId xmlns:r="http://schemas.openxmlformats.org/officeDocument/2006/relationships" id="277" r:id="Rf42dae14ee154834"/>
-    <p:sldId xmlns:r="http://schemas.openxmlformats.org/officeDocument/2006/relationships" id="278" r:id="Rabe223b186d0473f"/>
-    <p:sldId xmlns:r="http://schemas.openxmlformats.org/officeDocument/2006/relationships" id="279" r:id="Rec1f3b2f23c848ff"/>
-    <p:sldId xmlns:r="http://schemas.openxmlformats.org/officeDocument/2006/relationships" id="280" r:id="R5fc5e7637f334906"/>
-    <p:sldId xmlns:r="http://schemas.openxmlformats.org/officeDocument/2006/relationships" id="281" r:id="R09c542f907854b31"/>
-    <p:sldId xmlns:r="http://schemas.openxmlformats.org/officeDocument/2006/relationships" id="282" r:id="R9800b471a30f490a"/>
+    <p:sldId xmlns:r="http://schemas.openxmlformats.org/officeDocument/2006/relationships" id="256" r:id="R3ae3132588854dd3"/>
+    <p:sldId xmlns:r="http://schemas.openxmlformats.org/officeDocument/2006/relationships" id="257" r:id="R68d918a7efdf497b"/>
+    <p:sldId xmlns:r="http://schemas.openxmlformats.org/officeDocument/2006/relationships" id="258" r:id="R18e3dfb23b4a4020"/>
+    <p:sldId xmlns:r="http://schemas.openxmlformats.org/officeDocument/2006/relationships" id="259" r:id="R46d0302ac4c74d74"/>
+    <p:sldId xmlns:r="http://schemas.openxmlformats.org/officeDocument/2006/relationships" id="260" r:id="R0cdb06cab70d41b3"/>
+    <p:sldId xmlns:r="http://schemas.openxmlformats.org/officeDocument/2006/relationships" id="261" r:id="R0fce414b0ced4d09"/>
+    <p:sldId xmlns:r="http://schemas.openxmlformats.org/officeDocument/2006/relationships" id="262" r:id="R6186544d3d0d4eb0"/>
+    <p:sldId xmlns:r="http://schemas.openxmlformats.org/officeDocument/2006/relationships" id="263" r:id="R3fde24aa74bd47b3"/>
+    <p:sldId xmlns:r="http://schemas.openxmlformats.org/officeDocument/2006/relationships" id="264" r:id="R8168fc6a9fff4673"/>
+    <p:sldId xmlns:r="http://schemas.openxmlformats.org/officeDocument/2006/relationships" id="265" r:id="R5ddf33d861e54238"/>
+    <p:sldId xmlns:r="http://schemas.openxmlformats.org/officeDocument/2006/relationships" id="266" r:id="Rea98f945809a43ee"/>
+    <p:sldId xmlns:r="http://schemas.openxmlformats.org/officeDocument/2006/relationships" id="267" r:id="R970bfffcdcc5447d"/>
+    <p:sldId xmlns:r="http://schemas.openxmlformats.org/officeDocument/2006/relationships" id="268" r:id="R6f8d65e0105c4163"/>
+    <p:sldId xmlns:r="http://schemas.openxmlformats.org/officeDocument/2006/relationships" id="269" r:id="R771b510362704cd1"/>
+    <p:sldId xmlns:r="http://schemas.openxmlformats.org/officeDocument/2006/relationships" id="270" r:id="Ra7a596f3c81e46eb"/>
+    <p:sldId xmlns:r="http://schemas.openxmlformats.org/officeDocument/2006/relationships" id="271" r:id="Rc4c4bc88c06544c1"/>
+    <p:sldId xmlns:r="http://schemas.openxmlformats.org/officeDocument/2006/relationships" id="272" r:id="R8f661338f39f4125"/>
+    <p:sldId xmlns:r="http://schemas.openxmlformats.org/officeDocument/2006/relationships" id="273" r:id="Rfaa0a138199f416d"/>
+    <p:sldId xmlns:r="http://schemas.openxmlformats.org/officeDocument/2006/relationships" id="274" r:id="Rcd8a9038e77a413f"/>
+    <p:sldId xmlns:r="http://schemas.openxmlformats.org/officeDocument/2006/relationships" id="275" r:id="Rb51bf09998d245f8"/>
+    <p:sldId xmlns:r="http://schemas.openxmlformats.org/officeDocument/2006/relationships" id="276" r:id="R3072630270fe4a37"/>
+    <p:sldId xmlns:r="http://schemas.openxmlformats.org/officeDocument/2006/relationships" id="277" r:id="Rffc1d8460f4e49f4"/>
+    <p:sldId xmlns:r="http://schemas.openxmlformats.org/officeDocument/2006/relationships" id="278" r:id="R80dfa77c01b449d5"/>
+    <p:sldId xmlns:r="http://schemas.openxmlformats.org/officeDocument/2006/relationships" id="279" r:id="R0b7c378455df4877"/>
+    <p:sldId xmlns:r="http://schemas.openxmlformats.org/officeDocument/2006/relationships" id="280" r:id="R8ef78258ff7b4e05"/>
+    <p:sldId xmlns:r="http://schemas.openxmlformats.org/officeDocument/2006/relationships" id="281" r:id="R1449b03fdb9446de"/>
+    <p:sldId xmlns:r="http://schemas.openxmlformats.org/officeDocument/2006/relationships" id="282" r:id="R5a50d1ad94704c83"/>
   </p:sldIdLst>
   <p:sldSz cx="12192000" cy="6858000"/>
   <p:notesSz cx="6858000" cy="9144000"/>
@@ -1578,17 +1578,27 @@
           </a:p>
           <a:p xmlns:a="http://schemas.openxmlformats.org/drawingml/2006/main">
             <a:r>
-              <a:t>Map of Western European trade arrangements in the 1960s. Two separate circles contain the EEC Six and EFTA Seven. The UK, Denmark and Ireland are outside the EEC; several Southern European countries are outside both groupings.</a:t>
-            </a:r>
-          </a:p>
-          <a:p xmlns:a="http://schemas.openxmlformats.org/drawingml/2006/main">
-            <a:r>
-              <a:t/>
-            </a:r>
-          </a:p>
-          <a:p xmlns:a="http://schemas.openxmlformats.org/drawingml/2006/main">
-            <a:r>
-              <a:t/>
+              <a:t>Schematic after Baldwin and Wyplosz. EFTA history.</a:t>
+            </a:r>
+          </a:p>
+          <a:p xmlns:a="http://schemas.openxmlformats.org/drawingml/2006/main">
+            <a:r>
+              <a:t/>
+            </a:r>
+          </a:p>
+          <a:p xmlns:a="http://schemas.openxmlformats.org/drawingml/2006/main">
+            <a:r>
+              <a:t>Two separate groups: the EEC Six are Belgium, France, West Germany, Italy, Luxembourg and the Netherlands. The EFTA Seven are Austria, Denmark, Norway, Portugal, Sweden, Switzerland and the United Kingdom. Finland is an EFTA associate. Ireland, Iceland, Spain and Greece are outside both groups.</a:t>
+            </a:r>
+          </a:p>
+          <a:p xmlns:a="http://schemas.openxmlformats.org/drawingml/2006/main">
+            <a:r>
+              <a:t/>
+            </a:r>
+          </a:p>
+          <a:p xmlns:a="http://schemas.openxmlformats.org/drawingml/2006/main">
+            <a:r>
+              <a:t>https://www.efta.int/about-efta/european-free-trade-association/history</a:t>
             </a:r>
           </a:p>
         </p:txBody>
@@ -1703,17 +1713,27 @@
           </a:p>
           <a:p xmlns:a="http://schemas.openxmlformats.org/drawingml/2006/main">
             <a:r>
-              <a:t>Map of Western Europe's trade arrangements in the mid-1970s. The UK, Ireland and Denmark now appear inside the expanded EEC. An outer circle also encompasses remaining EFTA countries, illustrating the change from the earlier separate trade blocs.</a:t>
-            </a:r>
-          </a:p>
-          <a:p xmlns:a="http://schemas.openxmlformats.org/drawingml/2006/main">
-            <a:r>
-              <a:t/>
-            </a:r>
-          </a:p>
-          <a:p xmlns:a="http://schemas.openxmlformats.org/drawingml/2006/main">
-            <a:r>
-              <a:t/>
+              <a:t>Mid-1970s. Industrial tariffs phased out by 1977. EFTA history.</a:t>
+            </a:r>
+          </a:p>
+          <a:p xmlns:a="http://schemas.openxmlformats.org/drawingml/2006/main">
+            <a:r>
+              <a:t/>
+            </a:r>
+          </a:p>
+          <a:p xmlns:a="http://schemas.openxmlformats.org/drawingml/2006/main">
+            <a:r>
+              <a:t>Mid-1970s schematic: the EEC Nine now include the UK, Denmark and Ireland. A wider network of industrial free-trade agreements links the EEC to Austria, Iceland, Norway, Portugal, Sweden, Switzerland and associated Finland. The outer circle represents trade links, not EFTA membership of the EEC countries. Spain and Greece remain outside these groups.</a:t>
+            </a:r>
+          </a:p>
+          <a:p xmlns:a="http://schemas.openxmlformats.org/drawingml/2006/main">
+            <a:r>
+              <a:t/>
+            </a:r>
+          </a:p>
+          <a:p xmlns:a="http://schemas.openxmlformats.org/drawingml/2006/main">
+            <a:r>
+              <a:t>https://www.efta.int/about-efta/european-free-trade-association/history</a:t>
             </a:r>
           </a:p>
         </p:txBody>
@@ -1808,27 +1828,32 @@
           </a:p>
           <a:p xmlns:a="http://schemas.openxmlformats.org/drawingml/2006/main">
             <a:r>
-              <a:t>David Hasselhoff, Berlin, 31 December 1989. Photograph: picture-alliance/dpa/H.-J. Wöstmann, via Deutsche Welle.</a:t>
-            </a:r>
-          </a:p>
-          <a:p xmlns:a="http://schemas.openxmlformats.org/drawingml/2006/main">
-            <a:r>
-              <a:t/>
-            </a:r>
-          </a:p>
-          <a:p xmlns:a="http://schemas.openxmlformats.org/drawingml/2006/main">
-            <a:r>
-              <a:t>David Hasselhoff performs at Berlin's New Year's Eve celebrations in 1989, wearing his leather jacket with small lights and a piano-keyboard scarf. The crowd is visible behind him.</a:t>
-            </a:r>
-          </a:p>
-          <a:p xmlns:a="http://schemas.openxmlformats.org/drawingml/2006/main">
-            <a:r>
-              <a:t/>
-            </a:r>
-          </a:p>
-          <a:p xmlns:a="http://schemas.openxmlformats.org/drawingml/2006/main">
-            <a:r>
-              <a:t>https://www.dw.com/en/why-germany-loves-david-hasselhoff/a-59048932</a:t>
+              <a:t>David Hasselhoff above the Berlin Wall, 31 December 1989.</a:t>
+            </a:r>
+          </a:p>
+          <a:p xmlns:a="http://schemas.openxmlformats.org/drawingml/2006/main">
+            <a:r>
+              <a:t>Photograph: Wöstmann/picture alliance/Getty Images, via TIME.</a:t>
+            </a:r>
+          </a:p>
+          <a:p xmlns:a="http://schemas.openxmlformats.org/drawingml/2006/main">
+            <a:r>
+              <a:t/>
+            </a:r>
+          </a:p>
+          <a:p xmlns:a="http://schemas.openxmlformats.org/drawingml/2006/main">
+            <a:r>
+              <a:t>Wide historical photograph of David Hasselhoff singing from a crane above the Berlin Wall on New Year's Eve 1989. His light-up jacket, the camera platform, people standing on the Wall and the crowd below are all visible.</a:t>
+            </a:r>
+          </a:p>
+          <a:p xmlns:a="http://schemas.openxmlformats.org/drawingml/2006/main">
+            <a:r>
+              <a:t/>
+            </a:r>
+          </a:p>
+          <a:p xmlns:a="http://schemas.openxmlformats.org/drawingml/2006/main">
+            <a:r>
+              <a:t>https://time.com/5714602/david-hasselhoff-berlin-wall-fall/</a:t>
             </a:r>
           </a:p>
         </p:txBody>
@@ -4161,7 +4186,7 @@
   </p:cSld>
   <p:clrMap bg1="lt1" tx1="dk1" bg2="lt2" tx2="dk2" accent1="accent1" accent2="accent2" accent3="accent3" accent4="accent4" accent5="accent5" accent6="accent6" hlink="hlink" folHlink="folHlink"/>
   <p:sldLayoutIdLst>
-    <p:sldLayoutId xmlns:r="http://schemas.openxmlformats.org/officeDocument/2006/relationships" id="2147483649" r:id="Ra4d7740a96de480e"/>
+    <p:sldLayoutId xmlns:r="http://schemas.openxmlformats.org/officeDocument/2006/relationships" id="2147483649" r:id="Rfad7dc01a99147ca"/>
   </p:sldLayoutIdLst>
   <p:txStyles>
     <p:titleStyle>
@@ -4709,7 +4734,7 @@
           <p:nvPr/>
         </p:nvPicPr>
         <p:blipFill>
-          <a:blip xmlns:r="http://schemas.openxmlformats.org/officeDocument/2006/relationships" xmlns:a="http://schemas.openxmlformats.org/drawingml/2006/main" r:embed="R3e8105c5a58845f1"/>
+          <a:blip xmlns:r="http://schemas.openxmlformats.org/officeDocument/2006/relationships" xmlns:a="http://schemas.openxmlformats.org/drawingml/2006/main" r:embed="R81dd31a7f0664623"/>
           <a:stretch xmlns:a="http://schemas.openxmlformats.org/drawingml/2006/main"/>
         </p:blipFill>
         <p:spPr>
@@ -4725,7 +4750,7 @@
     </p:spTree>
     <p:extLst>
       <p:ext uri="{BB962C8B-B14F-4D97-AF65-F5344CB8AC3E}">
-        <p14:creationId xmlns:p14="http://schemas.microsoft.com/office/powerpoint/2010/main" val="152229726"/>
+        <p14:creationId xmlns:p14="http://schemas.microsoft.com/office/powerpoint/2010/main" val="1674328575"/>
       </p:ext>
     </p:extLst>
   </p:cSld>
@@ -4753,7 +4778,7 @@
           <p:nvPr/>
         </p:nvPicPr>
         <p:blipFill>
-          <a:blip xmlns:r="http://schemas.openxmlformats.org/officeDocument/2006/relationships" xmlns:a="http://schemas.openxmlformats.org/drawingml/2006/main" r:embed="Ra53faf33dc46419a"/>
+          <a:blip xmlns:r="http://schemas.openxmlformats.org/officeDocument/2006/relationships" xmlns:a="http://schemas.openxmlformats.org/drawingml/2006/main" r:embed="Rbeca3359880246cd"/>
           <a:stretch xmlns:a="http://schemas.openxmlformats.org/drawingml/2006/main"/>
         </p:blipFill>
         <p:spPr>
@@ -4769,7 +4794,7 @@
     </p:spTree>
     <p:extLst>
       <p:ext uri="{BB962C8B-B14F-4D97-AF65-F5344CB8AC3E}">
-        <p14:creationId xmlns:p14="http://schemas.microsoft.com/office/powerpoint/2010/main" val="1511968111"/>
+        <p14:creationId xmlns:p14="http://schemas.microsoft.com/office/powerpoint/2010/main" val="183056590"/>
       </p:ext>
     </p:extLst>
   </p:cSld>
@@ -4797,7 +4822,7 @@
           <p:nvPr/>
         </p:nvPicPr>
         <p:blipFill>
-          <a:blip xmlns:r="http://schemas.openxmlformats.org/officeDocument/2006/relationships" xmlns:a="http://schemas.openxmlformats.org/drawingml/2006/main" r:embed="R9482aa84e658445e"/>
+          <a:blip xmlns:r="http://schemas.openxmlformats.org/officeDocument/2006/relationships" xmlns:a="http://schemas.openxmlformats.org/drawingml/2006/main" r:embed="R5dc8496a5ff4450b"/>
           <a:stretch xmlns:a="http://schemas.openxmlformats.org/drawingml/2006/main"/>
         </p:blipFill>
         <p:spPr>
@@ -4813,7 +4838,7 @@
     </p:spTree>
     <p:extLst>
       <p:ext uri="{BB962C8B-B14F-4D97-AF65-F5344CB8AC3E}">
-        <p14:creationId xmlns:p14="http://schemas.microsoft.com/office/powerpoint/2010/main" val="1580560590"/>
+        <p14:creationId xmlns:p14="http://schemas.microsoft.com/office/powerpoint/2010/main" val="1536371433"/>
       </p:ext>
     </p:extLst>
   </p:cSld>
@@ -4841,7 +4866,7 @@
           <p:nvPr/>
         </p:nvPicPr>
         <p:blipFill>
-          <a:blip xmlns:r="http://schemas.openxmlformats.org/officeDocument/2006/relationships" xmlns:a="http://schemas.openxmlformats.org/drawingml/2006/main" r:embed="Rb49561e4aaf64300"/>
+          <a:blip xmlns:r="http://schemas.openxmlformats.org/officeDocument/2006/relationships" xmlns:a="http://schemas.openxmlformats.org/drawingml/2006/main" r:embed="R2353c391edfc4827"/>
           <a:stretch xmlns:a="http://schemas.openxmlformats.org/drawingml/2006/main"/>
         </p:blipFill>
         <p:spPr>
@@ -4857,7 +4882,7 @@
     </p:spTree>
     <p:extLst>
       <p:ext uri="{BB962C8B-B14F-4D97-AF65-F5344CB8AC3E}">
-        <p14:creationId xmlns:p14="http://schemas.microsoft.com/office/powerpoint/2010/main" val="1976159714"/>
+        <p14:creationId xmlns:p14="http://schemas.microsoft.com/office/powerpoint/2010/main" val="1993694286"/>
       </p:ext>
     </p:extLst>
   </p:cSld>
@@ -4885,7 +4910,7 @@
           <p:nvPr/>
         </p:nvPicPr>
         <p:blipFill>
-          <a:blip xmlns:r="http://schemas.openxmlformats.org/officeDocument/2006/relationships" xmlns:a="http://schemas.openxmlformats.org/drawingml/2006/main" r:embed="Rb004aa28e9594281"/>
+          <a:blip xmlns:r="http://schemas.openxmlformats.org/officeDocument/2006/relationships" xmlns:a="http://schemas.openxmlformats.org/drawingml/2006/main" r:embed="R5a82005745bf47c0"/>
           <a:stretch xmlns:a="http://schemas.openxmlformats.org/drawingml/2006/main"/>
         </p:blipFill>
         <p:spPr>
@@ -4901,7 +4926,7 @@
     </p:spTree>
     <p:extLst>
       <p:ext uri="{BB962C8B-B14F-4D97-AF65-F5344CB8AC3E}">
-        <p14:creationId xmlns:p14="http://schemas.microsoft.com/office/powerpoint/2010/main" val="512888682"/>
+        <p14:creationId xmlns:p14="http://schemas.microsoft.com/office/powerpoint/2010/main" val="1327136452"/>
       </p:ext>
     </p:extLst>
   </p:cSld>
@@ -4929,7 +4954,7 @@
           <p:nvPr/>
         </p:nvPicPr>
         <p:blipFill>
-          <a:blip xmlns:r="http://schemas.openxmlformats.org/officeDocument/2006/relationships" xmlns:a="http://schemas.openxmlformats.org/drawingml/2006/main" r:embed="Rdb3e32f0c2904d76"/>
+          <a:blip xmlns:r="http://schemas.openxmlformats.org/officeDocument/2006/relationships" xmlns:a="http://schemas.openxmlformats.org/drawingml/2006/main" r:embed="R0861cb7ce322470e"/>
           <a:stretch xmlns:a="http://schemas.openxmlformats.org/drawingml/2006/main"/>
         </p:blipFill>
         <p:spPr>
@@ -4945,7 +4970,7 @@
     </p:spTree>
     <p:extLst>
       <p:ext uri="{BB962C8B-B14F-4D97-AF65-F5344CB8AC3E}">
-        <p14:creationId xmlns:p14="http://schemas.microsoft.com/office/powerpoint/2010/main" val="420400100"/>
+        <p14:creationId xmlns:p14="http://schemas.microsoft.com/office/powerpoint/2010/main" val="302855767"/>
       </p:ext>
     </p:extLst>
   </p:cSld>
@@ -4973,7 +4998,7 @@
           <p:nvPr/>
         </p:nvPicPr>
         <p:blipFill>
-          <a:blip xmlns:r="http://schemas.openxmlformats.org/officeDocument/2006/relationships" xmlns:a="http://schemas.openxmlformats.org/drawingml/2006/main" r:embed="R68150cb812664b03"/>
+          <a:blip xmlns:r="http://schemas.openxmlformats.org/officeDocument/2006/relationships" xmlns:a="http://schemas.openxmlformats.org/drawingml/2006/main" r:embed="R6d73d3c2c667458d"/>
           <a:stretch xmlns:a="http://schemas.openxmlformats.org/drawingml/2006/main"/>
         </p:blipFill>
         <p:spPr>
@@ -4989,7 +5014,7 @@
     </p:spTree>
     <p:extLst>
       <p:ext uri="{BB962C8B-B14F-4D97-AF65-F5344CB8AC3E}">
-        <p14:creationId xmlns:p14="http://schemas.microsoft.com/office/powerpoint/2010/main" val="1632220364"/>
+        <p14:creationId xmlns:p14="http://schemas.microsoft.com/office/powerpoint/2010/main" val="1282404642"/>
       </p:ext>
     </p:extLst>
   </p:cSld>
@@ -5017,7 +5042,7 @@
           <p:nvPr/>
         </p:nvPicPr>
         <p:blipFill>
-          <a:blip xmlns:r="http://schemas.openxmlformats.org/officeDocument/2006/relationships" xmlns:a="http://schemas.openxmlformats.org/drawingml/2006/main" r:embed="Ra61f13210d0842e0"/>
+          <a:blip xmlns:r="http://schemas.openxmlformats.org/officeDocument/2006/relationships" xmlns:a="http://schemas.openxmlformats.org/drawingml/2006/main" r:embed="R4b0b92f54490432d"/>
           <a:stretch xmlns:a="http://schemas.openxmlformats.org/drawingml/2006/main"/>
         </p:blipFill>
         <p:spPr>
@@ -5033,7 +5058,7 @@
     </p:spTree>
     <p:extLst>
       <p:ext uri="{BB962C8B-B14F-4D97-AF65-F5344CB8AC3E}">
-        <p14:creationId xmlns:p14="http://schemas.microsoft.com/office/powerpoint/2010/main" val="1938612159"/>
+        <p14:creationId xmlns:p14="http://schemas.microsoft.com/office/powerpoint/2010/main" val="1654969929"/>
       </p:ext>
     </p:extLst>
   </p:cSld>
@@ -5061,7 +5086,7 @@
           <p:nvPr/>
         </p:nvPicPr>
         <p:blipFill>
-          <a:blip xmlns:r="http://schemas.openxmlformats.org/officeDocument/2006/relationships" xmlns:a="http://schemas.openxmlformats.org/drawingml/2006/main" r:embed="R960c12e980ea42aa"/>
+          <a:blip xmlns:r="http://schemas.openxmlformats.org/officeDocument/2006/relationships" xmlns:a="http://schemas.openxmlformats.org/drawingml/2006/main" r:embed="R22da7c1411e342b1"/>
           <a:stretch xmlns:a="http://schemas.openxmlformats.org/drawingml/2006/main"/>
         </p:blipFill>
         <p:spPr>
@@ -5077,7 +5102,7 @@
     </p:spTree>
     <p:extLst>
       <p:ext uri="{BB962C8B-B14F-4D97-AF65-F5344CB8AC3E}">
-        <p14:creationId xmlns:p14="http://schemas.microsoft.com/office/powerpoint/2010/main" val="826649630"/>
+        <p14:creationId xmlns:p14="http://schemas.microsoft.com/office/powerpoint/2010/main" val="1927447949"/>
       </p:ext>
     </p:extLst>
   </p:cSld>
@@ -5105,7 +5130,7 @@
           <p:nvPr/>
         </p:nvPicPr>
         <p:blipFill>
-          <a:blip xmlns:r="http://schemas.openxmlformats.org/officeDocument/2006/relationships" xmlns:a="http://schemas.openxmlformats.org/drawingml/2006/main" r:embed="Rdcc8953ae31246a1"/>
+          <a:blip xmlns:r="http://schemas.openxmlformats.org/officeDocument/2006/relationships" xmlns:a="http://schemas.openxmlformats.org/drawingml/2006/main" r:embed="Rda364b6158504ed8"/>
           <a:stretch xmlns:a="http://schemas.openxmlformats.org/drawingml/2006/main"/>
         </p:blipFill>
         <p:spPr>
@@ -5121,7 +5146,7 @@
     </p:spTree>
     <p:extLst>
       <p:ext uri="{BB962C8B-B14F-4D97-AF65-F5344CB8AC3E}">
-        <p14:creationId xmlns:p14="http://schemas.microsoft.com/office/powerpoint/2010/main" val="947485940"/>
+        <p14:creationId xmlns:p14="http://schemas.microsoft.com/office/powerpoint/2010/main" val="1781509107"/>
       </p:ext>
     </p:extLst>
   </p:cSld>
@@ -5149,7 +5174,7 @@
           <p:nvPr/>
         </p:nvPicPr>
         <p:blipFill>
-          <a:blip xmlns:r="http://schemas.openxmlformats.org/officeDocument/2006/relationships" xmlns:a="http://schemas.openxmlformats.org/drawingml/2006/main" r:embed="R4eedd3f65e194f79"/>
+          <a:blip xmlns:r="http://schemas.openxmlformats.org/officeDocument/2006/relationships" xmlns:a="http://schemas.openxmlformats.org/drawingml/2006/main" r:embed="R1f890bc9fac542cf"/>
           <a:stretch xmlns:a="http://schemas.openxmlformats.org/drawingml/2006/main"/>
         </p:blipFill>
         <p:spPr>
@@ -5165,7 +5190,7 @@
     </p:spTree>
     <p:extLst>
       <p:ext uri="{BB962C8B-B14F-4D97-AF65-F5344CB8AC3E}">
-        <p14:creationId xmlns:p14="http://schemas.microsoft.com/office/powerpoint/2010/main" val="1523561383"/>
+        <p14:creationId xmlns:p14="http://schemas.microsoft.com/office/powerpoint/2010/main" val="1010592073"/>
       </p:ext>
     </p:extLst>
   </p:cSld>
@@ -5193,7 +5218,7 @@
           <p:nvPr/>
         </p:nvPicPr>
         <p:blipFill>
-          <a:blip xmlns:r="http://schemas.openxmlformats.org/officeDocument/2006/relationships" xmlns:a="http://schemas.openxmlformats.org/drawingml/2006/main" r:embed="Rd87bd0f72ddf4e98"/>
+          <a:blip xmlns:r="http://schemas.openxmlformats.org/officeDocument/2006/relationships" xmlns:a="http://schemas.openxmlformats.org/drawingml/2006/main" r:embed="R18329973a9fe4992"/>
           <a:stretch xmlns:a="http://schemas.openxmlformats.org/drawingml/2006/main"/>
         </p:blipFill>
         <p:spPr>
@@ -5209,7 +5234,7 @@
     </p:spTree>
     <p:extLst>
       <p:ext uri="{BB962C8B-B14F-4D97-AF65-F5344CB8AC3E}">
-        <p14:creationId xmlns:p14="http://schemas.microsoft.com/office/powerpoint/2010/main" val="2006974241"/>
+        <p14:creationId xmlns:p14="http://schemas.microsoft.com/office/powerpoint/2010/main" val="2064668600"/>
       </p:ext>
     </p:extLst>
   </p:cSld>
@@ -5237,7 +5262,7 @@
           <p:nvPr/>
         </p:nvPicPr>
         <p:blipFill>
-          <a:blip xmlns:r="http://schemas.openxmlformats.org/officeDocument/2006/relationships" xmlns:a="http://schemas.openxmlformats.org/drawingml/2006/main" r:embed="R445961468fbd4ab4"/>
+          <a:blip xmlns:r="http://schemas.openxmlformats.org/officeDocument/2006/relationships" xmlns:a="http://schemas.openxmlformats.org/drawingml/2006/main" r:embed="Rd3d1d60080864b69"/>
           <a:stretch xmlns:a="http://schemas.openxmlformats.org/drawingml/2006/main"/>
         </p:blipFill>
         <p:spPr>
@@ -5253,7 +5278,7 @@
     </p:spTree>
     <p:extLst>
       <p:ext uri="{BB962C8B-B14F-4D97-AF65-F5344CB8AC3E}">
-        <p14:creationId xmlns:p14="http://schemas.microsoft.com/office/powerpoint/2010/main" val="1907312165"/>
+        <p14:creationId xmlns:p14="http://schemas.microsoft.com/office/powerpoint/2010/main" val="1178915104"/>
       </p:ext>
     </p:extLst>
   </p:cSld>
@@ -5281,7 +5306,7 @@
           <p:nvPr/>
         </p:nvPicPr>
         <p:blipFill>
-          <a:blip xmlns:r="http://schemas.openxmlformats.org/officeDocument/2006/relationships" xmlns:a="http://schemas.openxmlformats.org/drawingml/2006/main" r:embed="Rd84b5c0907f4414a"/>
+          <a:blip xmlns:r="http://schemas.openxmlformats.org/officeDocument/2006/relationships" xmlns:a="http://schemas.openxmlformats.org/drawingml/2006/main" r:embed="R8db40050c1044647"/>
           <a:stretch xmlns:a="http://schemas.openxmlformats.org/drawingml/2006/main"/>
         </p:blipFill>
         <p:spPr>
@@ -5297,7 +5322,7 @@
     </p:spTree>
     <p:extLst>
       <p:ext uri="{BB962C8B-B14F-4D97-AF65-F5344CB8AC3E}">
-        <p14:creationId xmlns:p14="http://schemas.microsoft.com/office/powerpoint/2010/main" val="345234559"/>
+        <p14:creationId xmlns:p14="http://schemas.microsoft.com/office/powerpoint/2010/main" val="866147731"/>
       </p:ext>
     </p:extLst>
   </p:cSld>
@@ -5325,7 +5350,7 @@
           <p:nvPr/>
         </p:nvPicPr>
         <p:blipFill>
-          <a:blip xmlns:r="http://schemas.openxmlformats.org/officeDocument/2006/relationships" xmlns:a="http://schemas.openxmlformats.org/drawingml/2006/main" r:embed="R6b045f6bb41d4c6a"/>
+          <a:blip xmlns:r="http://schemas.openxmlformats.org/officeDocument/2006/relationships" xmlns:a="http://schemas.openxmlformats.org/drawingml/2006/main" r:embed="Rdae1a52933ad4ef6"/>
           <a:stretch xmlns:a="http://schemas.openxmlformats.org/drawingml/2006/main"/>
         </p:blipFill>
         <p:spPr>
@@ -5341,7 +5366,7 @@
     </p:spTree>
     <p:extLst>
       <p:ext uri="{BB962C8B-B14F-4D97-AF65-F5344CB8AC3E}">
-        <p14:creationId xmlns:p14="http://schemas.microsoft.com/office/powerpoint/2010/main" val="579553167"/>
+        <p14:creationId xmlns:p14="http://schemas.microsoft.com/office/powerpoint/2010/main" val="431156952"/>
       </p:ext>
     </p:extLst>
   </p:cSld>
@@ -5369,7 +5394,7 @@
           <p:nvPr/>
         </p:nvPicPr>
         <p:blipFill>
-          <a:blip xmlns:r="http://schemas.openxmlformats.org/officeDocument/2006/relationships" xmlns:a="http://schemas.openxmlformats.org/drawingml/2006/main" r:embed="Rf3e07a7ed6d34bd5"/>
+          <a:blip xmlns:r="http://schemas.openxmlformats.org/officeDocument/2006/relationships" xmlns:a="http://schemas.openxmlformats.org/drawingml/2006/main" r:embed="R7852bd5cfe7748da"/>
           <a:stretch xmlns:a="http://schemas.openxmlformats.org/drawingml/2006/main"/>
         </p:blipFill>
         <p:spPr>
@@ -5385,7 +5410,7 @@
     </p:spTree>
     <p:extLst>
       <p:ext uri="{BB962C8B-B14F-4D97-AF65-F5344CB8AC3E}">
-        <p14:creationId xmlns:p14="http://schemas.microsoft.com/office/powerpoint/2010/main" val="910910976"/>
+        <p14:creationId xmlns:p14="http://schemas.microsoft.com/office/powerpoint/2010/main" val="1087195861"/>
       </p:ext>
     </p:extLst>
   </p:cSld>
@@ -5413,7 +5438,7 @@
           <p:nvPr/>
         </p:nvPicPr>
         <p:blipFill>
-          <a:blip xmlns:r="http://schemas.openxmlformats.org/officeDocument/2006/relationships" xmlns:a="http://schemas.openxmlformats.org/drawingml/2006/main" r:embed="Reac819dbd6cd4970"/>
+          <a:blip xmlns:r="http://schemas.openxmlformats.org/officeDocument/2006/relationships" xmlns:a="http://schemas.openxmlformats.org/drawingml/2006/main" r:embed="R0da995cde58e4384"/>
           <a:stretch xmlns:a="http://schemas.openxmlformats.org/drawingml/2006/main"/>
         </p:blipFill>
         <p:spPr>
@@ -5429,7 +5454,7 @@
     </p:spTree>
     <p:extLst>
       <p:ext uri="{BB962C8B-B14F-4D97-AF65-F5344CB8AC3E}">
-        <p14:creationId xmlns:p14="http://schemas.microsoft.com/office/powerpoint/2010/main" val="277476872"/>
+        <p14:creationId xmlns:p14="http://schemas.microsoft.com/office/powerpoint/2010/main" val="2073410884"/>
       </p:ext>
     </p:extLst>
   </p:cSld>
@@ -5457,7 +5482,7 @@
           <p:nvPr/>
         </p:nvPicPr>
         <p:blipFill>
-          <a:blip xmlns:r="http://schemas.openxmlformats.org/officeDocument/2006/relationships" xmlns:a="http://schemas.openxmlformats.org/drawingml/2006/main" r:embed="Ra9ba233b53fb4a05"/>
+          <a:blip xmlns:r="http://schemas.openxmlformats.org/officeDocument/2006/relationships" xmlns:a="http://schemas.openxmlformats.org/drawingml/2006/main" r:embed="R1e7128bc02734750"/>
           <a:stretch xmlns:a="http://schemas.openxmlformats.org/drawingml/2006/main"/>
         </p:blipFill>
         <p:spPr>
@@ -5473,7 +5498,7 @@
     </p:spTree>
     <p:extLst>
       <p:ext uri="{BB962C8B-B14F-4D97-AF65-F5344CB8AC3E}">
-        <p14:creationId xmlns:p14="http://schemas.microsoft.com/office/powerpoint/2010/main" val="1428159975"/>
+        <p14:creationId xmlns:p14="http://schemas.microsoft.com/office/powerpoint/2010/main" val="441936961"/>
       </p:ext>
     </p:extLst>
   </p:cSld>
@@ -5501,7 +5526,7 @@
           <p:nvPr/>
         </p:nvPicPr>
         <p:blipFill>
-          <a:blip xmlns:r="http://schemas.openxmlformats.org/officeDocument/2006/relationships" xmlns:a="http://schemas.openxmlformats.org/drawingml/2006/main" r:embed="R669469c0d7994677"/>
+          <a:blip xmlns:r="http://schemas.openxmlformats.org/officeDocument/2006/relationships" xmlns:a="http://schemas.openxmlformats.org/drawingml/2006/main" r:embed="R24594a3221a34e97"/>
           <a:stretch xmlns:a="http://schemas.openxmlformats.org/drawingml/2006/main"/>
         </p:blipFill>
         <p:spPr>
@@ -5517,7 +5542,7 @@
     </p:spTree>
     <p:extLst>
       <p:ext uri="{BB962C8B-B14F-4D97-AF65-F5344CB8AC3E}">
-        <p14:creationId xmlns:p14="http://schemas.microsoft.com/office/powerpoint/2010/main" val="470571442"/>
+        <p14:creationId xmlns:p14="http://schemas.microsoft.com/office/powerpoint/2010/main" val="332908516"/>
       </p:ext>
     </p:extLst>
   </p:cSld>
@@ -5545,7 +5570,7 @@
           <p:nvPr/>
         </p:nvPicPr>
         <p:blipFill>
-          <a:blip xmlns:r="http://schemas.openxmlformats.org/officeDocument/2006/relationships" xmlns:a="http://schemas.openxmlformats.org/drawingml/2006/main" r:embed="R752fdba9d53a4e17"/>
+          <a:blip xmlns:r="http://schemas.openxmlformats.org/officeDocument/2006/relationships" xmlns:a="http://schemas.openxmlformats.org/drawingml/2006/main" r:embed="R85c7c6a6a27542fd"/>
           <a:stretch xmlns:a="http://schemas.openxmlformats.org/drawingml/2006/main"/>
         </p:blipFill>
         <p:spPr>
@@ -5561,7 +5586,7 @@
     </p:spTree>
     <p:extLst>
       <p:ext uri="{BB962C8B-B14F-4D97-AF65-F5344CB8AC3E}">
-        <p14:creationId xmlns:p14="http://schemas.microsoft.com/office/powerpoint/2010/main" val="1929073526"/>
+        <p14:creationId xmlns:p14="http://schemas.microsoft.com/office/powerpoint/2010/main" val="639233886"/>
       </p:ext>
     </p:extLst>
   </p:cSld>
@@ -5589,7 +5614,7 @@
           <p:nvPr/>
         </p:nvPicPr>
         <p:blipFill>
-          <a:blip xmlns:r="http://schemas.openxmlformats.org/officeDocument/2006/relationships" xmlns:a="http://schemas.openxmlformats.org/drawingml/2006/main" r:embed="Rceb24fb162144c3a"/>
+          <a:blip xmlns:r="http://schemas.openxmlformats.org/officeDocument/2006/relationships" xmlns:a="http://schemas.openxmlformats.org/drawingml/2006/main" r:embed="Re72a0fc16b494b99"/>
           <a:stretch xmlns:a="http://schemas.openxmlformats.org/drawingml/2006/main"/>
         </p:blipFill>
         <p:spPr>
@@ -5605,7 +5630,7 @@
     </p:spTree>
     <p:extLst>
       <p:ext uri="{BB962C8B-B14F-4D97-AF65-F5344CB8AC3E}">
-        <p14:creationId xmlns:p14="http://schemas.microsoft.com/office/powerpoint/2010/main" val="1253569383"/>
+        <p14:creationId xmlns:p14="http://schemas.microsoft.com/office/powerpoint/2010/main" val="87797307"/>
       </p:ext>
     </p:extLst>
   </p:cSld>
@@ -5633,7 +5658,7 @@
           <p:nvPr/>
         </p:nvPicPr>
         <p:blipFill>
-          <a:blip xmlns:r="http://schemas.openxmlformats.org/officeDocument/2006/relationships" xmlns:a="http://schemas.openxmlformats.org/drawingml/2006/main" r:embed="R82c27776d63346d0"/>
+          <a:blip xmlns:r="http://schemas.openxmlformats.org/officeDocument/2006/relationships" xmlns:a="http://schemas.openxmlformats.org/drawingml/2006/main" r:embed="Rc8fa8012e9394971"/>
           <a:stretch xmlns:a="http://schemas.openxmlformats.org/drawingml/2006/main"/>
         </p:blipFill>
         <p:spPr>
@@ -5649,7 +5674,7 @@
     </p:spTree>
     <p:extLst>
       <p:ext uri="{BB962C8B-B14F-4D97-AF65-F5344CB8AC3E}">
-        <p14:creationId xmlns:p14="http://schemas.microsoft.com/office/powerpoint/2010/main" val="1858874278"/>
+        <p14:creationId xmlns:p14="http://schemas.microsoft.com/office/powerpoint/2010/main" val="612923828"/>
       </p:ext>
     </p:extLst>
   </p:cSld>
@@ -5677,7 +5702,7 @@
           <p:nvPr/>
         </p:nvPicPr>
         <p:blipFill>
-          <a:blip xmlns:r="http://schemas.openxmlformats.org/officeDocument/2006/relationships" xmlns:a="http://schemas.openxmlformats.org/drawingml/2006/main" r:embed="R0a4a65039ed04918"/>
+          <a:blip xmlns:r="http://schemas.openxmlformats.org/officeDocument/2006/relationships" xmlns:a="http://schemas.openxmlformats.org/drawingml/2006/main" r:embed="Re25b84ad3cd84feb"/>
           <a:stretch xmlns:a="http://schemas.openxmlformats.org/drawingml/2006/main"/>
         </p:blipFill>
         <p:spPr>
@@ -5693,7 +5718,7 @@
     </p:spTree>
     <p:extLst>
       <p:ext uri="{BB962C8B-B14F-4D97-AF65-F5344CB8AC3E}">
-        <p14:creationId xmlns:p14="http://schemas.microsoft.com/office/powerpoint/2010/main" val="1167067331"/>
+        <p14:creationId xmlns:p14="http://schemas.microsoft.com/office/powerpoint/2010/main" val="879226667"/>
       </p:ext>
     </p:extLst>
   </p:cSld>
@@ -5721,7 +5746,7 @@
           <p:nvPr/>
         </p:nvPicPr>
         <p:blipFill>
-          <a:blip xmlns:r="http://schemas.openxmlformats.org/officeDocument/2006/relationships" xmlns:a="http://schemas.openxmlformats.org/drawingml/2006/main" r:embed="Rf50806962adf47c7"/>
+          <a:blip xmlns:r="http://schemas.openxmlformats.org/officeDocument/2006/relationships" xmlns:a="http://schemas.openxmlformats.org/drawingml/2006/main" r:embed="Ra4543561e2104719"/>
           <a:stretch xmlns:a="http://schemas.openxmlformats.org/drawingml/2006/main"/>
         </p:blipFill>
         <p:spPr>
@@ -5737,7 +5762,7 @@
     </p:spTree>
     <p:extLst>
       <p:ext uri="{BB962C8B-B14F-4D97-AF65-F5344CB8AC3E}">
-        <p14:creationId xmlns:p14="http://schemas.microsoft.com/office/powerpoint/2010/main" val="107493978"/>
+        <p14:creationId xmlns:p14="http://schemas.microsoft.com/office/powerpoint/2010/main" val="1010986328"/>
       </p:ext>
     </p:extLst>
   </p:cSld>
@@ -5765,7 +5790,7 @@
           <p:nvPr/>
         </p:nvPicPr>
         <p:blipFill>
-          <a:blip xmlns:r="http://schemas.openxmlformats.org/officeDocument/2006/relationships" xmlns:a="http://schemas.openxmlformats.org/drawingml/2006/main" r:embed="R3d11c6a1f4e54c80"/>
+          <a:blip xmlns:r="http://schemas.openxmlformats.org/officeDocument/2006/relationships" xmlns:a="http://schemas.openxmlformats.org/drawingml/2006/main" r:embed="R9244b0e2ac26418a"/>
           <a:stretch xmlns:a="http://schemas.openxmlformats.org/drawingml/2006/main"/>
         </p:blipFill>
         <p:spPr>
@@ -5781,7 +5806,7 @@
     </p:spTree>
     <p:extLst>
       <p:ext uri="{BB962C8B-B14F-4D97-AF65-F5344CB8AC3E}">
-        <p14:creationId xmlns:p14="http://schemas.microsoft.com/office/powerpoint/2010/main" val="72795023"/>
+        <p14:creationId xmlns:p14="http://schemas.microsoft.com/office/powerpoint/2010/main" val="1784867779"/>
       </p:ext>
     </p:extLst>
   </p:cSld>
@@ -5809,7 +5834,7 @@
           <p:nvPr/>
         </p:nvPicPr>
         <p:blipFill>
-          <a:blip xmlns:r="http://schemas.openxmlformats.org/officeDocument/2006/relationships" xmlns:a="http://schemas.openxmlformats.org/drawingml/2006/main" r:embed="Rbede1b531dcc42d9"/>
+          <a:blip xmlns:r="http://schemas.openxmlformats.org/officeDocument/2006/relationships" xmlns:a="http://schemas.openxmlformats.org/drawingml/2006/main" r:embed="Rba02edaf43b8449b"/>
           <a:stretch xmlns:a="http://schemas.openxmlformats.org/drawingml/2006/main"/>
         </p:blipFill>
         <p:spPr>
@@ -5825,7 +5850,7 @@
     </p:spTree>
     <p:extLst>
       <p:ext uri="{BB962C8B-B14F-4D97-AF65-F5344CB8AC3E}">
-        <p14:creationId xmlns:p14="http://schemas.microsoft.com/office/powerpoint/2010/main" val="30682631"/>
+        <p14:creationId xmlns:p14="http://schemas.microsoft.com/office/powerpoint/2010/main" val="1240075071"/>
       </p:ext>
     </p:extLst>
   </p:cSld>
@@ -5853,7 +5878,7 @@
           <p:nvPr/>
         </p:nvPicPr>
         <p:blipFill>
-          <a:blip xmlns:r="http://schemas.openxmlformats.org/officeDocument/2006/relationships" xmlns:a="http://schemas.openxmlformats.org/drawingml/2006/main" r:embed="R3ca8ef810b904b21"/>
+          <a:blip xmlns:r="http://schemas.openxmlformats.org/officeDocument/2006/relationships" xmlns:a="http://schemas.openxmlformats.org/drawingml/2006/main" r:embed="Rafb3c4cccabf4ef4"/>
           <a:stretch xmlns:a="http://schemas.openxmlformats.org/drawingml/2006/main"/>
         </p:blipFill>
         <p:spPr>
@@ -5869,7 +5894,7 @@
     </p:spTree>
     <p:extLst>
       <p:ext uri="{BB962C8B-B14F-4D97-AF65-F5344CB8AC3E}">
-        <p14:creationId xmlns:p14="http://schemas.microsoft.com/office/powerpoint/2010/main" val="1670561483"/>
+        <p14:creationId xmlns:p14="http://schemas.microsoft.com/office/powerpoint/2010/main" val="610095119"/>
       </p:ext>
     </p:extLst>
   </p:cSld>

</xml_diff>

<commit_message>
Use geographical trade maps and keep hover text sharp and stationary
</commit_message>
<xml_diff>
--- a/teaching/macro-applications/downloads/lecture_1.pptx
+++ b/teaching/macro-applications/downloads/lecture_1.pptx
@@ -2,39 +2,39 @@
 <file path=ppt/presentation.xml><?xml version="1.0" encoding="utf-8"?>
 <p:presentation xmlns:p="http://schemas.openxmlformats.org/presentationml/2006/main">
   <p:sldMasterIdLst>
-    <p:sldMasterId xmlns:r="http://schemas.openxmlformats.org/officeDocument/2006/relationships" id="2147483648" r:id="R027a5d4d101146f3"/>
+    <p:sldMasterId xmlns:r="http://schemas.openxmlformats.org/officeDocument/2006/relationships" id="2147483648" r:id="Rfcc3c60dd05f4b01"/>
   </p:sldMasterIdLst>
   <p:notesMasterIdLst>
-    <p:notesMasterId xmlns:r="http://schemas.openxmlformats.org/officeDocument/2006/relationships" r:id="R159b2fdf43ca4590"/>
+    <p:notesMasterId xmlns:r="http://schemas.openxmlformats.org/officeDocument/2006/relationships" r:id="Re5ecb6f0821e4bd7"/>
   </p:notesMasterIdLst>
   <p:sldIdLst>
-    <p:sldId xmlns:r="http://schemas.openxmlformats.org/officeDocument/2006/relationships" id="256" r:id="R3ae3132588854dd3"/>
-    <p:sldId xmlns:r="http://schemas.openxmlformats.org/officeDocument/2006/relationships" id="257" r:id="R68d918a7efdf497b"/>
-    <p:sldId xmlns:r="http://schemas.openxmlformats.org/officeDocument/2006/relationships" id="258" r:id="R18e3dfb23b4a4020"/>
-    <p:sldId xmlns:r="http://schemas.openxmlformats.org/officeDocument/2006/relationships" id="259" r:id="R46d0302ac4c74d74"/>
-    <p:sldId xmlns:r="http://schemas.openxmlformats.org/officeDocument/2006/relationships" id="260" r:id="R0cdb06cab70d41b3"/>
-    <p:sldId xmlns:r="http://schemas.openxmlformats.org/officeDocument/2006/relationships" id="261" r:id="R0fce414b0ced4d09"/>
-    <p:sldId xmlns:r="http://schemas.openxmlformats.org/officeDocument/2006/relationships" id="262" r:id="R6186544d3d0d4eb0"/>
-    <p:sldId xmlns:r="http://schemas.openxmlformats.org/officeDocument/2006/relationships" id="263" r:id="R3fde24aa74bd47b3"/>
-    <p:sldId xmlns:r="http://schemas.openxmlformats.org/officeDocument/2006/relationships" id="264" r:id="R8168fc6a9fff4673"/>
-    <p:sldId xmlns:r="http://schemas.openxmlformats.org/officeDocument/2006/relationships" id="265" r:id="R5ddf33d861e54238"/>
-    <p:sldId xmlns:r="http://schemas.openxmlformats.org/officeDocument/2006/relationships" id="266" r:id="Rea98f945809a43ee"/>
-    <p:sldId xmlns:r="http://schemas.openxmlformats.org/officeDocument/2006/relationships" id="267" r:id="R970bfffcdcc5447d"/>
-    <p:sldId xmlns:r="http://schemas.openxmlformats.org/officeDocument/2006/relationships" id="268" r:id="R6f8d65e0105c4163"/>
-    <p:sldId xmlns:r="http://schemas.openxmlformats.org/officeDocument/2006/relationships" id="269" r:id="R771b510362704cd1"/>
-    <p:sldId xmlns:r="http://schemas.openxmlformats.org/officeDocument/2006/relationships" id="270" r:id="Ra7a596f3c81e46eb"/>
-    <p:sldId xmlns:r="http://schemas.openxmlformats.org/officeDocument/2006/relationships" id="271" r:id="Rc4c4bc88c06544c1"/>
-    <p:sldId xmlns:r="http://schemas.openxmlformats.org/officeDocument/2006/relationships" id="272" r:id="R8f661338f39f4125"/>
-    <p:sldId xmlns:r="http://schemas.openxmlformats.org/officeDocument/2006/relationships" id="273" r:id="Rfaa0a138199f416d"/>
-    <p:sldId xmlns:r="http://schemas.openxmlformats.org/officeDocument/2006/relationships" id="274" r:id="Rcd8a9038e77a413f"/>
-    <p:sldId xmlns:r="http://schemas.openxmlformats.org/officeDocument/2006/relationships" id="275" r:id="Rb51bf09998d245f8"/>
-    <p:sldId xmlns:r="http://schemas.openxmlformats.org/officeDocument/2006/relationships" id="276" r:id="R3072630270fe4a37"/>
-    <p:sldId xmlns:r="http://schemas.openxmlformats.org/officeDocument/2006/relationships" id="277" r:id="Rffc1d8460f4e49f4"/>
-    <p:sldId xmlns:r="http://schemas.openxmlformats.org/officeDocument/2006/relationships" id="278" r:id="R80dfa77c01b449d5"/>
-    <p:sldId xmlns:r="http://schemas.openxmlformats.org/officeDocument/2006/relationships" id="279" r:id="R0b7c378455df4877"/>
-    <p:sldId xmlns:r="http://schemas.openxmlformats.org/officeDocument/2006/relationships" id="280" r:id="R8ef78258ff7b4e05"/>
-    <p:sldId xmlns:r="http://schemas.openxmlformats.org/officeDocument/2006/relationships" id="281" r:id="R1449b03fdb9446de"/>
-    <p:sldId xmlns:r="http://schemas.openxmlformats.org/officeDocument/2006/relationships" id="282" r:id="R5a50d1ad94704c83"/>
+    <p:sldId xmlns:r="http://schemas.openxmlformats.org/officeDocument/2006/relationships" id="256" r:id="R5f03ccecba284949"/>
+    <p:sldId xmlns:r="http://schemas.openxmlformats.org/officeDocument/2006/relationships" id="257" r:id="R4af68580bfb34011"/>
+    <p:sldId xmlns:r="http://schemas.openxmlformats.org/officeDocument/2006/relationships" id="258" r:id="Rcc328ac5ea5a48ef"/>
+    <p:sldId xmlns:r="http://schemas.openxmlformats.org/officeDocument/2006/relationships" id="259" r:id="Rbed9c841fd514c6f"/>
+    <p:sldId xmlns:r="http://schemas.openxmlformats.org/officeDocument/2006/relationships" id="260" r:id="Ree9a5575990647b9"/>
+    <p:sldId xmlns:r="http://schemas.openxmlformats.org/officeDocument/2006/relationships" id="261" r:id="Rd8b1b70498cc4943"/>
+    <p:sldId xmlns:r="http://schemas.openxmlformats.org/officeDocument/2006/relationships" id="262" r:id="R6d29d8e5c926448d"/>
+    <p:sldId xmlns:r="http://schemas.openxmlformats.org/officeDocument/2006/relationships" id="263" r:id="R062c918bc8cf4d5b"/>
+    <p:sldId xmlns:r="http://schemas.openxmlformats.org/officeDocument/2006/relationships" id="264" r:id="Rbf714044aa8044e7"/>
+    <p:sldId xmlns:r="http://schemas.openxmlformats.org/officeDocument/2006/relationships" id="265" r:id="Rb638d72f46eb41e2"/>
+    <p:sldId xmlns:r="http://schemas.openxmlformats.org/officeDocument/2006/relationships" id="266" r:id="R5380fb41bb1b4bed"/>
+    <p:sldId xmlns:r="http://schemas.openxmlformats.org/officeDocument/2006/relationships" id="267" r:id="R5fc4d228475c444f"/>
+    <p:sldId xmlns:r="http://schemas.openxmlformats.org/officeDocument/2006/relationships" id="268" r:id="R66efae53160d4840"/>
+    <p:sldId xmlns:r="http://schemas.openxmlformats.org/officeDocument/2006/relationships" id="269" r:id="R631fc3fff795449e"/>
+    <p:sldId xmlns:r="http://schemas.openxmlformats.org/officeDocument/2006/relationships" id="270" r:id="Rffa582fc2f6d4134"/>
+    <p:sldId xmlns:r="http://schemas.openxmlformats.org/officeDocument/2006/relationships" id="271" r:id="Reaf3448d1c374d54"/>
+    <p:sldId xmlns:r="http://schemas.openxmlformats.org/officeDocument/2006/relationships" id="272" r:id="Rd003d1b38fd149bf"/>
+    <p:sldId xmlns:r="http://schemas.openxmlformats.org/officeDocument/2006/relationships" id="273" r:id="R891e62855c634fa9"/>
+    <p:sldId xmlns:r="http://schemas.openxmlformats.org/officeDocument/2006/relationships" id="274" r:id="Rdff7aa665388431b"/>
+    <p:sldId xmlns:r="http://schemas.openxmlformats.org/officeDocument/2006/relationships" id="275" r:id="R2fdcb08e3edf44e9"/>
+    <p:sldId xmlns:r="http://schemas.openxmlformats.org/officeDocument/2006/relationships" id="276" r:id="R15d90f79400f4a55"/>
+    <p:sldId xmlns:r="http://schemas.openxmlformats.org/officeDocument/2006/relationships" id="277" r:id="Ra2dc9739e2924e9a"/>
+    <p:sldId xmlns:r="http://schemas.openxmlformats.org/officeDocument/2006/relationships" id="278" r:id="R148504be3eaf496c"/>
+    <p:sldId xmlns:r="http://schemas.openxmlformats.org/officeDocument/2006/relationships" id="279" r:id="Rd91579d1a49047f9"/>
+    <p:sldId xmlns:r="http://schemas.openxmlformats.org/officeDocument/2006/relationships" id="280" r:id="Rb766574569474feb"/>
+    <p:sldId xmlns:r="http://schemas.openxmlformats.org/officeDocument/2006/relationships" id="281" r:id="R57ab791190094ebe"/>
+    <p:sldId xmlns:r="http://schemas.openxmlformats.org/officeDocument/2006/relationships" id="282" r:id="R75efbe1f55574a2a"/>
   </p:sldIdLst>
   <p:sldSz cx="12192000" cy="6858000"/>
   <p:notesSz cx="6858000" cy="9144000"/>
@@ -1573,22 +1573,87 @@
           </a:p>
           <a:p xmlns:a="http://schemas.openxmlformats.org/drawingml/2006/main">
             <a:r>
-              <a:t/>
-            </a:r>
-          </a:p>
-          <a:p xmlns:a="http://schemas.openxmlformats.org/drawingml/2006/main">
-            <a:r>
-              <a:t>Schematic after Baldwin and Wyplosz. EFTA history.</a:t>
-            </a:r>
-          </a:p>
-          <a:p xmlns:a="http://schemas.openxmlformats.org/drawingml/2006/main">
-            <a:r>
-              <a:t/>
-            </a:r>
-          </a:p>
-          <a:p xmlns:a="http://schemas.openxmlformats.org/drawingml/2006/main">
-            <a:r>
-              <a:t>Two separate groups: the EEC Six are Belgium, France, West Germany, Italy, Luxembourg and the Netherlands. The EFTA Seven are Austria, Denmark, Norway, Portugal, Sweden, Switzerland and the United Kingdom. Finland is an EFTA associate. Ireland, Iceland, Spain and Greece are outside both groups.</a:t>
+              <a:t>Two separate trade blocs</a:t>
+            </a:r>
+          </a:p>
+          <a:p xmlns:a="http://schemas.openxmlformats.org/drawingml/2006/main">
+            <a:r>
+              <a:t/>
+            </a:r>
+          </a:p>
+          <a:p xmlns:a="http://schemas.openxmlformats.org/drawingml/2006/main">
+            <a:r>
+              <a:t>EEC: six members</a:t>
+            </a:r>
+          </a:p>
+          <a:p xmlns:a="http://schemas.openxmlformats.org/drawingml/2006/main">
+            <a:r>
+              <a:t>A customs union</a:t>
+            </a:r>
+          </a:p>
+          <a:p xmlns:a="http://schemas.openxmlformats.org/drawingml/2006/main">
+            <a:r>
+              <a:t/>
+            </a:r>
+          </a:p>
+          <a:p xmlns:a="http://schemas.openxmlformats.org/drawingml/2006/main">
+            <a:r>
+              <a:t>EFTA: seven members</a:t>
+            </a:r>
+          </a:p>
+          <a:p xmlns:a="http://schemas.openxmlformats.org/drawingml/2006/main">
+            <a:r>
+              <a:t>A free-trade area</a:t>
+            </a:r>
+          </a:p>
+          <a:p xmlns:a="http://schemas.openxmlformats.org/drawingml/2006/main">
+            <a:r>
+              <a:t/>
+            </a:r>
+          </a:p>
+          <a:p xmlns:a="http://schemas.openxmlformats.org/drawingml/2006/main">
+            <a:r>
+              <a:t>Finland: EFTA associate</a:t>
+            </a:r>
+          </a:p>
+          <a:p xmlns:a="http://schemas.openxmlformats.org/drawingml/2006/main">
+            <a:r>
+              <a:t/>
+            </a:r>
+          </a:p>
+          <a:p xmlns:a="http://schemas.openxmlformats.org/drawingml/2006/main">
+            <a:r>
+              <a:t>AT Austria · BE Belgium · CH Switzerland</a:t>
+            </a:r>
+          </a:p>
+          <a:p xmlns:a="http://schemas.openxmlformats.org/drawingml/2006/main">
+            <a:r>
+              <a:t>DK Denmark · LU Luxembourg</a:t>
+            </a:r>
+          </a:p>
+          <a:p xmlns:a="http://schemas.openxmlformats.org/drawingml/2006/main">
+            <a:r>
+              <a:t>NL Netherlands · PT Portugal</a:t>
+            </a:r>
+          </a:p>
+          <a:p xmlns:a="http://schemas.openxmlformats.org/drawingml/2006/main">
+            <a:r>
+              <a:t/>
+            </a:r>
+          </a:p>
+          <a:p xmlns:a="http://schemas.openxmlformats.org/drawingml/2006/main">
+            <a:r>
+              <a:t>Historical membership: Baldwin and Wyplosz; EFTA. Map adapted from Sémhur, CC BY-SA 4.0.</a:t>
+            </a:r>
+          </a:p>
+          <a:p xmlns:a="http://schemas.openxmlformats.org/drawingml/2006/main">
+            <a:r>
+              <a:t/>
+            </a:r>
+          </a:p>
+          <a:p xmlns:a="http://schemas.openxmlformats.org/drawingml/2006/main">
+            <a:r>
+              <a:t>Geographical map of Western Europe in the late 1960s. The EEC Six are blue: Belgium, France, West Germany, Italy, Luxembourg and the Netherlands. The EFTA Seven are purple: Austria, Denmark, Norway, Portugal, Sweden, Switzerland and the UK. Finland is hatched as an EFTA associate. The historical West/East German border is shown.</a:t>
             </a:r>
           </a:p>
           <a:p xmlns:a="http://schemas.openxmlformats.org/drawingml/2006/main">
@@ -1599,6 +1664,16 @@
           <a:p xmlns:a="http://schemas.openxmlformats.org/drawingml/2006/main">
             <a:r>
               <a:t>https://www.efta.int/about-efta/european-free-trade-association/history</a:t>
+            </a:r>
+          </a:p>
+          <a:p xmlns:a="http://schemas.openxmlformats.org/drawingml/2006/main">
+            <a:r>
+              <a:t>https://commons.wikimedia.org/wiki/File:Iron_Curtain_map.svg</a:t>
+            </a:r>
+          </a:p>
+          <a:p xmlns:a="http://schemas.openxmlformats.org/drawingml/2006/main">
+            <a:r>
+              <a:t>https://creativecommons.org/licenses/by-sa/4.0/</a:t>
             </a:r>
           </a:p>
         </p:txBody>
@@ -1713,17 +1788,47 @@
           </a:p>
           <a:p xmlns:a="http://schemas.openxmlformats.org/drawingml/2006/main">
             <a:r>
-              <a:t>Mid-1970s. Industrial tariffs phased out by 1977. EFTA history.</a:t>
-            </a:r>
-          </a:p>
-          <a:p xmlns:a="http://schemas.openxmlformats.org/drawingml/2006/main">
-            <a:r>
-              <a:t/>
-            </a:r>
-          </a:p>
-          <a:p xmlns:a="http://schemas.openxmlformats.org/drawingml/2006/main">
-            <a:r>
-              <a:t>Mid-1970s schematic: the EEC Nine now include the UK, Denmark and Ireland. A wider network of industrial free-trade agreements links the EEC to Austria, Iceland, Norway, Portugal, Sweden, Switzerland and associated Finland. The outer circle represents trade links, not EFTA membership of the EEC countries. Spain and Greece remain outside these groups.</a:t>
+              <a:t>EEC: nine members</a:t>
+            </a:r>
+          </a:p>
+          <a:p xmlns:a="http://schemas.openxmlformats.org/drawingml/2006/main">
+            <a:r>
+              <a:t>EFTA members</a:t>
+            </a:r>
+          </a:p>
+          <a:p xmlns:a="http://schemas.openxmlformats.org/drawingml/2006/main">
+            <a:r>
+              <a:t>Finland: associate</a:t>
+            </a:r>
+          </a:p>
+          <a:p xmlns:a="http://schemas.openxmlformats.org/drawingml/2006/main">
+            <a:r>
+              <a:t/>
+            </a:r>
+          </a:p>
+          <a:p xmlns:a="http://schemas.openxmlformats.org/drawingml/2006/main">
+            <a:r>
+              <a:t>Industrial free-trade agreements now link the two blocs.</a:t>
+            </a:r>
+          </a:p>
+          <a:p xmlns:a="http://schemas.openxmlformats.org/drawingml/2006/main">
+            <a:r>
+              <a:t/>
+            </a:r>
+          </a:p>
+          <a:p xmlns:a="http://schemas.openxmlformats.org/drawingml/2006/main">
+            <a:r>
+              <a:t>Mid-1970s; industrial tariffs phased out by 1977. EFTA history. Map adapted from Sémhur, CC BY-SA 4.0.</a:t>
+            </a:r>
+          </a:p>
+          <a:p xmlns:a="http://schemas.openxmlformats.org/drawingml/2006/main">
+            <a:r>
+              <a:t/>
+            </a:r>
+          </a:p>
+          <a:p xmlns:a="http://schemas.openxmlformats.org/drawingml/2006/main">
+            <a:r>
+              <a:t>The same geographical map in the mid-1970s. The UK, Denmark and Ireland are now blue as part of the EEC Nine. Iceland has joined EFTA, shown in purple with Austria, Norway, Portugal, Sweden and Switzerland. Finland remains an associate. Industrial free-trade agreements link EEC and EFTA countries.</a:t>
             </a:r>
           </a:p>
           <a:p xmlns:a="http://schemas.openxmlformats.org/drawingml/2006/main">
@@ -1734,6 +1839,16 @@
           <a:p xmlns:a="http://schemas.openxmlformats.org/drawingml/2006/main">
             <a:r>
               <a:t>https://www.efta.int/about-efta/european-free-trade-association/history</a:t>
+            </a:r>
+          </a:p>
+          <a:p xmlns:a="http://schemas.openxmlformats.org/drawingml/2006/main">
+            <a:r>
+              <a:t>https://commons.wikimedia.org/wiki/File:Iron_Curtain_map.svg</a:t>
+            </a:r>
+          </a:p>
+          <a:p xmlns:a="http://schemas.openxmlformats.org/drawingml/2006/main">
+            <a:r>
+              <a:t>https://creativecommons.org/licenses/by-sa/4.0/</a:t>
             </a:r>
           </a:p>
         </p:txBody>
@@ -4186,7 +4301,7 @@
   </p:cSld>
   <p:clrMap bg1="lt1" tx1="dk1" bg2="lt2" tx2="dk2" accent1="accent1" accent2="accent2" accent3="accent3" accent4="accent4" accent5="accent5" accent6="accent6" hlink="hlink" folHlink="folHlink"/>
   <p:sldLayoutIdLst>
-    <p:sldLayoutId xmlns:r="http://schemas.openxmlformats.org/officeDocument/2006/relationships" id="2147483649" r:id="Rfad7dc01a99147ca"/>
+    <p:sldLayoutId xmlns:r="http://schemas.openxmlformats.org/officeDocument/2006/relationships" id="2147483649" r:id="R3294e4dbf33a4a96"/>
   </p:sldLayoutIdLst>
   <p:txStyles>
     <p:titleStyle>
@@ -4734,7 +4849,7 @@
           <p:nvPr/>
         </p:nvPicPr>
         <p:blipFill>
-          <a:blip xmlns:r="http://schemas.openxmlformats.org/officeDocument/2006/relationships" xmlns:a="http://schemas.openxmlformats.org/drawingml/2006/main" r:embed="R81dd31a7f0664623"/>
+          <a:blip xmlns:r="http://schemas.openxmlformats.org/officeDocument/2006/relationships" xmlns:a="http://schemas.openxmlformats.org/drawingml/2006/main" r:embed="R1fadce5945a54c74"/>
           <a:stretch xmlns:a="http://schemas.openxmlformats.org/drawingml/2006/main"/>
         </p:blipFill>
         <p:spPr>
@@ -4750,7 +4865,7 @@
     </p:spTree>
     <p:extLst>
       <p:ext uri="{BB962C8B-B14F-4D97-AF65-F5344CB8AC3E}">
-        <p14:creationId xmlns:p14="http://schemas.microsoft.com/office/powerpoint/2010/main" val="1674328575"/>
+        <p14:creationId xmlns:p14="http://schemas.microsoft.com/office/powerpoint/2010/main" val="1239858466"/>
       </p:ext>
     </p:extLst>
   </p:cSld>
@@ -4778,7 +4893,7 @@
           <p:nvPr/>
         </p:nvPicPr>
         <p:blipFill>
-          <a:blip xmlns:r="http://schemas.openxmlformats.org/officeDocument/2006/relationships" xmlns:a="http://schemas.openxmlformats.org/drawingml/2006/main" r:embed="Rbeca3359880246cd"/>
+          <a:blip xmlns:r="http://schemas.openxmlformats.org/officeDocument/2006/relationships" xmlns:a="http://schemas.openxmlformats.org/drawingml/2006/main" r:embed="R83df1b9c6f7b4570"/>
           <a:stretch xmlns:a="http://schemas.openxmlformats.org/drawingml/2006/main"/>
         </p:blipFill>
         <p:spPr>
@@ -4794,7 +4909,7 @@
     </p:spTree>
     <p:extLst>
       <p:ext uri="{BB962C8B-B14F-4D97-AF65-F5344CB8AC3E}">
-        <p14:creationId xmlns:p14="http://schemas.microsoft.com/office/powerpoint/2010/main" val="183056590"/>
+        <p14:creationId xmlns:p14="http://schemas.microsoft.com/office/powerpoint/2010/main" val="1804609607"/>
       </p:ext>
     </p:extLst>
   </p:cSld>
@@ -4822,7 +4937,7 @@
           <p:nvPr/>
         </p:nvPicPr>
         <p:blipFill>
-          <a:blip xmlns:r="http://schemas.openxmlformats.org/officeDocument/2006/relationships" xmlns:a="http://schemas.openxmlformats.org/drawingml/2006/main" r:embed="R5dc8496a5ff4450b"/>
+          <a:blip xmlns:r="http://schemas.openxmlformats.org/officeDocument/2006/relationships" xmlns:a="http://schemas.openxmlformats.org/drawingml/2006/main" r:embed="R4a5f323550854e13"/>
           <a:stretch xmlns:a="http://schemas.openxmlformats.org/drawingml/2006/main"/>
         </p:blipFill>
         <p:spPr>
@@ -4838,7 +4953,7 @@
     </p:spTree>
     <p:extLst>
       <p:ext uri="{BB962C8B-B14F-4D97-AF65-F5344CB8AC3E}">
-        <p14:creationId xmlns:p14="http://schemas.microsoft.com/office/powerpoint/2010/main" val="1536371433"/>
+        <p14:creationId xmlns:p14="http://schemas.microsoft.com/office/powerpoint/2010/main" val="712793846"/>
       </p:ext>
     </p:extLst>
   </p:cSld>
@@ -4866,7 +4981,7 @@
           <p:nvPr/>
         </p:nvPicPr>
         <p:blipFill>
-          <a:blip xmlns:r="http://schemas.openxmlformats.org/officeDocument/2006/relationships" xmlns:a="http://schemas.openxmlformats.org/drawingml/2006/main" r:embed="R2353c391edfc4827"/>
+          <a:blip xmlns:r="http://schemas.openxmlformats.org/officeDocument/2006/relationships" xmlns:a="http://schemas.openxmlformats.org/drawingml/2006/main" r:embed="Rf8a41412116a4793"/>
           <a:stretch xmlns:a="http://schemas.openxmlformats.org/drawingml/2006/main"/>
         </p:blipFill>
         <p:spPr>
@@ -4882,7 +4997,7 @@
     </p:spTree>
     <p:extLst>
       <p:ext uri="{BB962C8B-B14F-4D97-AF65-F5344CB8AC3E}">
-        <p14:creationId xmlns:p14="http://schemas.microsoft.com/office/powerpoint/2010/main" val="1993694286"/>
+        <p14:creationId xmlns:p14="http://schemas.microsoft.com/office/powerpoint/2010/main" val="1342626851"/>
       </p:ext>
     </p:extLst>
   </p:cSld>
@@ -4910,7 +5025,7 @@
           <p:nvPr/>
         </p:nvPicPr>
         <p:blipFill>
-          <a:blip xmlns:r="http://schemas.openxmlformats.org/officeDocument/2006/relationships" xmlns:a="http://schemas.openxmlformats.org/drawingml/2006/main" r:embed="R5a82005745bf47c0"/>
+          <a:blip xmlns:r="http://schemas.openxmlformats.org/officeDocument/2006/relationships" xmlns:a="http://schemas.openxmlformats.org/drawingml/2006/main" r:embed="Rfd0f276edadc41da"/>
           <a:stretch xmlns:a="http://schemas.openxmlformats.org/drawingml/2006/main"/>
         </p:blipFill>
         <p:spPr>
@@ -4926,7 +5041,7 @@
     </p:spTree>
     <p:extLst>
       <p:ext uri="{BB962C8B-B14F-4D97-AF65-F5344CB8AC3E}">
-        <p14:creationId xmlns:p14="http://schemas.microsoft.com/office/powerpoint/2010/main" val="1327136452"/>
+        <p14:creationId xmlns:p14="http://schemas.microsoft.com/office/powerpoint/2010/main" val="604528572"/>
       </p:ext>
     </p:extLst>
   </p:cSld>
@@ -4954,7 +5069,7 @@
           <p:nvPr/>
         </p:nvPicPr>
         <p:blipFill>
-          <a:blip xmlns:r="http://schemas.openxmlformats.org/officeDocument/2006/relationships" xmlns:a="http://schemas.openxmlformats.org/drawingml/2006/main" r:embed="R0861cb7ce322470e"/>
+          <a:blip xmlns:r="http://schemas.openxmlformats.org/officeDocument/2006/relationships" xmlns:a="http://schemas.openxmlformats.org/drawingml/2006/main" r:embed="R94130d2a6737457e"/>
           <a:stretch xmlns:a="http://schemas.openxmlformats.org/drawingml/2006/main"/>
         </p:blipFill>
         <p:spPr>
@@ -4970,7 +5085,7 @@
     </p:spTree>
     <p:extLst>
       <p:ext uri="{BB962C8B-B14F-4D97-AF65-F5344CB8AC3E}">
-        <p14:creationId xmlns:p14="http://schemas.microsoft.com/office/powerpoint/2010/main" val="302855767"/>
+        <p14:creationId xmlns:p14="http://schemas.microsoft.com/office/powerpoint/2010/main" val="2052103195"/>
       </p:ext>
     </p:extLst>
   </p:cSld>
@@ -4998,7 +5113,7 @@
           <p:nvPr/>
         </p:nvPicPr>
         <p:blipFill>
-          <a:blip xmlns:r="http://schemas.openxmlformats.org/officeDocument/2006/relationships" xmlns:a="http://schemas.openxmlformats.org/drawingml/2006/main" r:embed="R6d73d3c2c667458d"/>
+          <a:blip xmlns:r="http://schemas.openxmlformats.org/officeDocument/2006/relationships" xmlns:a="http://schemas.openxmlformats.org/drawingml/2006/main" r:embed="Rdb91ec2476eb4174"/>
           <a:stretch xmlns:a="http://schemas.openxmlformats.org/drawingml/2006/main"/>
         </p:blipFill>
         <p:spPr>
@@ -5014,7 +5129,7 @@
     </p:spTree>
     <p:extLst>
       <p:ext uri="{BB962C8B-B14F-4D97-AF65-F5344CB8AC3E}">
-        <p14:creationId xmlns:p14="http://schemas.microsoft.com/office/powerpoint/2010/main" val="1282404642"/>
+        <p14:creationId xmlns:p14="http://schemas.microsoft.com/office/powerpoint/2010/main" val="1732247153"/>
       </p:ext>
     </p:extLst>
   </p:cSld>
@@ -5042,7 +5157,7 @@
           <p:nvPr/>
         </p:nvPicPr>
         <p:blipFill>
-          <a:blip xmlns:r="http://schemas.openxmlformats.org/officeDocument/2006/relationships" xmlns:a="http://schemas.openxmlformats.org/drawingml/2006/main" r:embed="R4b0b92f54490432d"/>
+          <a:blip xmlns:r="http://schemas.openxmlformats.org/officeDocument/2006/relationships" xmlns:a="http://schemas.openxmlformats.org/drawingml/2006/main" r:embed="R84ce68acfb424fa0"/>
           <a:stretch xmlns:a="http://schemas.openxmlformats.org/drawingml/2006/main"/>
         </p:blipFill>
         <p:spPr>
@@ -5058,7 +5173,7 @@
     </p:spTree>
     <p:extLst>
       <p:ext uri="{BB962C8B-B14F-4D97-AF65-F5344CB8AC3E}">
-        <p14:creationId xmlns:p14="http://schemas.microsoft.com/office/powerpoint/2010/main" val="1654969929"/>
+        <p14:creationId xmlns:p14="http://schemas.microsoft.com/office/powerpoint/2010/main" val="109380818"/>
       </p:ext>
     </p:extLst>
   </p:cSld>
@@ -5086,7 +5201,7 @@
           <p:nvPr/>
         </p:nvPicPr>
         <p:blipFill>
-          <a:blip xmlns:r="http://schemas.openxmlformats.org/officeDocument/2006/relationships" xmlns:a="http://schemas.openxmlformats.org/drawingml/2006/main" r:embed="R22da7c1411e342b1"/>
+          <a:blip xmlns:r="http://schemas.openxmlformats.org/officeDocument/2006/relationships" xmlns:a="http://schemas.openxmlformats.org/drawingml/2006/main" r:embed="Rd1070fab71bc4388"/>
           <a:stretch xmlns:a="http://schemas.openxmlformats.org/drawingml/2006/main"/>
         </p:blipFill>
         <p:spPr>
@@ -5102,7 +5217,7 @@
     </p:spTree>
     <p:extLst>
       <p:ext uri="{BB962C8B-B14F-4D97-AF65-F5344CB8AC3E}">
-        <p14:creationId xmlns:p14="http://schemas.microsoft.com/office/powerpoint/2010/main" val="1927447949"/>
+        <p14:creationId xmlns:p14="http://schemas.microsoft.com/office/powerpoint/2010/main" val="1908471438"/>
       </p:ext>
     </p:extLst>
   </p:cSld>
@@ -5130,7 +5245,7 @@
           <p:nvPr/>
         </p:nvPicPr>
         <p:blipFill>
-          <a:blip xmlns:r="http://schemas.openxmlformats.org/officeDocument/2006/relationships" xmlns:a="http://schemas.openxmlformats.org/drawingml/2006/main" r:embed="Rda364b6158504ed8"/>
+          <a:blip xmlns:r="http://schemas.openxmlformats.org/officeDocument/2006/relationships" xmlns:a="http://schemas.openxmlformats.org/drawingml/2006/main" r:embed="Re8204770d3e84bec"/>
           <a:stretch xmlns:a="http://schemas.openxmlformats.org/drawingml/2006/main"/>
         </p:blipFill>
         <p:spPr>
@@ -5146,7 +5261,7 @@
     </p:spTree>
     <p:extLst>
       <p:ext uri="{BB962C8B-B14F-4D97-AF65-F5344CB8AC3E}">
-        <p14:creationId xmlns:p14="http://schemas.microsoft.com/office/powerpoint/2010/main" val="1781509107"/>
+        <p14:creationId xmlns:p14="http://schemas.microsoft.com/office/powerpoint/2010/main" val="1530081624"/>
       </p:ext>
     </p:extLst>
   </p:cSld>
@@ -5174,7 +5289,7 @@
           <p:nvPr/>
         </p:nvPicPr>
         <p:blipFill>
-          <a:blip xmlns:r="http://schemas.openxmlformats.org/officeDocument/2006/relationships" xmlns:a="http://schemas.openxmlformats.org/drawingml/2006/main" r:embed="R1f890bc9fac542cf"/>
+          <a:blip xmlns:r="http://schemas.openxmlformats.org/officeDocument/2006/relationships" xmlns:a="http://schemas.openxmlformats.org/drawingml/2006/main" r:embed="Rb38b2c4c0cae4700"/>
           <a:stretch xmlns:a="http://schemas.openxmlformats.org/drawingml/2006/main"/>
         </p:blipFill>
         <p:spPr>
@@ -5190,7 +5305,7 @@
     </p:spTree>
     <p:extLst>
       <p:ext uri="{BB962C8B-B14F-4D97-AF65-F5344CB8AC3E}">
-        <p14:creationId xmlns:p14="http://schemas.microsoft.com/office/powerpoint/2010/main" val="1010592073"/>
+        <p14:creationId xmlns:p14="http://schemas.microsoft.com/office/powerpoint/2010/main" val="1857545863"/>
       </p:ext>
     </p:extLst>
   </p:cSld>
@@ -5218,7 +5333,7 @@
           <p:nvPr/>
         </p:nvPicPr>
         <p:blipFill>
-          <a:blip xmlns:r="http://schemas.openxmlformats.org/officeDocument/2006/relationships" xmlns:a="http://schemas.openxmlformats.org/drawingml/2006/main" r:embed="R18329973a9fe4992"/>
+          <a:blip xmlns:r="http://schemas.openxmlformats.org/officeDocument/2006/relationships" xmlns:a="http://schemas.openxmlformats.org/drawingml/2006/main" r:embed="R4c607f5ec93742fa"/>
           <a:stretch xmlns:a="http://schemas.openxmlformats.org/drawingml/2006/main"/>
         </p:blipFill>
         <p:spPr>
@@ -5234,7 +5349,7 @@
     </p:spTree>
     <p:extLst>
       <p:ext uri="{BB962C8B-B14F-4D97-AF65-F5344CB8AC3E}">
-        <p14:creationId xmlns:p14="http://schemas.microsoft.com/office/powerpoint/2010/main" val="2064668600"/>
+        <p14:creationId xmlns:p14="http://schemas.microsoft.com/office/powerpoint/2010/main" val="77880283"/>
       </p:ext>
     </p:extLst>
   </p:cSld>
@@ -5262,7 +5377,7 @@
           <p:nvPr/>
         </p:nvPicPr>
         <p:blipFill>
-          <a:blip xmlns:r="http://schemas.openxmlformats.org/officeDocument/2006/relationships" xmlns:a="http://schemas.openxmlformats.org/drawingml/2006/main" r:embed="Rd3d1d60080864b69"/>
+          <a:blip xmlns:r="http://schemas.openxmlformats.org/officeDocument/2006/relationships" xmlns:a="http://schemas.openxmlformats.org/drawingml/2006/main" r:embed="R44eccdf8b9504ba4"/>
           <a:stretch xmlns:a="http://schemas.openxmlformats.org/drawingml/2006/main"/>
         </p:blipFill>
         <p:spPr>
@@ -5278,7 +5393,7 @@
     </p:spTree>
     <p:extLst>
       <p:ext uri="{BB962C8B-B14F-4D97-AF65-F5344CB8AC3E}">
-        <p14:creationId xmlns:p14="http://schemas.microsoft.com/office/powerpoint/2010/main" val="1178915104"/>
+        <p14:creationId xmlns:p14="http://schemas.microsoft.com/office/powerpoint/2010/main" val="700849976"/>
       </p:ext>
     </p:extLst>
   </p:cSld>
@@ -5306,7 +5421,7 @@
           <p:nvPr/>
         </p:nvPicPr>
         <p:blipFill>
-          <a:blip xmlns:r="http://schemas.openxmlformats.org/officeDocument/2006/relationships" xmlns:a="http://schemas.openxmlformats.org/drawingml/2006/main" r:embed="R8db40050c1044647"/>
+          <a:blip xmlns:r="http://schemas.openxmlformats.org/officeDocument/2006/relationships" xmlns:a="http://schemas.openxmlformats.org/drawingml/2006/main" r:embed="Rbe77efeb9c4f45eb"/>
           <a:stretch xmlns:a="http://schemas.openxmlformats.org/drawingml/2006/main"/>
         </p:blipFill>
         <p:spPr>
@@ -5322,7 +5437,7 @@
     </p:spTree>
     <p:extLst>
       <p:ext uri="{BB962C8B-B14F-4D97-AF65-F5344CB8AC3E}">
-        <p14:creationId xmlns:p14="http://schemas.microsoft.com/office/powerpoint/2010/main" val="866147731"/>
+        <p14:creationId xmlns:p14="http://schemas.microsoft.com/office/powerpoint/2010/main" val="1730625343"/>
       </p:ext>
     </p:extLst>
   </p:cSld>
@@ -5350,7 +5465,7 @@
           <p:nvPr/>
         </p:nvPicPr>
         <p:blipFill>
-          <a:blip xmlns:r="http://schemas.openxmlformats.org/officeDocument/2006/relationships" xmlns:a="http://schemas.openxmlformats.org/drawingml/2006/main" r:embed="Rdae1a52933ad4ef6"/>
+          <a:blip xmlns:r="http://schemas.openxmlformats.org/officeDocument/2006/relationships" xmlns:a="http://schemas.openxmlformats.org/drawingml/2006/main" r:embed="R85a66d15ffd04e5a"/>
           <a:stretch xmlns:a="http://schemas.openxmlformats.org/drawingml/2006/main"/>
         </p:blipFill>
         <p:spPr>
@@ -5366,7 +5481,7 @@
     </p:spTree>
     <p:extLst>
       <p:ext uri="{BB962C8B-B14F-4D97-AF65-F5344CB8AC3E}">
-        <p14:creationId xmlns:p14="http://schemas.microsoft.com/office/powerpoint/2010/main" val="431156952"/>
+        <p14:creationId xmlns:p14="http://schemas.microsoft.com/office/powerpoint/2010/main" val="664015826"/>
       </p:ext>
     </p:extLst>
   </p:cSld>
@@ -5394,7 +5509,7 @@
           <p:nvPr/>
         </p:nvPicPr>
         <p:blipFill>
-          <a:blip xmlns:r="http://schemas.openxmlformats.org/officeDocument/2006/relationships" xmlns:a="http://schemas.openxmlformats.org/drawingml/2006/main" r:embed="R7852bd5cfe7748da"/>
+          <a:blip xmlns:r="http://schemas.openxmlformats.org/officeDocument/2006/relationships" xmlns:a="http://schemas.openxmlformats.org/drawingml/2006/main" r:embed="Ra460add9a8e04ce3"/>
           <a:stretch xmlns:a="http://schemas.openxmlformats.org/drawingml/2006/main"/>
         </p:blipFill>
         <p:spPr>
@@ -5410,7 +5525,7 @@
     </p:spTree>
     <p:extLst>
       <p:ext uri="{BB962C8B-B14F-4D97-AF65-F5344CB8AC3E}">
-        <p14:creationId xmlns:p14="http://schemas.microsoft.com/office/powerpoint/2010/main" val="1087195861"/>
+        <p14:creationId xmlns:p14="http://schemas.microsoft.com/office/powerpoint/2010/main" val="415592368"/>
       </p:ext>
     </p:extLst>
   </p:cSld>
@@ -5438,7 +5553,7 @@
           <p:nvPr/>
         </p:nvPicPr>
         <p:blipFill>
-          <a:blip xmlns:r="http://schemas.openxmlformats.org/officeDocument/2006/relationships" xmlns:a="http://schemas.openxmlformats.org/drawingml/2006/main" r:embed="R0da995cde58e4384"/>
+          <a:blip xmlns:r="http://schemas.openxmlformats.org/officeDocument/2006/relationships" xmlns:a="http://schemas.openxmlformats.org/drawingml/2006/main" r:embed="Rd1895353e8964d54"/>
           <a:stretch xmlns:a="http://schemas.openxmlformats.org/drawingml/2006/main"/>
         </p:blipFill>
         <p:spPr>
@@ -5454,7 +5569,7 @@
     </p:spTree>
     <p:extLst>
       <p:ext uri="{BB962C8B-B14F-4D97-AF65-F5344CB8AC3E}">
-        <p14:creationId xmlns:p14="http://schemas.microsoft.com/office/powerpoint/2010/main" val="2073410884"/>
+        <p14:creationId xmlns:p14="http://schemas.microsoft.com/office/powerpoint/2010/main" val="1786178217"/>
       </p:ext>
     </p:extLst>
   </p:cSld>
@@ -5482,7 +5597,7 @@
           <p:nvPr/>
         </p:nvPicPr>
         <p:blipFill>
-          <a:blip xmlns:r="http://schemas.openxmlformats.org/officeDocument/2006/relationships" xmlns:a="http://schemas.openxmlformats.org/drawingml/2006/main" r:embed="R1e7128bc02734750"/>
+          <a:blip xmlns:r="http://schemas.openxmlformats.org/officeDocument/2006/relationships" xmlns:a="http://schemas.openxmlformats.org/drawingml/2006/main" r:embed="R3cf57fbb174c49e5"/>
           <a:stretch xmlns:a="http://schemas.openxmlformats.org/drawingml/2006/main"/>
         </p:blipFill>
         <p:spPr>
@@ -5498,7 +5613,7 @@
     </p:spTree>
     <p:extLst>
       <p:ext uri="{BB962C8B-B14F-4D97-AF65-F5344CB8AC3E}">
-        <p14:creationId xmlns:p14="http://schemas.microsoft.com/office/powerpoint/2010/main" val="441936961"/>
+        <p14:creationId xmlns:p14="http://schemas.microsoft.com/office/powerpoint/2010/main" val="1123007840"/>
       </p:ext>
     </p:extLst>
   </p:cSld>
@@ -5526,7 +5641,7 @@
           <p:nvPr/>
         </p:nvPicPr>
         <p:blipFill>
-          <a:blip xmlns:r="http://schemas.openxmlformats.org/officeDocument/2006/relationships" xmlns:a="http://schemas.openxmlformats.org/drawingml/2006/main" r:embed="R24594a3221a34e97"/>
+          <a:blip xmlns:r="http://schemas.openxmlformats.org/officeDocument/2006/relationships" xmlns:a="http://schemas.openxmlformats.org/drawingml/2006/main" r:embed="Raa411436e7f6461b"/>
           <a:stretch xmlns:a="http://schemas.openxmlformats.org/drawingml/2006/main"/>
         </p:blipFill>
         <p:spPr>
@@ -5542,7 +5657,7 @@
     </p:spTree>
     <p:extLst>
       <p:ext uri="{BB962C8B-B14F-4D97-AF65-F5344CB8AC3E}">
-        <p14:creationId xmlns:p14="http://schemas.microsoft.com/office/powerpoint/2010/main" val="332908516"/>
+        <p14:creationId xmlns:p14="http://schemas.microsoft.com/office/powerpoint/2010/main" val="1200249309"/>
       </p:ext>
     </p:extLst>
   </p:cSld>
@@ -5570,7 +5685,7 @@
           <p:nvPr/>
         </p:nvPicPr>
         <p:blipFill>
-          <a:blip xmlns:r="http://schemas.openxmlformats.org/officeDocument/2006/relationships" xmlns:a="http://schemas.openxmlformats.org/drawingml/2006/main" r:embed="R85c7c6a6a27542fd"/>
+          <a:blip xmlns:r="http://schemas.openxmlformats.org/officeDocument/2006/relationships" xmlns:a="http://schemas.openxmlformats.org/drawingml/2006/main" r:embed="Rf5ada75d2d664960"/>
           <a:stretch xmlns:a="http://schemas.openxmlformats.org/drawingml/2006/main"/>
         </p:blipFill>
         <p:spPr>
@@ -5586,7 +5701,7 @@
     </p:spTree>
     <p:extLst>
       <p:ext uri="{BB962C8B-B14F-4D97-AF65-F5344CB8AC3E}">
-        <p14:creationId xmlns:p14="http://schemas.microsoft.com/office/powerpoint/2010/main" val="639233886"/>
+        <p14:creationId xmlns:p14="http://schemas.microsoft.com/office/powerpoint/2010/main" val="528232755"/>
       </p:ext>
     </p:extLst>
   </p:cSld>
@@ -5614,7 +5729,7 @@
           <p:nvPr/>
         </p:nvPicPr>
         <p:blipFill>
-          <a:blip xmlns:r="http://schemas.openxmlformats.org/officeDocument/2006/relationships" xmlns:a="http://schemas.openxmlformats.org/drawingml/2006/main" r:embed="Re72a0fc16b494b99"/>
+          <a:blip xmlns:r="http://schemas.openxmlformats.org/officeDocument/2006/relationships" xmlns:a="http://schemas.openxmlformats.org/drawingml/2006/main" r:embed="Rcebfba481e3c4630"/>
           <a:stretch xmlns:a="http://schemas.openxmlformats.org/drawingml/2006/main"/>
         </p:blipFill>
         <p:spPr>
@@ -5630,7 +5745,7 @@
     </p:spTree>
     <p:extLst>
       <p:ext uri="{BB962C8B-B14F-4D97-AF65-F5344CB8AC3E}">
-        <p14:creationId xmlns:p14="http://schemas.microsoft.com/office/powerpoint/2010/main" val="87797307"/>
+        <p14:creationId xmlns:p14="http://schemas.microsoft.com/office/powerpoint/2010/main" val="1631198808"/>
       </p:ext>
     </p:extLst>
   </p:cSld>
@@ -5658,7 +5773,7 @@
           <p:nvPr/>
         </p:nvPicPr>
         <p:blipFill>
-          <a:blip xmlns:r="http://schemas.openxmlformats.org/officeDocument/2006/relationships" xmlns:a="http://schemas.openxmlformats.org/drawingml/2006/main" r:embed="Rc8fa8012e9394971"/>
+          <a:blip xmlns:r="http://schemas.openxmlformats.org/officeDocument/2006/relationships" xmlns:a="http://schemas.openxmlformats.org/drawingml/2006/main" r:embed="Rd2f0b490e8564d2a"/>
           <a:stretch xmlns:a="http://schemas.openxmlformats.org/drawingml/2006/main"/>
         </p:blipFill>
         <p:spPr>
@@ -5674,7 +5789,7 @@
     </p:spTree>
     <p:extLst>
       <p:ext uri="{BB962C8B-B14F-4D97-AF65-F5344CB8AC3E}">
-        <p14:creationId xmlns:p14="http://schemas.microsoft.com/office/powerpoint/2010/main" val="612923828"/>
+        <p14:creationId xmlns:p14="http://schemas.microsoft.com/office/powerpoint/2010/main" val="1052916662"/>
       </p:ext>
     </p:extLst>
   </p:cSld>
@@ -5702,7 +5817,7 @@
           <p:nvPr/>
         </p:nvPicPr>
         <p:blipFill>
-          <a:blip xmlns:r="http://schemas.openxmlformats.org/officeDocument/2006/relationships" xmlns:a="http://schemas.openxmlformats.org/drawingml/2006/main" r:embed="Re25b84ad3cd84feb"/>
+          <a:blip xmlns:r="http://schemas.openxmlformats.org/officeDocument/2006/relationships" xmlns:a="http://schemas.openxmlformats.org/drawingml/2006/main" r:embed="Rfdc68a689f254435"/>
           <a:stretch xmlns:a="http://schemas.openxmlformats.org/drawingml/2006/main"/>
         </p:blipFill>
         <p:spPr>
@@ -5718,7 +5833,7 @@
     </p:spTree>
     <p:extLst>
       <p:ext uri="{BB962C8B-B14F-4D97-AF65-F5344CB8AC3E}">
-        <p14:creationId xmlns:p14="http://schemas.microsoft.com/office/powerpoint/2010/main" val="879226667"/>
+        <p14:creationId xmlns:p14="http://schemas.microsoft.com/office/powerpoint/2010/main" val="611432694"/>
       </p:ext>
     </p:extLst>
   </p:cSld>
@@ -5746,7 +5861,7 @@
           <p:nvPr/>
         </p:nvPicPr>
         <p:blipFill>
-          <a:blip xmlns:r="http://schemas.openxmlformats.org/officeDocument/2006/relationships" xmlns:a="http://schemas.openxmlformats.org/drawingml/2006/main" r:embed="Ra4543561e2104719"/>
+          <a:blip xmlns:r="http://schemas.openxmlformats.org/officeDocument/2006/relationships" xmlns:a="http://schemas.openxmlformats.org/drawingml/2006/main" r:embed="R0e6c59792805443a"/>
           <a:stretch xmlns:a="http://schemas.openxmlformats.org/drawingml/2006/main"/>
         </p:blipFill>
         <p:spPr>
@@ -5762,7 +5877,7 @@
     </p:spTree>
     <p:extLst>
       <p:ext uri="{BB962C8B-B14F-4D97-AF65-F5344CB8AC3E}">
-        <p14:creationId xmlns:p14="http://schemas.microsoft.com/office/powerpoint/2010/main" val="1010986328"/>
+        <p14:creationId xmlns:p14="http://schemas.microsoft.com/office/powerpoint/2010/main" val="928858971"/>
       </p:ext>
     </p:extLst>
   </p:cSld>
@@ -5790,7 +5905,7 @@
           <p:nvPr/>
         </p:nvPicPr>
         <p:blipFill>
-          <a:blip xmlns:r="http://schemas.openxmlformats.org/officeDocument/2006/relationships" xmlns:a="http://schemas.openxmlformats.org/drawingml/2006/main" r:embed="R9244b0e2ac26418a"/>
+          <a:blip xmlns:r="http://schemas.openxmlformats.org/officeDocument/2006/relationships" xmlns:a="http://schemas.openxmlformats.org/drawingml/2006/main" r:embed="Rfdc7bc30f79f426c"/>
           <a:stretch xmlns:a="http://schemas.openxmlformats.org/drawingml/2006/main"/>
         </p:blipFill>
         <p:spPr>
@@ -5806,7 +5921,7 @@
     </p:spTree>
     <p:extLst>
       <p:ext uri="{BB962C8B-B14F-4D97-AF65-F5344CB8AC3E}">
-        <p14:creationId xmlns:p14="http://schemas.microsoft.com/office/powerpoint/2010/main" val="1784867779"/>
+        <p14:creationId xmlns:p14="http://schemas.microsoft.com/office/powerpoint/2010/main" val="18253860"/>
       </p:ext>
     </p:extLst>
   </p:cSld>
@@ -5834,7 +5949,7 @@
           <p:nvPr/>
         </p:nvPicPr>
         <p:blipFill>
-          <a:blip xmlns:r="http://schemas.openxmlformats.org/officeDocument/2006/relationships" xmlns:a="http://schemas.openxmlformats.org/drawingml/2006/main" r:embed="Rba02edaf43b8449b"/>
+          <a:blip xmlns:r="http://schemas.openxmlformats.org/officeDocument/2006/relationships" xmlns:a="http://schemas.openxmlformats.org/drawingml/2006/main" r:embed="Re8a97589736e45c2"/>
           <a:stretch xmlns:a="http://schemas.openxmlformats.org/drawingml/2006/main"/>
         </p:blipFill>
         <p:spPr>
@@ -5850,7 +5965,7 @@
     </p:spTree>
     <p:extLst>
       <p:ext uri="{BB962C8B-B14F-4D97-AF65-F5344CB8AC3E}">
-        <p14:creationId xmlns:p14="http://schemas.microsoft.com/office/powerpoint/2010/main" val="1240075071"/>
+        <p14:creationId xmlns:p14="http://schemas.microsoft.com/office/powerpoint/2010/main" val="1968070789"/>
       </p:ext>
     </p:extLst>
   </p:cSld>
@@ -5878,7 +5993,7 @@
           <p:nvPr/>
         </p:nvPicPr>
         <p:blipFill>
-          <a:blip xmlns:r="http://schemas.openxmlformats.org/officeDocument/2006/relationships" xmlns:a="http://schemas.openxmlformats.org/drawingml/2006/main" r:embed="Rafb3c4cccabf4ef4"/>
+          <a:blip xmlns:r="http://schemas.openxmlformats.org/officeDocument/2006/relationships" xmlns:a="http://schemas.openxmlformats.org/drawingml/2006/main" r:embed="Rac156a2fac0d42ad"/>
           <a:stretch xmlns:a="http://schemas.openxmlformats.org/drawingml/2006/main"/>
         </p:blipFill>
         <p:spPr>
@@ -5894,7 +6009,7 @@
     </p:spTree>
     <p:extLst>
       <p:ext uri="{BB962C8B-B14F-4D97-AF65-F5344CB8AC3E}">
-        <p14:creationId xmlns:p14="http://schemas.microsoft.com/office/powerpoint/2010/main" val="610095119"/>
+        <p14:creationId xmlns:p14="http://schemas.microsoft.com/office/powerpoint/2010/main" val="985641117"/>
       </p:ext>
     </p:extLst>
   </p:cSld>

</xml_diff>

<commit_message>
Enlarge the complete Hasselhoff photograph on Lecture 1
</commit_message>
<xml_diff>
--- a/teaching/macro-applications/downloads/lecture_1.pptx
+++ b/teaching/macro-applications/downloads/lecture_1.pptx
@@ -2,39 +2,39 @@
 <file path=ppt/presentation.xml><?xml version="1.0" encoding="utf-8"?>
 <p:presentation xmlns:p="http://schemas.openxmlformats.org/presentationml/2006/main">
   <p:sldMasterIdLst>
-    <p:sldMasterId xmlns:r="http://schemas.openxmlformats.org/officeDocument/2006/relationships" id="2147483648" r:id="Rfcc3c60dd05f4b01"/>
+    <p:sldMasterId xmlns:r="http://schemas.openxmlformats.org/officeDocument/2006/relationships" id="2147483648" r:id="R1d5a4c5bda0c431b"/>
   </p:sldMasterIdLst>
   <p:notesMasterIdLst>
-    <p:notesMasterId xmlns:r="http://schemas.openxmlformats.org/officeDocument/2006/relationships" r:id="Re5ecb6f0821e4bd7"/>
+    <p:notesMasterId xmlns:r="http://schemas.openxmlformats.org/officeDocument/2006/relationships" r:id="Rb00ab6de9c5742bf"/>
   </p:notesMasterIdLst>
   <p:sldIdLst>
-    <p:sldId xmlns:r="http://schemas.openxmlformats.org/officeDocument/2006/relationships" id="256" r:id="R5f03ccecba284949"/>
-    <p:sldId xmlns:r="http://schemas.openxmlformats.org/officeDocument/2006/relationships" id="257" r:id="R4af68580bfb34011"/>
-    <p:sldId xmlns:r="http://schemas.openxmlformats.org/officeDocument/2006/relationships" id="258" r:id="Rcc328ac5ea5a48ef"/>
-    <p:sldId xmlns:r="http://schemas.openxmlformats.org/officeDocument/2006/relationships" id="259" r:id="Rbed9c841fd514c6f"/>
-    <p:sldId xmlns:r="http://schemas.openxmlformats.org/officeDocument/2006/relationships" id="260" r:id="Ree9a5575990647b9"/>
-    <p:sldId xmlns:r="http://schemas.openxmlformats.org/officeDocument/2006/relationships" id="261" r:id="Rd8b1b70498cc4943"/>
-    <p:sldId xmlns:r="http://schemas.openxmlformats.org/officeDocument/2006/relationships" id="262" r:id="R6d29d8e5c926448d"/>
-    <p:sldId xmlns:r="http://schemas.openxmlformats.org/officeDocument/2006/relationships" id="263" r:id="R062c918bc8cf4d5b"/>
-    <p:sldId xmlns:r="http://schemas.openxmlformats.org/officeDocument/2006/relationships" id="264" r:id="Rbf714044aa8044e7"/>
-    <p:sldId xmlns:r="http://schemas.openxmlformats.org/officeDocument/2006/relationships" id="265" r:id="Rb638d72f46eb41e2"/>
-    <p:sldId xmlns:r="http://schemas.openxmlformats.org/officeDocument/2006/relationships" id="266" r:id="R5380fb41bb1b4bed"/>
-    <p:sldId xmlns:r="http://schemas.openxmlformats.org/officeDocument/2006/relationships" id="267" r:id="R5fc4d228475c444f"/>
-    <p:sldId xmlns:r="http://schemas.openxmlformats.org/officeDocument/2006/relationships" id="268" r:id="R66efae53160d4840"/>
-    <p:sldId xmlns:r="http://schemas.openxmlformats.org/officeDocument/2006/relationships" id="269" r:id="R631fc3fff795449e"/>
-    <p:sldId xmlns:r="http://schemas.openxmlformats.org/officeDocument/2006/relationships" id="270" r:id="Rffa582fc2f6d4134"/>
-    <p:sldId xmlns:r="http://schemas.openxmlformats.org/officeDocument/2006/relationships" id="271" r:id="Reaf3448d1c374d54"/>
-    <p:sldId xmlns:r="http://schemas.openxmlformats.org/officeDocument/2006/relationships" id="272" r:id="Rd003d1b38fd149bf"/>
-    <p:sldId xmlns:r="http://schemas.openxmlformats.org/officeDocument/2006/relationships" id="273" r:id="R891e62855c634fa9"/>
-    <p:sldId xmlns:r="http://schemas.openxmlformats.org/officeDocument/2006/relationships" id="274" r:id="Rdff7aa665388431b"/>
-    <p:sldId xmlns:r="http://schemas.openxmlformats.org/officeDocument/2006/relationships" id="275" r:id="R2fdcb08e3edf44e9"/>
-    <p:sldId xmlns:r="http://schemas.openxmlformats.org/officeDocument/2006/relationships" id="276" r:id="R15d90f79400f4a55"/>
-    <p:sldId xmlns:r="http://schemas.openxmlformats.org/officeDocument/2006/relationships" id="277" r:id="Ra2dc9739e2924e9a"/>
-    <p:sldId xmlns:r="http://schemas.openxmlformats.org/officeDocument/2006/relationships" id="278" r:id="R148504be3eaf496c"/>
-    <p:sldId xmlns:r="http://schemas.openxmlformats.org/officeDocument/2006/relationships" id="279" r:id="Rd91579d1a49047f9"/>
-    <p:sldId xmlns:r="http://schemas.openxmlformats.org/officeDocument/2006/relationships" id="280" r:id="Rb766574569474feb"/>
-    <p:sldId xmlns:r="http://schemas.openxmlformats.org/officeDocument/2006/relationships" id="281" r:id="R57ab791190094ebe"/>
-    <p:sldId xmlns:r="http://schemas.openxmlformats.org/officeDocument/2006/relationships" id="282" r:id="R75efbe1f55574a2a"/>
+    <p:sldId xmlns:r="http://schemas.openxmlformats.org/officeDocument/2006/relationships" id="256" r:id="R161e3a0ec30949ad"/>
+    <p:sldId xmlns:r="http://schemas.openxmlformats.org/officeDocument/2006/relationships" id="257" r:id="Ra7ed63610cec4c8e"/>
+    <p:sldId xmlns:r="http://schemas.openxmlformats.org/officeDocument/2006/relationships" id="258" r:id="R410f4d70a84c448f"/>
+    <p:sldId xmlns:r="http://schemas.openxmlformats.org/officeDocument/2006/relationships" id="259" r:id="R1e23e77a99804a4f"/>
+    <p:sldId xmlns:r="http://schemas.openxmlformats.org/officeDocument/2006/relationships" id="260" r:id="Rf05693ba461a43f9"/>
+    <p:sldId xmlns:r="http://schemas.openxmlformats.org/officeDocument/2006/relationships" id="261" r:id="R4f9ba948ca134f0e"/>
+    <p:sldId xmlns:r="http://schemas.openxmlformats.org/officeDocument/2006/relationships" id="262" r:id="Rb495bcd2a1054e97"/>
+    <p:sldId xmlns:r="http://schemas.openxmlformats.org/officeDocument/2006/relationships" id="263" r:id="R94aaf2ee95214f28"/>
+    <p:sldId xmlns:r="http://schemas.openxmlformats.org/officeDocument/2006/relationships" id="264" r:id="R4c5b882ba369488a"/>
+    <p:sldId xmlns:r="http://schemas.openxmlformats.org/officeDocument/2006/relationships" id="265" r:id="R424ab4a5150b42b4"/>
+    <p:sldId xmlns:r="http://schemas.openxmlformats.org/officeDocument/2006/relationships" id="266" r:id="Rd106e9a9f95548da"/>
+    <p:sldId xmlns:r="http://schemas.openxmlformats.org/officeDocument/2006/relationships" id="267" r:id="R4ac576c59064450f"/>
+    <p:sldId xmlns:r="http://schemas.openxmlformats.org/officeDocument/2006/relationships" id="268" r:id="R4a1c39da5d234cbe"/>
+    <p:sldId xmlns:r="http://schemas.openxmlformats.org/officeDocument/2006/relationships" id="269" r:id="R4a88e2203b924641"/>
+    <p:sldId xmlns:r="http://schemas.openxmlformats.org/officeDocument/2006/relationships" id="270" r:id="R5eeb3b3c0f5d4d2b"/>
+    <p:sldId xmlns:r="http://schemas.openxmlformats.org/officeDocument/2006/relationships" id="271" r:id="Ra5c27dcee4c244cc"/>
+    <p:sldId xmlns:r="http://schemas.openxmlformats.org/officeDocument/2006/relationships" id="272" r:id="Rb4d3a342f4944165"/>
+    <p:sldId xmlns:r="http://schemas.openxmlformats.org/officeDocument/2006/relationships" id="273" r:id="Rac49bf133f9a4edc"/>
+    <p:sldId xmlns:r="http://schemas.openxmlformats.org/officeDocument/2006/relationships" id="274" r:id="R99379a7448d94559"/>
+    <p:sldId xmlns:r="http://schemas.openxmlformats.org/officeDocument/2006/relationships" id="275" r:id="Raaad4f93362342c5"/>
+    <p:sldId xmlns:r="http://schemas.openxmlformats.org/officeDocument/2006/relationships" id="276" r:id="Re882ff767cd64dbc"/>
+    <p:sldId xmlns:r="http://schemas.openxmlformats.org/officeDocument/2006/relationships" id="277" r:id="R003e920b57494658"/>
+    <p:sldId xmlns:r="http://schemas.openxmlformats.org/officeDocument/2006/relationships" id="278" r:id="Re4a93e1f31af4226"/>
+    <p:sldId xmlns:r="http://schemas.openxmlformats.org/officeDocument/2006/relationships" id="279" r:id="R293bb0493d09468d"/>
+    <p:sldId xmlns:r="http://schemas.openxmlformats.org/officeDocument/2006/relationships" id="280" r:id="R57d8f7a8c8f94732"/>
+    <p:sldId xmlns:r="http://schemas.openxmlformats.org/officeDocument/2006/relationships" id="281" r:id="R1a3a103ee4054da9"/>
+    <p:sldId xmlns:r="http://schemas.openxmlformats.org/officeDocument/2006/relationships" id="282" r:id="Ra1f758e547ce4327"/>
   </p:sldIdLst>
   <p:sldSz cx="12192000" cy="6858000"/>
   <p:notesSz cx="6858000" cy="9144000"/>
@@ -4301,7 +4301,7 @@
   </p:cSld>
   <p:clrMap bg1="lt1" tx1="dk1" bg2="lt2" tx2="dk2" accent1="accent1" accent2="accent2" accent3="accent3" accent4="accent4" accent5="accent5" accent6="accent6" hlink="hlink" folHlink="folHlink"/>
   <p:sldLayoutIdLst>
-    <p:sldLayoutId xmlns:r="http://schemas.openxmlformats.org/officeDocument/2006/relationships" id="2147483649" r:id="R3294e4dbf33a4a96"/>
+    <p:sldLayoutId xmlns:r="http://schemas.openxmlformats.org/officeDocument/2006/relationships" id="2147483649" r:id="R3ab3ba43e7b84ed4"/>
   </p:sldLayoutIdLst>
   <p:txStyles>
     <p:titleStyle>
@@ -4849,7 +4849,7 @@
           <p:nvPr/>
         </p:nvPicPr>
         <p:blipFill>
-          <a:blip xmlns:r="http://schemas.openxmlformats.org/officeDocument/2006/relationships" xmlns:a="http://schemas.openxmlformats.org/drawingml/2006/main" r:embed="R1fadce5945a54c74"/>
+          <a:blip xmlns:r="http://schemas.openxmlformats.org/officeDocument/2006/relationships" xmlns:a="http://schemas.openxmlformats.org/drawingml/2006/main" r:embed="R0ddc63ecf02e44eb"/>
           <a:stretch xmlns:a="http://schemas.openxmlformats.org/drawingml/2006/main"/>
         </p:blipFill>
         <p:spPr>
@@ -4865,7 +4865,7 @@
     </p:spTree>
     <p:extLst>
       <p:ext uri="{BB962C8B-B14F-4D97-AF65-F5344CB8AC3E}">
-        <p14:creationId xmlns:p14="http://schemas.microsoft.com/office/powerpoint/2010/main" val="1239858466"/>
+        <p14:creationId xmlns:p14="http://schemas.microsoft.com/office/powerpoint/2010/main" val="956591022"/>
       </p:ext>
     </p:extLst>
   </p:cSld>
@@ -4893,7 +4893,7 @@
           <p:nvPr/>
         </p:nvPicPr>
         <p:blipFill>
-          <a:blip xmlns:r="http://schemas.openxmlformats.org/officeDocument/2006/relationships" xmlns:a="http://schemas.openxmlformats.org/drawingml/2006/main" r:embed="R83df1b9c6f7b4570"/>
+          <a:blip xmlns:r="http://schemas.openxmlformats.org/officeDocument/2006/relationships" xmlns:a="http://schemas.openxmlformats.org/drawingml/2006/main" r:embed="Ree7856a205634919"/>
           <a:stretch xmlns:a="http://schemas.openxmlformats.org/drawingml/2006/main"/>
         </p:blipFill>
         <p:spPr>
@@ -4909,7 +4909,7 @@
     </p:spTree>
     <p:extLst>
       <p:ext uri="{BB962C8B-B14F-4D97-AF65-F5344CB8AC3E}">
-        <p14:creationId xmlns:p14="http://schemas.microsoft.com/office/powerpoint/2010/main" val="1804609607"/>
+        <p14:creationId xmlns:p14="http://schemas.microsoft.com/office/powerpoint/2010/main" val="2034767347"/>
       </p:ext>
     </p:extLst>
   </p:cSld>
@@ -4937,7 +4937,7 @@
           <p:nvPr/>
         </p:nvPicPr>
         <p:blipFill>
-          <a:blip xmlns:r="http://schemas.openxmlformats.org/officeDocument/2006/relationships" xmlns:a="http://schemas.openxmlformats.org/drawingml/2006/main" r:embed="R4a5f323550854e13"/>
+          <a:blip xmlns:r="http://schemas.openxmlformats.org/officeDocument/2006/relationships" xmlns:a="http://schemas.openxmlformats.org/drawingml/2006/main" r:embed="R60b216fb72954010"/>
           <a:stretch xmlns:a="http://schemas.openxmlformats.org/drawingml/2006/main"/>
         </p:blipFill>
         <p:spPr>
@@ -4953,7 +4953,7 @@
     </p:spTree>
     <p:extLst>
       <p:ext uri="{BB962C8B-B14F-4D97-AF65-F5344CB8AC3E}">
-        <p14:creationId xmlns:p14="http://schemas.microsoft.com/office/powerpoint/2010/main" val="712793846"/>
+        <p14:creationId xmlns:p14="http://schemas.microsoft.com/office/powerpoint/2010/main" val="1249804834"/>
       </p:ext>
     </p:extLst>
   </p:cSld>
@@ -4981,7 +4981,7 @@
           <p:nvPr/>
         </p:nvPicPr>
         <p:blipFill>
-          <a:blip xmlns:r="http://schemas.openxmlformats.org/officeDocument/2006/relationships" xmlns:a="http://schemas.openxmlformats.org/drawingml/2006/main" r:embed="Rf8a41412116a4793"/>
+          <a:blip xmlns:r="http://schemas.openxmlformats.org/officeDocument/2006/relationships" xmlns:a="http://schemas.openxmlformats.org/drawingml/2006/main" r:embed="Rdc15c4ad5c2d439f"/>
           <a:stretch xmlns:a="http://schemas.openxmlformats.org/drawingml/2006/main"/>
         </p:blipFill>
         <p:spPr>
@@ -4997,7 +4997,7 @@
     </p:spTree>
     <p:extLst>
       <p:ext uri="{BB962C8B-B14F-4D97-AF65-F5344CB8AC3E}">
-        <p14:creationId xmlns:p14="http://schemas.microsoft.com/office/powerpoint/2010/main" val="1342626851"/>
+        <p14:creationId xmlns:p14="http://schemas.microsoft.com/office/powerpoint/2010/main" val="1740008360"/>
       </p:ext>
     </p:extLst>
   </p:cSld>
@@ -5025,7 +5025,7 @@
           <p:nvPr/>
         </p:nvPicPr>
         <p:blipFill>
-          <a:blip xmlns:r="http://schemas.openxmlformats.org/officeDocument/2006/relationships" xmlns:a="http://schemas.openxmlformats.org/drawingml/2006/main" r:embed="Rfd0f276edadc41da"/>
+          <a:blip xmlns:r="http://schemas.openxmlformats.org/officeDocument/2006/relationships" xmlns:a="http://schemas.openxmlformats.org/drawingml/2006/main" r:embed="R31a488cc9b6345be"/>
           <a:stretch xmlns:a="http://schemas.openxmlformats.org/drawingml/2006/main"/>
         </p:blipFill>
         <p:spPr>
@@ -5041,7 +5041,7 @@
     </p:spTree>
     <p:extLst>
       <p:ext uri="{BB962C8B-B14F-4D97-AF65-F5344CB8AC3E}">
-        <p14:creationId xmlns:p14="http://schemas.microsoft.com/office/powerpoint/2010/main" val="604528572"/>
+        <p14:creationId xmlns:p14="http://schemas.microsoft.com/office/powerpoint/2010/main" val="1225855945"/>
       </p:ext>
     </p:extLst>
   </p:cSld>
@@ -5069,7 +5069,7 @@
           <p:nvPr/>
         </p:nvPicPr>
         <p:blipFill>
-          <a:blip xmlns:r="http://schemas.openxmlformats.org/officeDocument/2006/relationships" xmlns:a="http://schemas.openxmlformats.org/drawingml/2006/main" r:embed="R94130d2a6737457e"/>
+          <a:blip xmlns:r="http://schemas.openxmlformats.org/officeDocument/2006/relationships" xmlns:a="http://schemas.openxmlformats.org/drawingml/2006/main" r:embed="R02599276e1ef4c5f"/>
           <a:stretch xmlns:a="http://schemas.openxmlformats.org/drawingml/2006/main"/>
         </p:blipFill>
         <p:spPr>
@@ -5085,7 +5085,7 @@
     </p:spTree>
     <p:extLst>
       <p:ext uri="{BB962C8B-B14F-4D97-AF65-F5344CB8AC3E}">
-        <p14:creationId xmlns:p14="http://schemas.microsoft.com/office/powerpoint/2010/main" val="2052103195"/>
+        <p14:creationId xmlns:p14="http://schemas.microsoft.com/office/powerpoint/2010/main" val="236235841"/>
       </p:ext>
     </p:extLst>
   </p:cSld>
@@ -5113,7 +5113,7 @@
           <p:nvPr/>
         </p:nvPicPr>
         <p:blipFill>
-          <a:blip xmlns:r="http://schemas.openxmlformats.org/officeDocument/2006/relationships" xmlns:a="http://schemas.openxmlformats.org/drawingml/2006/main" r:embed="Rdb91ec2476eb4174"/>
+          <a:blip xmlns:r="http://schemas.openxmlformats.org/officeDocument/2006/relationships" xmlns:a="http://schemas.openxmlformats.org/drawingml/2006/main" r:embed="R775fe97cc43f4bbb"/>
           <a:stretch xmlns:a="http://schemas.openxmlformats.org/drawingml/2006/main"/>
         </p:blipFill>
         <p:spPr>
@@ -5129,7 +5129,7 @@
     </p:spTree>
     <p:extLst>
       <p:ext uri="{BB962C8B-B14F-4D97-AF65-F5344CB8AC3E}">
-        <p14:creationId xmlns:p14="http://schemas.microsoft.com/office/powerpoint/2010/main" val="1732247153"/>
+        <p14:creationId xmlns:p14="http://schemas.microsoft.com/office/powerpoint/2010/main" val="1529324599"/>
       </p:ext>
     </p:extLst>
   </p:cSld>
@@ -5157,7 +5157,7 @@
           <p:nvPr/>
         </p:nvPicPr>
         <p:blipFill>
-          <a:blip xmlns:r="http://schemas.openxmlformats.org/officeDocument/2006/relationships" xmlns:a="http://schemas.openxmlformats.org/drawingml/2006/main" r:embed="R84ce68acfb424fa0"/>
+          <a:blip xmlns:r="http://schemas.openxmlformats.org/officeDocument/2006/relationships" xmlns:a="http://schemas.openxmlformats.org/drawingml/2006/main" r:embed="R380f0be520fd4037"/>
           <a:stretch xmlns:a="http://schemas.openxmlformats.org/drawingml/2006/main"/>
         </p:blipFill>
         <p:spPr>
@@ -5173,7 +5173,7 @@
     </p:spTree>
     <p:extLst>
       <p:ext uri="{BB962C8B-B14F-4D97-AF65-F5344CB8AC3E}">
-        <p14:creationId xmlns:p14="http://schemas.microsoft.com/office/powerpoint/2010/main" val="109380818"/>
+        <p14:creationId xmlns:p14="http://schemas.microsoft.com/office/powerpoint/2010/main" val="254461078"/>
       </p:ext>
     </p:extLst>
   </p:cSld>
@@ -5201,7 +5201,7 @@
           <p:nvPr/>
         </p:nvPicPr>
         <p:blipFill>
-          <a:blip xmlns:r="http://schemas.openxmlformats.org/officeDocument/2006/relationships" xmlns:a="http://schemas.openxmlformats.org/drawingml/2006/main" r:embed="Rd1070fab71bc4388"/>
+          <a:blip xmlns:r="http://schemas.openxmlformats.org/officeDocument/2006/relationships" xmlns:a="http://schemas.openxmlformats.org/drawingml/2006/main" r:embed="R3538a5d86db54ab5"/>
           <a:stretch xmlns:a="http://schemas.openxmlformats.org/drawingml/2006/main"/>
         </p:blipFill>
         <p:spPr>
@@ -5217,7 +5217,7 @@
     </p:spTree>
     <p:extLst>
       <p:ext uri="{BB962C8B-B14F-4D97-AF65-F5344CB8AC3E}">
-        <p14:creationId xmlns:p14="http://schemas.microsoft.com/office/powerpoint/2010/main" val="1908471438"/>
+        <p14:creationId xmlns:p14="http://schemas.microsoft.com/office/powerpoint/2010/main" val="938502960"/>
       </p:ext>
     </p:extLst>
   </p:cSld>
@@ -5245,7 +5245,7 @@
           <p:nvPr/>
         </p:nvPicPr>
         <p:blipFill>
-          <a:blip xmlns:r="http://schemas.openxmlformats.org/officeDocument/2006/relationships" xmlns:a="http://schemas.openxmlformats.org/drawingml/2006/main" r:embed="Re8204770d3e84bec"/>
+          <a:blip xmlns:r="http://schemas.openxmlformats.org/officeDocument/2006/relationships" xmlns:a="http://schemas.openxmlformats.org/drawingml/2006/main" r:embed="R9015cba60230458b"/>
           <a:stretch xmlns:a="http://schemas.openxmlformats.org/drawingml/2006/main"/>
         </p:blipFill>
         <p:spPr>
@@ -5261,7 +5261,7 @@
     </p:spTree>
     <p:extLst>
       <p:ext uri="{BB962C8B-B14F-4D97-AF65-F5344CB8AC3E}">
-        <p14:creationId xmlns:p14="http://schemas.microsoft.com/office/powerpoint/2010/main" val="1530081624"/>
+        <p14:creationId xmlns:p14="http://schemas.microsoft.com/office/powerpoint/2010/main" val="657048383"/>
       </p:ext>
     </p:extLst>
   </p:cSld>
@@ -5289,7 +5289,7 @@
           <p:nvPr/>
         </p:nvPicPr>
         <p:blipFill>
-          <a:blip xmlns:r="http://schemas.openxmlformats.org/officeDocument/2006/relationships" xmlns:a="http://schemas.openxmlformats.org/drawingml/2006/main" r:embed="Rb38b2c4c0cae4700"/>
+          <a:blip xmlns:r="http://schemas.openxmlformats.org/officeDocument/2006/relationships" xmlns:a="http://schemas.openxmlformats.org/drawingml/2006/main" r:embed="R7f5d3302ae824377"/>
           <a:stretch xmlns:a="http://schemas.openxmlformats.org/drawingml/2006/main"/>
         </p:blipFill>
         <p:spPr>
@@ -5305,7 +5305,7 @@
     </p:spTree>
     <p:extLst>
       <p:ext uri="{BB962C8B-B14F-4D97-AF65-F5344CB8AC3E}">
-        <p14:creationId xmlns:p14="http://schemas.microsoft.com/office/powerpoint/2010/main" val="1857545863"/>
+        <p14:creationId xmlns:p14="http://schemas.microsoft.com/office/powerpoint/2010/main" val="1642115809"/>
       </p:ext>
     </p:extLst>
   </p:cSld>
@@ -5333,7 +5333,7 @@
           <p:nvPr/>
         </p:nvPicPr>
         <p:blipFill>
-          <a:blip xmlns:r="http://schemas.openxmlformats.org/officeDocument/2006/relationships" xmlns:a="http://schemas.openxmlformats.org/drawingml/2006/main" r:embed="R4c607f5ec93742fa"/>
+          <a:blip xmlns:r="http://schemas.openxmlformats.org/officeDocument/2006/relationships" xmlns:a="http://schemas.openxmlformats.org/drawingml/2006/main" r:embed="R4523768829a441e1"/>
           <a:stretch xmlns:a="http://schemas.openxmlformats.org/drawingml/2006/main"/>
         </p:blipFill>
         <p:spPr>
@@ -5349,7 +5349,7 @@
     </p:spTree>
     <p:extLst>
       <p:ext uri="{BB962C8B-B14F-4D97-AF65-F5344CB8AC3E}">
-        <p14:creationId xmlns:p14="http://schemas.microsoft.com/office/powerpoint/2010/main" val="77880283"/>
+        <p14:creationId xmlns:p14="http://schemas.microsoft.com/office/powerpoint/2010/main" val="438118554"/>
       </p:ext>
     </p:extLst>
   </p:cSld>
@@ -5377,7 +5377,7 @@
           <p:nvPr/>
         </p:nvPicPr>
         <p:blipFill>
-          <a:blip xmlns:r="http://schemas.openxmlformats.org/officeDocument/2006/relationships" xmlns:a="http://schemas.openxmlformats.org/drawingml/2006/main" r:embed="R44eccdf8b9504ba4"/>
+          <a:blip xmlns:r="http://schemas.openxmlformats.org/officeDocument/2006/relationships" xmlns:a="http://schemas.openxmlformats.org/drawingml/2006/main" r:embed="R138bdff6ecea4a69"/>
           <a:stretch xmlns:a="http://schemas.openxmlformats.org/drawingml/2006/main"/>
         </p:blipFill>
         <p:spPr>
@@ -5393,7 +5393,7 @@
     </p:spTree>
     <p:extLst>
       <p:ext uri="{BB962C8B-B14F-4D97-AF65-F5344CB8AC3E}">
-        <p14:creationId xmlns:p14="http://schemas.microsoft.com/office/powerpoint/2010/main" val="700849976"/>
+        <p14:creationId xmlns:p14="http://schemas.microsoft.com/office/powerpoint/2010/main" val="676884188"/>
       </p:ext>
     </p:extLst>
   </p:cSld>
@@ -5421,7 +5421,7 @@
           <p:nvPr/>
         </p:nvPicPr>
         <p:blipFill>
-          <a:blip xmlns:r="http://schemas.openxmlformats.org/officeDocument/2006/relationships" xmlns:a="http://schemas.openxmlformats.org/drawingml/2006/main" r:embed="Rbe77efeb9c4f45eb"/>
+          <a:blip xmlns:r="http://schemas.openxmlformats.org/officeDocument/2006/relationships" xmlns:a="http://schemas.openxmlformats.org/drawingml/2006/main" r:embed="Ra16ce1060ffc47b9"/>
           <a:stretch xmlns:a="http://schemas.openxmlformats.org/drawingml/2006/main"/>
         </p:blipFill>
         <p:spPr>
@@ -5437,7 +5437,7 @@
     </p:spTree>
     <p:extLst>
       <p:ext uri="{BB962C8B-B14F-4D97-AF65-F5344CB8AC3E}">
-        <p14:creationId xmlns:p14="http://schemas.microsoft.com/office/powerpoint/2010/main" val="1730625343"/>
+        <p14:creationId xmlns:p14="http://schemas.microsoft.com/office/powerpoint/2010/main" val="226779528"/>
       </p:ext>
     </p:extLst>
   </p:cSld>
@@ -5465,7 +5465,7 @@
           <p:nvPr/>
         </p:nvPicPr>
         <p:blipFill>
-          <a:blip xmlns:r="http://schemas.openxmlformats.org/officeDocument/2006/relationships" xmlns:a="http://schemas.openxmlformats.org/drawingml/2006/main" r:embed="R85a66d15ffd04e5a"/>
+          <a:blip xmlns:r="http://schemas.openxmlformats.org/officeDocument/2006/relationships" xmlns:a="http://schemas.openxmlformats.org/drawingml/2006/main" r:embed="R9eb603471c1e41c5"/>
           <a:stretch xmlns:a="http://schemas.openxmlformats.org/drawingml/2006/main"/>
         </p:blipFill>
         <p:spPr>
@@ -5481,7 +5481,7 @@
     </p:spTree>
     <p:extLst>
       <p:ext uri="{BB962C8B-B14F-4D97-AF65-F5344CB8AC3E}">
-        <p14:creationId xmlns:p14="http://schemas.microsoft.com/office/powerpoint/2010/main" val="664015826"/>
+        <p14:creationId xmlns:p14="http://schemas.microsoft.com/office/powerpoint/2010/main" val="1765964440"/>
       </p:ext>
     </p:extLst>
   </p:cSld>
@@ -5509,7 +5509,7 @@
           <p:nvPr/>
         </p:nvPicPr>
         <p:blipFill>
-          <a:blip xmlns:r="http://schemas.openxmlformats.org/officeDocument/2006/relationships" xmlns:a="http://schemas.openxmlformats.org/drawingml/2006/main" r:embed="Ra460add9a8e04ce3"/>
+          <a:blip xmlns:r="http://schemas.openxmlformats.org/officeDocument/2006/relationships" xmlns:a="http://schemas.openxmlformats.org/drawingml/2006/main" r:embed="Rf43f04cf41de4a4a"/>
           <a:stretch xmlns:a="http://schemas.openxmlformats.org/drawingml/2006/main"/>
         </p:blipFill>
         <p:spPr>
@@ -5525,7 +5525,7 @@
     </p:spTree>
     <p:extLst>
       <p:ext uri="{BB962C8B-B14F-4D97-AF65-F5344CB8AC3E}">
-        <p14:creationId xmlns:p14="http://schemas.microsoft.com/office/powerpoint/2010/main" val="415592368"/>
+        <p14:creationId xmlns:p14="http://schemas.microsoft.com/office/powerpoint/2010/main" val="1498047098"/>
       </p:ext>
     </p:extLst>
   </p:cSld>
@@ -5553,7 +5553,7 @@
           <p:nvPr/>
         </p:nvPicPr>
         <p:blipFill>
-          <a:blip xmlns:r="http://schemas.openxmlformats.org/officeDocument/2006/relationships" xmlns:a="http://schemas.openxmlformats.org/drawingml/2006/main" r:embed="Rd1895353e8964d54"/>
+          <a:blip xmlns:r="http://schemas.openxmlformats.org/officeDocument/2006/relationships" xmlns:a="http://schemas.openxmlformats.org/drawingml/2006/main" r:embed="R5335025379b547b2"/>
           <a:stretch xmlns:a="http://schemas.openxmlformats.org/drawingml/2006/main"/>
         </p:blipFill>
         <p:spPr>
@@ -5569,7 +5569,7 @@
     </p:spTree>
     <p:extLst>
       <p:ext uri="{BB962C8B-B14F-4D97-AF65-F5344CB8AC3E}">
-        <p14:creationId xmlns:p14="http://schemas.microsoft.com/office/powerpoint/2010/main" val="1786178217"/>
+        <p14:creationId xmlns:p14="http://schemas.microsoft.com/office/powerpoint/2010/main" val="2019384463"/>
       </p:ext>
     </p:extLst>
   </p:cSld>
@@ -5597,7 +5597,7 @@
           <p:nvPr/>
         </p:nvPicPr>
         <p:blipFill>
-          <a:blip xmlns:r="http://schemas.openxmlformats.org/officeDocument/2006/relationships" xmlns:a="http://schemas.openxmlformats.org/drawingml/2006/main" r:embed="R3cf57fbb174c49e5"/>
+          <a:blip xmlns:r="http://schemas.openxmlformats.org/officeDocument/2006/relationships" xmlns:a="http://schemas.openxmlformats.org/drawingml/2006/main" r:embed="Rf63bc6b030924c7c"/>
           <a:stretch xmlns:a="http://schemas.openxmlformats.org/drawingml/2006/main"/>
         </p:blipFill>
         <p:spPr>
@@ -5613,7 +5613,7 @@
     </p:spTree>
     <p:extLst>
       <p:ext uri="{BB962C8B-B14F-4D97-AF65-F5344CB8AC3E}">
-        <p14:creationId xmlns:p14="http://schemas.microsoft.com/office/powerpoint/2010/main" val="1123007840"/>
+        <p14:creationId xmlns:p14="http://schemas.microsoft.com/office/powerpoint/2010/main" val="682544403"/>
       </p:ext>
     </p:extLst>
   </p:cSld>
@@ -5641,7 +5641,7 @@
           <p:nvPr/>
         </p:nvPicPr>
         <p:blipFill>
-          <a:blip xmlns:r="http://schemas.openxmlformats.org/officeDocument/2006/relationships" xmlns:a="http://schemas.openxmlformats.org/drawingml/2006/main" r:embed="Raa411436e7f6461b"/>
+          <a:blip xmlns:r="http://schemas.openxmlformats.org/officeDocument/2006/relationships" xmlns:a="http://schemas.openxmlformats.org/drawingml/2006/main" r:embed="Rf9408cb8e05e4b14"/>
           <a:stretch xmlns:a="http://schemas.openxmlformats.org/drawingml/2006/main"/>
         </p:blipFill>
         <p:spPr>
@@ -5657,7 +5657,7 @@
     </p:spTree>
     <p:extLst>
       <p:ext uri="{BB962C8B-B14F-4D97-AF65-F5344CB8AC3E}">
-        <p14:creationId xmlns:p14="http://schemas.microsoft.com/office/powerpoint/2010/main" val="1200249309"/>
+        <p14:creationId xmlns:p14="http://schemas.microsoft.com/office/powerpoint/2010/main" val="2061230931"/>
       </p:ext>
     </p:extLst>
   </p:cSld>
@@ -5685,7 +5685,7 @@
           <p:nvPr/>
         </p:nvPicPr>
         <p:blipFill>
-          <a:blip xmlns:r="http://schemas.openxmlformats.org/officeDocument/2006/relationships" xmlns:a="http://schemas.openxmlformats.org/drawingml/2006/main" r:embed="Rf5ada75d2d664960"/>
+          <a:blip xmlns:r="http://schemas.openxmlformats.org/officeDocument/2006/relationships" xmlns:a="http://schemas.openxmlformats.org/drawingml/2006/main" r:embed="Rbc60b343d19d4c72"/>
           <a:stretch xmlns:a="http://schemas.openxmlformats.org/drawingml/2006/main"/>
         </p:blipFill>
         <p:spPr>
@@ -5701,7 +5701,7 @@
     </p:spTree>
     <p:extLst>
       <p:ext uri="{BB962C8B-B14F-4D97-AF65-F5344CB8AC3E}">
-        <p14:creationId xmlns:p14="http://schemas.microsoft.com/office/powerpoint/2010/main" val="528232755"/>
+        <p14:creationId xmlns:p14="http://schemas.microsoft.com/office/powerpoint/2010/main" val="1357109764"/>
       </p:ext>
     </p:extLst>
   </p:cSld>
@@ -5729,7 +5729,7 @@
           <p:nvPr/>
         </p:nvPicPr>
         <p:blipFill>
-          <a:blip xmlns:r="http://schemas.openxmlformats.org/officeDocument/2006/relationships" xmlns:a="http://schemas.openxmlformats.org/drawingml/2006/main" r:embed="Rcebfba481e3c4630"/>
+          <a:blip xmlns:r="http://schemas.openxmlformats.org/officeDocument/2006/relationships" xmlns:a="http://schemas.openxmlformats.org/drawingml/2006/main" r:embed="Rcef6ee5016984816"/>
           <a:stretch xmlns:a="http://schemas.openxmlformats.org/drawingml/2006/main"/>
         </p:blipFill>
         <p:spPr>
@@ -5745,7 +5745,7 @@
     </p:spTree>
     <p:extLst>
       <p:ext uri="{BB962C8B-B14F-4D97-AF65-F5344CB8AC3E}">
-        <p14:creationId xmlns:p14="http://schemas.microsoft.com/office/powerpoint/2010/main" val="1631198808"/>
+        <p14:creationId xmlns:p14="http://schemas.microsoft.com/office/powerpoint/2010/main" val="1656594818"/>
       </p:ext>
     </p:extLst>
   </p:cSld>
@@ -5773,7 +5773,7 @@
           <p:nvPr/>
         </p:nvPicPr>
         <p:blipFill>
-          <a:blip xmlns:r="http://schemas.openxmlformats.org/officeDocument/2006/relationships" xmlns:a="http://schemas.openxmlformats.org/drawingml/2006/main" r:embed="Rd2f0b490e8564d2a"/>
+          <a:blip xmlns:r="http://schemas.openxmlformats.org/officeDocument/2006/relationships" xmlns:a="http://schemas.openxmlformats.org/drawingml/2006/main" r:embed="R586c6564186e4bbc"/>
           <a:stretch xmlns:a="http://schemas.openxmlformats.org/drawingml/2006/main"/>
         </p:blipFill>
         <p:spPr>
@@ -5789,7 +5789,7 @@
     </p:spTree>
     <p:extLst>
       <p:ext uri="{BB962C8B-B14F-4D97-AF65-F5344CB8AC3E}">
-        <p14:creationId xmlns:p14="http://schemas.microsoft.com/office/powerpoint/2010/main" val="1052916662"/>
+        <p14:creationId xmlns:p14="http://schemas.microsoft.com/office/powerpoint/2010/main" val="554863795"/>
       </p:ext>
     </p:extLst>
   </p:cSld>
@@ -5817,7 +5817,7 @@
           <p:nvPr/>
         </p:nvPicPr>
         <p:blipFill>
-          <a:blip xmlns:r="http://schemas.openxmlformats.org/officeDocument/2006/relationships" xmlns:a="http://schemas.openxmlformats.org/drawingml/2006/main" r:embed="Rfdc68a689f254435"/>
+          <a:blip xmlns:r="http://schemas.openxmlformats.org/officeDocument/2006/relationships" xmlns:a="http://schemas.openxmlformats.org/drawingml/2006/main" r:embed="Rd5a2d0ad95cd4086"/>
           <a:stretch xmlns:a="http://schemas.openxmlformats.org/drawingml/2006/main"/>
         </p:blipFill>
         <p:spPr>
@@ -5833,7 +5833,7 @@
     </p:spTree>
     <p:extLst>
       <p:ext uri="{BB962C8B-B14F-4D97-AF65-F5344CB8AC3E}">
-        <p14:creationId xmlns:p14="http://schemas.microsoft.com/office/powerpoint/2010/main" val="611432694"/>
+        <p14:creationId xmlns:p14="http://schemas.microsoft.com/office/powerpoint/2010/main" val="1830005852"/>
       </p:ext>
     </p:extLst>
   </p:cSld>
@@ -5861,7 +5861,7 @@
           <p:nvPr/>
         </p:nvPicPr>
         <p:blipFill>
-          <a:blip xmlns:r="http://schemas.openxmlformats.org/officeDocument/2006/relationships" xmlns:a="http://schemas.openxmlformats.org/drawingml/2006/main" r:embed="R0e6c59792805443a"/>
+          <a:blip xmlns:r="http://schemas.openxmlformats.org/officeDocument/2006/relationships" xmlns:a="http://schemas.openxmlformats.org/drawingml/2006/main" r:embed="Rc10ee9ff0d37410c"/>
           <a:stretch xmlns:a="http://schemas.openxmlformats.org/drawingml/2006/main"/>
         </p:blipFill>
         <p:spPr>
@@ -5877,7 +5877,7 @@
     </p:spTree>
     <p:extLst>
       <p:ext uri="{BB962C8B-B14F-4D97-AF65-F5344CB8AC3E}">
-        <p14:creationId xmlns:p14="http://schemas.microsoft.com/office/powerpoint/2010/main" val="928858971"/>
+        <p14:creationId xmlns:p14="http://schemas.microsoft.com/office/powerpoint/2010/main" val="1618343768"/>
       </p:ext>
     </p:extLst>
   </p:cSld>
@@ -5905,7 +5905,7 @@
           <p:nvPr/>
         </p:nvPicPr>
         <p:blipFill>
-          <a:blip xmlns:r="http://schemas.openxmlformats.org/officeDocument/2006/relationships" xmlns:a="http://schemas.openxmlformats.org/drawingml/2006/main" r:embed="Rfdc7bc30f79f426c"/>
+          <a:blip xmlns:r="http://schemas.openxmlformats.org/officeDocument/2006/relationships" xmlns:a="http://schemas.openxmlformats.org/drawingml/2006/main" r:embed="R02def4e5a54d4259"/>
           <a:stretch xmlns:a="http://schemas.openxmlformats.org/drawingml/2006/main"/>
         </p:blipFill>
         <p:spPr>
@@ -5921,7 +5921,7 @@
     </p:spTree>
     <p:extLst>
       <p:ext uri="{BB962C8B-B14F-4D97-AF65-F5344CB8AC3E}">
-        <p14:creationId xmlns:p14="http://schemas.microsoft.com/office/powerpoint/2010/main" val="18253860"/>
+        <p14:creationId xmlns:p14="http://schemas.microsoft.com/office/powerpoint/2010/main" val="1946876401"/>
       </p:ext>
     </p:extLst>
   </p:cSld>
@@ -5949,7 +5949,7 @@
           <p:nvPr/>
         </p:nvPicPr>
         <p:blipFill>
-          <a:blip xmlns:r="http://schemas.openxmlformats.org/officeDocument/2006/relationships" xmlns:a="http://schemas.openxmlformats.org/drawingml/2006/main" r:embed="Re8a97589736e45c2"/>
+          <a:blip xmlns:r="http://schemas.openxmlformats.org/officeDocument/2006/relationships" xmlns:a="http://schemas.openxmlformats.org/drawingml/2006/main" r:embed="Rcb744d8a0b6847f0"/>
           <a:stretch xmlns:a="http://schemas.openxmlformats.org/drawingml/2006/main"/>
         </p:blipFill>
         <p:spPr>
@@ -5965,7 +5965,7 @@
     </p:spTree>
     <p:extLst>
       <p:ext uri="{BB962C8B-B14F-4D97-AF65-F5344CB8AC3E}">
-        <p14:creationId xmlns:p14="http://schemas.microsoft.com/office/powerpoint/2010/main" val="1968070789"/>
+        <p14:creationId xmlns:p14="http://schemas.microsoft.com/office/powerpoint/2010/main" val="564399211"/>
       </p:ext>
     </p:extLst>
   </p:cSld>
@@ -5993,7 +5993,7 @@
           <p:nvPr/>
         </p:nvPicPr>
         <p:blipFill>
-          <a:blip xmlns:r="http://schemas.openxmlformats.org/officeDocument/2006/relationships" xmlns:a="http://schemas.openxmlformats.org/drawingml/2006/main" r:embed="Rac156a2fac0d42ad"/>
+          <a:blip xmlns:r="http://schemas.openxmlformats.org/officeDocument/2006/relationships" xmlns:a="http://schemas.openxmlformats.org/drawingml/2006/main" r:embed="R13d58500168c4a8a"/>
           <a:stretch xmlns:a="http://schemas.openxmlformats.org/drawingml/2006/main"/>
         </p:blipFill>
         <p:spPr>
@@ -6009,7 +6009,7 @@
     </p:spTree>
     <p:extLst>
       <p:ext uri="{BB962C8B-B14F-4D97-AF65-F5344CB8AC3E}">
-        <p14:creationId xmlns:p14="http://schemas.microsoft.com/office/powerpoint/2010/main" val="985641117"/>
+        <p14:creationId xmlns:p14="http://schemas.microsoft.com/office/powerpoint/2010/main" val="580936685"/>
       </p:ext>
     </p:extLst>
   </p:cSld>

</xml_diff>

<commit_message>
Centre the heading beside the Hasselhoff photograph
</commit_message>
<xml_diff>
--- a/teaching/macro-applications/downloads/lecture_1.pptx
+++ b/teaching/macro-applications/downloads/lecture_1.pptx
@@ -2,39 +2,39 @@
 <file path=ppt/presentation.xml><?xml version="1.0" encoding="utf-8"?>
 <p:presentation xmlns:p="http://schemas.openxmlformats.org/presentationml/2006/main">
   <p:sldMasterIdLst>
-    <p:sldMasterId xmlns:r="http://schemas.openxmlformats.org/officeDocument/2006/relationships" id="2147483648" r:id="R1d5a4c5bda0c431b"/>
+    <p:sldMasterId xmlns:r="http://schemas.openxmlformats.org/officeDocument/2006/relationships" id="2147483648" r:id="R3a12e30eed604e70"/>
   </p:sldMasterIdLst>
   <p:notesMasterIdLst>
-    <p:notesMasterId xmlns:r="http://schemas.openxmlformats.org/officeDocument/2006/relationships" r:id="Rb00ab6de9c5742bf"/>
+    <p:notesMasterId xmlns:r="http://schemas.openxmlformats.org/officeDocument/2006/relationships" r:id="Rddcf4b1c54fa43be"/>
   </p:notesMasterIdLst>
   <p:sldIdLst>
-    <p:sldId xmlns:r="http://schemas.openxmlformats.org/officeDocument/2006/relationships" id="256" r:id="R161e3a0ec30949ad"/>
-    <p:sldId xmlns:r="http://schemas.openxmlformats.org/officeDocument/2006/relationships" id="257" r:id="Ra7ed63610cec4c8e"/>
-    <p:sldId xmlns:r="http://schemas.openxmlformats.org/officeDocument/2006/relationships" id="258" r:id="R410f4d70a84c448f"/>
-    <p:sldId xmlns:r="http://schemas.openxmlformats.org/officeDocument/2006/relationships" id="259" r:id="R1e23e77a99804a4f"/>
-    <p:sldId xmlns:r="http://schemas.openxmlformats.org/officeDocument/2006/relationships" id="260" r:id="Rf05693ba461a43f9"/>
-    <p:sldId xmlns:r="http://schemas.openxmlformats.org/officeDocument/2006/relationships" id="261" r:id="R4f9ba948ca134f0e"/>
-    <p:sldId xmlns:r="http://schemas.openxmlformats.org/officeDocument/2006/relationships" id="262" r:id="Rb495bcd2a1054e97"/>
-    <p:sldId xmlns:r="http://schemas.openxmlformats.org/officeDocument/2006/relationships" id="263" r:id="R94aaf2ee95214f28"/>
-    <p:sldId xmlns:r="http://schemas.openxmlformats.org/officeDocument/2006/relationships" id="264" r:id="R4c5b882ba369488a"/>
-    <p:sldId xmlns:r="http://schemas.openxmlformats.org/officeDocument/2006/relationships" id="265" r:id="R424ab4a5150b42b4"/>
-    <p:sldId xmlns:r="http://schemas.openxmlformats.org/officeDocument/2006/relationships" id="266" r:id="Rd106e9a9f95548da"/>
-    <p:sldId xmlns:r="http://schemas.openxmlformats.org/officeDocument/2006/relationships" id="267" r:id="R4ac576c59064450f"/>
-    <p:sldId xmlns:r="http://schemas.openxmlformats.org/officeDocument/2006/relationships" id="268" r:id="R4a1c39da5d234cbe"/>
-    <p:sldId xmlns:r="http://schemas.openxmlformats.org/officeDocument/2006/relationships" id="269" r:id="R4a88e2203b924641"/>
-    <p:sldId xmlns:r="http://schemas.openxmlformats.org/officeDocument/2006/relationships" id="270" r:id="R5eeb3b3c0f5d4d2b"/>
-    <p:sldId xmlns:r="http://schemas.openxmlformats.org/officeDocument/2006/relationships" id="271" r:id="Ra5c27dcee4c244cc"/>
-    <p:sldId xmlns:r="http://schemas.openxmlformats.org/officeDocument/2006/relationships" id="272" r:id="Rb4d3a342f4944165"/>
-    <p:sldId xmlns:r="http://schemas.openxmlformats.org/officeDocument/2006/relationships" id="273" r:id="Rac49bf133f9a4edc"/>
-    <p:sldId xmlns:r="http://schemas.openxmlformats.org/officeDocument/2006/relationships" id="274" r:id="R99379a7448d94559"/>
-    <p:sldId xmlns:r="http://schemas.openxmlformats.org/officeDocument/2006/relationships" id="275" r:id="Raaad4f93362342c5"/>
-    <p:sldId xmlns:r="http://schemas.openxmlformats.org/officeDocument/2006/relationships" id="276" r:id="Re882ff767cd64dbc"/>
-    <p:sldId xmlns:r="http://schemas.openxmlformats.org/officeDocument/2006/relationships" id="277" r:id="R003e920b57494658"/>
-    <p:sldId xmlns:r="http://schemas.openxmlformats.org/officeDocument/2006/relationships" id="278" r:id="Re4a93e1f31af4226"/>
-    <p:sldId xmlns:r="http://schemas.openxmlformats.org/officeDocument/2006/relationships" id="279" r:id="R293bb0493d09468d"/>
-    <p:sldId xmlns:r="http://schemas.openxmlformats.org/officeDocument/2006/relationships" id="280" r:id="R57d8f7a8c8f94732"/>
-    <p:sldId xmlns:r="http://schemas.openxmlformats.org/officeDocument/2006/relationships" id="281" r:id="R1a3a103ee4054da9"/>
-    <p:sldId xmlns:r="http://schemas.openxmlformats.org/officeDocument/2006/relationships" id="282" r:id="Ra1f758e547ce4327"/>
+    <p:sldId xmlns:r="http://schemas.openxmlformats.org/officeDocument/2006/relationships" id="256" r:id="Ra4f982ed6ac044bf"/>
+    <p:sldId xmlns:r="http://schemas.openxmlformats.org/officeDocument/2006/relationships" id="257" r:id="Reb2c1eee711e40c8"/>
+    <p:sldId xmlns:r="http://schemas.openxmlformats.org/officeDocument/2006/relationships" id="258" r:id="R3bd44938682c4377"/>
+    <p:sldId xmlns:r="http://schemas.openxmlformats.org/officeDocument/2006/relationships" id="259" r:id="Raa7b01afaafe4409"/>
+    <p:sldId xmlns:r="http://schemas.openxmlformats.org/officeDocument/2006/relationships" id="260" r:id="Rccb3fd3398ef4344"/>
+    <p:sldId xmlns:r="http://schemas.openxmlformats.org/officeDocument/2006/relationships" id="261" r:id="Rbf5441d68a2e4051"/>
+    <p:sldId xmlns:r="http://schemas.openxmlformats.org/officeDocument/2006/relationships" id="262" r:id="R415f31c13ad144db"/>
+    <p:sldId xmlns:r="http://schemas.openxmlformats.org/officeDocument/2006/relationships" id="263" r:id="Rce63c91d13224e92"/>
+    <p:sldId xmlns:r="http://schemas.openxmlformats.org/officeDocument/2006/relationships" id="264" r:id="R36bf10df14c34fd9"/>
+    <p:sldId xmlns:r="http://schemas.openxmlformats.org/officeDocument/2006/relationships" id="265" r:id="R27534808fe6a4702"/>
+    <p:sldId xmlns:r="http://schemas.openxmlformats.org/officeDocument/2006/relationships" id="266" r:id="R1aaf8b9d8ee1409f"/>
+    <p:sldId xmlns:r="http://schemas.openxmlformats.org/officeDocument/2006/relationships" id="267" r:id="R720ba65a5d9f4dab"/>
+    <p:sldId xmlns:r="http://schemas.openxmlformats.org/officeDocument/2006/relationships" id="268" r:id="R5d3bf47fb84c4d43"/>
+    <p:sldId xmlns:r="http://schemas.openxmlformats.org/officeDocument/2006/relationships" id="269" r:id="R36ea238e6b3544e8"/>
+    <p:sldId xmlns:r="http://schemas.openxmlformats.org/officeDocument/2006/relationships" id="270" r:id="Rb8ee96ce2b0341b0"/>
+    <p:sldId xmlns:r="http://schemas.openxmlformats.org/officeDocument/2006/relationships" id="271" r:id="R9513e01fe10446bc"/>
+    <p:sldId xmlns:r="http://schemas.openxmlformats.org/officeDocument/2006/relationships" id="272" r:id="R9c7dae8df83e498b"/>
+    <p:sldId xmlns:r="http://schemas.openxmlformats.org/officeDocument/2006/relationships" id="273" r:id="R9ce63fc85fc140b1"/>
+    <p:sldId xmlns:r="http://schemas.openxmlformats.org/officeDocument/2006/relationships" id="274" r:id="R0ca74f4cebc244ab"/>
+    <p:sldId xmlns:r="http://schemas.openxmlformats.org/officeDocument/2006/relationships" id="275" r:id="Re2971669329b42fc"/>
+    <p:sldId xmlns:r="http://schemas.openxmlformats.org/officeDocument/2006/relationships" id="276" r:id="R2c557def419545eb"/>
+    <p:sldId xmlns:r="http://schemas.openxmlformats.org/officeDocument/2006/relationships" id="277" r:id="R744e2fa33e574045"/>
+    <p:sldId xmlns:r="http://schemas.openxmlformats.org/officeDocument/2006/relationships" id="278" r:id="Raa65f5449ab94068"/>
+    <p:sldId xmlns:r="http://schemas.openxmlformats.org/officeDocument/2006/relationships" id="279" r:id="R8955cb6d7bea4ee0"/>
+    <p:sldId xmlns:r="http://schemas.openxmlformats.org/officeDocument/2006/relationships" id="280" r:id="Ra2e551576c6a462f"/>
+    <p:sldId xmlns:r="http://schemas.openxmlformats.org/officeDocument/2006/relationships" id="281" r:id="R4336ce5b86a94c1f"/>
+    <p:sldId xmlns:r="http://schemas.openxmlformats.org/officeDocument/2006/relationships" id="282" r:id="R15d7b257b9d441f2"/>
   </p:sldIdLst>
   <p:sldSz cx="12192000" cy="6858000"/>
   <p:notesSz cx="6858000" cy="9144000"/>
@@ -4301,7 +4301,7 @@
   </p:cSld>
   <p:clrMap bg1="lt1" tx1="dk1" bg2="lt2" tx2="dk2" accent1="accent1" accent2="accent2" accent3="accent3" accent4="accent4" accent5="accent5" accent6="accent6" hlink="hlink" folHlink="folHlink"/>
   <p:sldLayoutIdLst>
-    <p:sldLayoutId xmlns:r="http://schemas.openxmlformats.org/officeDocument/2006/relationships" id="2147483649" r:id="R3ab3ba43e7b84ed4"/>
+    <p:sldLayoutId xmlns:r="http://schemas.openxmlformats.org/officeDocument/2006/relationships" id="2147483649" r:id="Rf2de4c0ac8f3456d"/>
   </p:sldLayoutIdLst>
   <p:txStyles>
     <p:titleStyle>
@@ -4849,7 +4849,7 @@
           <p:nvPr/>
         </p:nvPicPr>
         <p:blipFill>
-          <a:blip xmlns:r="http://schemas.openxmlformats.org/officeDocument/2006/relationships" xmlns:a="http://schemas.openxmlformats.org/drawingml/2006/main" r:embed="R0ddc63ecf02e44eb"/>
+          <a:blip xmlns:r="http://schemas.openxmlformats.org/officeDocument/2006/relationships" xmlns:a="http://schemas.openxmlformats.org/drawingml/2006/main" r:embed="R93a386808c874202"/>
           <a:stretch xmlns:a="http://schemas.openxmlformats.org/drawingml/2006/main"/>
         </p:blipFill>
         <p:spPr>
@@ -4865,7 +4865,7 @@
     </p:spTree>
     <p:extLst>
       <p:ext uri="{BB962C8B-B14F-4D97-AF65-F5344CB8AC3E}">
-        <p14:creationId xmlns:p14="http://schemas.microsoft.com/office/powerpoint/2010/main" val="956591022"/>
+        <p14:creationId xmlns:p14="http://schemas.microsoft.com/office/powerpoint/2010/main" val="768967557"/>
       </p:ext>
     </p:extLst>
   </p:cSld>
@@ -4893,7 +4893,7 @@
           <p:nvPr/>
         </p:nvPicPr>
         <p:blipFill>
-          <a:blip xmlns:r="http://schemas.openxmlformats.org/officeDocument/2006/relationships" xmlns:a="http://schemas.openxmlformats.org/drawingml/2006/main" r:embed="Ree7856a205634919"/>
+          <a:blip xmlns:r="http://schemas.openxmlformats.org/officeDocument/2006/relationships" xmlns:a="http://schemas.openxmlformats.org/drawingml/2006/main" r:embed="R2028ee3ac7fd47f1"/>
           <a:stretch xmlns:a="http://schemas.openxmlformats.org/drawingml/2006/main"/>
         </p:blipFill>
         <p:spPr>
@@ -4909,7 +4909,7 @@
     </p:spTree>
     <p:extLst>
       <p:ext uri="{BB962C8B-B14F-4D97-AF65-F5344CB8AC3E}">
-        <p14:creationId xmlns:p14="http://schemas.microsoft.com/office/powerpoint/2010/main" val="2034767347"/>
+        <p14:creationId xmlns:p14="http://schemas.microsoft.com/office/powerpoint/2010/main" val="2106287433"/>
       </p:ext>
     </p:extLst>
   </p:cSld>
@@ -4937,7 +4937,7 @@
           <p:nvPr/>
         </p:nvPicPr>
         <p:blipFill>
-          <a:blip xmlns:r="http://schemas.openxmlformats.org/officeDocument/2006/relationships" xmlns:a="http://schemas.openxmlformats.org/drawingml/2006/main" r:embed="R60b216fb72954010"/>
+          <a:blip xmlns:r="http://schemas.openxmlformats.org/officeDocument/2006/relationships" xmlns:a="http://schemas.openxmlformats.org/drawingml/2006/main" r:embed="R690cc37fe6894df6"/>
           <a:stretch xmlns:a="http://schemas.openxmlformats.org/drawingml/2006/main"/>
         </p:blipFill>
         <p:spPr>
@@ -4953,7 +4953,7 @@
     </p:spTree>
     <p:extLst>
       <p:ext uri="{BB962C8B-B14F-4D97-AF65-F5344CB8AC3E}">
-        <p14:creationId xmlns:p14="http://schemas.microsoft.com/office/powerpoint/2010/main" val="1249804834"/>
+        <p14:creationId xmlns:p14="http://schemas.microsoft.com/office/powerpoint/2010/main" val="763083665"/>
       </p:ext>
     </p:extLst>
   </p:cSld>
@@ -4981,7 +4981,7 @@
           <p:nvPr/>
         </p:nvPicPr>
         <p:blipFill>
-          <a:blip xmlns:r="http://schemas.openxmlformats.org/officeDocument/2006/relationships" xmlns:a="http://schemas.openxmlformats.org/drawingml/2006/main" r:embed="Rdc15c4ad5c2d439f"/>
+          <a:blip xmlns:r="http://schemas.openxmlformats.org/officeDocument/2006/relationships" xmlns:a="http://schemas.openxmlformats.org/drawingml/2006/main" r:embed="Red923f01a67e4889"/>
           <a:stretch xmlns:a="http://schemas.openxmlformats.org/drawingml/2006/main"/>
         </p:blipFill>
         <p:spPr>
@@ -4997,7 +4997,7 @@
     </p:spTree>
     <p:extLst>
       <p:ext uri="{BB962C8B-B14F-4D97-AF65-F5344CB8AC3E}">
-        <p14:creationId xmlns:p14="http://schemas.microsoft.com/office/powerpoint/2010/main" val="1740008360"/>
+        <p14:creationId xmlns:p14="http://schemas.microsoft.com/office/powerpoint/2010/main" val="4564897"/>
       </p:ext>
     </p:extLst>
   </p:cSld>
@@ -5025,7 +5025,7 @@
           <p:nvPr/>
         </p:nvPicPr>
         <p:blipFill>
-          <a:blip xmlns:r="http://schemas.openxmlformats.org/officeDocument/2006/relationships" xmlns:a="http://schemas.openxmlformats.org/drawingml/2006/main" r:embed="R31a488cc9b6345be"/>
+          <a:blip xmlns:r="http://schemas.openxmlformats.org/officeDocument/2006/relationships" xmlns:a="http://schemas.openxmlformats.org/drawingml/2006/main" r:embed="Rc71f671f09b54098"/>
           <a:stretch xmlns:a="http://schemas.openxmlformats.org/drawingml/2006/main"/>
         </p:blipFill>
         <p:spPr>
@@ -5041,7 +5041,7 @@
     </p:spTree>
     <p:extLst>
       <p:ext uri="{BB962C8B-B14F-4D97-AF65-F5344CB8AC3E}">
-        <p14:creationId xmlns:p14="http://schemas.microsoft.com/office/powerpoint/2010/main" val="1225855945"/>
+        <p14:creationId xmlns:p14="http://schemas.microsoft.com/office/powerpoint/2010/main" val="1526855147"/>
       </p:ext>
     </p:extLst>
   </p:cSld>
@@ -5069,7 +5069,7 @@
           <p:nvPr/>
         </p:nvPicPr>
         <p:blipFill>
-          <a:blip xmlns:r="http://schemas.openxmlformats.org/officeDocument/2006/relationships" xmlns:a="http://schemas.openxmlformats.org/drawingml/2006/main" r:embed="R02599276e1ef4c5f"/>
+          <a:blip xmlns:r="http://schemas.openxmlformats.org/officeDocument/2006/relationships" xmlns:a="http://schemas.openxmlformats.org/drawingml/2006/main" r:embed="Rf41568baea9c47d9"/>
           <a:stretch xmlns:a="http://schemas.openxmlformats.org/drawingml/2006/main"/>
         </p:blipFill>
         <p:spPr>
@@ -5085,7 +5085,7 @@
     </p:spTree>
     <p:extLst>
       <p:ext uri="{BB962C8B-B14F-4D97-AF65-F5344CB8AC3E}">
-        <p14:creationId xmlns:p14="http://schemas.microsoft.com/office/powerpoint/2010/main" val="236235841"/>
+        <p14:creationId xmlns:p14="http://schemas.microsoft.com/office/powerpoint/2010/main" val="1631629683"/>
       </p:ext>
     </p:extLst>
   </p:cSld>
@@ -5113,7 +5113,7 @@
           <p:nvPr/>
         </p:nvPicPr>
         <p:blipFill>
-          <a:blip xmlns:r="http://schemas.openxmlformats.org/officeDocument/2006/relationships" xmlns:a="http://schemas.openxmlformats.org/drawingml/2006/main" r:embed="R775fe97cc43f4bbb"/>
+          <a:blip xmlns:r="http://schemas.openxmlformats.org/officeDocument/2006/relationships" xmlns:a="http://schemas.openxmlformats.org/drawingml/2006/main" r:embed="Rf77782b366244b5b"/>
           <a:stretch xmlns:a="http://schemas.openxmlformats.org/drawingml/2006/main"/>
         </p:blipFill>
         <p:spPr>
@@ -5129,7 +5129,7 @@
     </p:spTree>
     <p:extLst>
       <p:ext uri="{BB962C8B-B14F-4D97-AF65-F5344CB8AC3E}">
-        <p14:creationId xmlns:p14="http://schemas.microsoft.com/office/powerpoint/2010/main" val="1529324599"/>
+        <p14:creationId xmlns:p14="http://schemas.microsoft.com/office/powerpoint/2010/main" val="189847138"/>
       </p:ext>
     </p:extLst>
   </p:cSld>
@@ -5157,7 +5157,7 @@
           <p:nvPr/>
         </p:nvPicPr>
         <p:blipFill>
-          <a:blip xmlns:r="http://schemas.openxmlformats.org/officeDocument/2006/relationships" xmlns:a="http://schemas.openxmlformats.org/drawingml/2006/main" r:embed="R380f0be520fd4037"/>
+          <a:blip xmlns:r="http://schemas.openxmlformats.org/officeDocument/2006/relationships" xmlns:a="http://schemas.openxmlformats.org/drawingml/2006/main" r:embed="R8beb7914471d41d0"/>
           <a:stretch xmlns:a="http://schemas.openxmlformats.org/drawingml/2006/main"/>
         </p:blipFill>
         <p:spPr>
@@ -5173,7 +5173,7 @@
     </p:spTree>
     <p:extLst>
       <p:ext uri="{BB962C8B-B14F-4D97-AF65-F5344CB8AC3E}">
-        <p14:creationId xmlns:p14="http://schemas.microsoft.com/office/powerpoint/2010/main" val="254461078"/>
+        <p14:creationId xmlns:p14="http://schemas.microsoft.com/office/powerpoint/2010/main" val="878402552"/>
       </p:ext>
     </p:extLst>
   </p:cSld>
@@ -5201,7 +5201,7 @@
           <p:nvPr/>
         </p:nvPicPr>
         <p:blipFill>
-          <a:blip xmlns:r="http://schemas.openxmlformats.org/officeDocument/2006/relationships" xmlns:a="http://schemas.openxmlformats.org/drawingml/2006/main" r:embed="R3538a5d86db54ab5"/>
+          <a:blip xmlns:r="http://schemas.openxmlformats.org/officeDocument/2006/relationships" xmlns:a="http://schemas.openxmlformats.org/drawingml/2006/main" r:embed="R8869a38084d04c2d"/>
           <a:stretch xmlns:a="http://schemas.openxmlformats.org/drawingml/2006/main"/>
         </p:blipFill>
         <p:spPr>
@@ -5217,7 +5217,7 @@
     </p:spTree>
     <p:extLst>
       <p:ext uri="{BB962C8B-B14F-4D97-AF65-F5344CB8AC3E}">
-        <p14:creationId xmlns:p14="http://schemas.microsoft.com/office/powerpoint/2010/main" val="938502960"/>
+        <p14:creationId xmlns:p14="http://schemas.microsoft.com/office/powerpoint/2010/main" val="348383378"/>
       </p:ext>
     </p:extLst>
   </p:cSld>
@@ -5245,7 +5245,7 @@
           <p:nvPr/>
         </p:nvPicPr>
         <p:blipFill>
-          <a:blip xmlns:r="http://schemas.openxmlformats.org/officeDocument/2006/relationships" xmlns:a="http://schemas.openxmlformats.org/drawingml/2006/main" r:embed="R9015cba60230458b"/>
+          <a:blip xmlns:r="http://schemas.openxmlformats.org/officeDocument/2006/relationships" xmlns:a="http://schemas.openxmlformats.org/drawingml/2006/main" r:embed="R62554359054340de"/>
           <a:stretch xmlns:a="http://schemas.openxmlformats.org/drawingml/2006/main"/>
         </p:blipFill>
         <p:spPr>
@@ -5261,7 +5261,7 @@
     </p:spTree>
     <p:extLst>
       <p:ext uri="{BB962C8B-B14F-4D97-AF65-F5344CB8AC3E}">
-        <p14:creationId xmlns:p14="http://schemas.microsoft.com/office/powerpoint/2010/main" val="657048383"/>
+        <p14:creationId xmlns:p14="http://schemas.microsoft.com/office/powerpoint/2010/main" val="1773440913"/>
       </p:ext>
     </p:extLst>
   </p:cSld>
@@ -5289,7 +5289,7 @@
           <p:nvPr/>
         </p:nvPicPr>
         <p:blipFill>
-          <a:blip xmlns:r="http://schemas.openxmlformats.org/officeDocument/2006/relationships" xmlns:a="http://schemas.openxmlformats.org/drawingml/2006/main" r:embed="R7f5d3302ae824377"/>
+          <a:blip xmlns:r="http://schemas.openxmlformats.org/officeDocument/2006/relationships" xmlns:a="http://schemas.openxmlformats.org/drawingml/2006/main" r:embed="R197ea481dd5b4055"/>
           <a:stretch xmlns:a="http://schemas.openxmlformats.org/drawingml/2006/main"/>
         </p:blipFill>
         <p:spPr>
@@ -5305,7 +5305,7 @@
     </p:spTree>
     <p:extLst>
       <p:ext uri="{BB962C8B-B14F-4D97-AF65-F5344CB8AC3E}">
-        <p14:creationId xmlns:p14="http://schemas.microsoft.com/office/powerpoint/2010/main" val="1642115809"/>
+        <p14:creationId xmlns:p14="http://schemas.microsoft.com/office/powerpoint/2010/main" val="544444089"/>
       </p:ext>
     </p:extLst>
   </p:cSld>
@@ -5333,7 +5333,7 @@
           <p:nvPr/>
         </p:nvPicPr>
         <p:blipFill>
-          <a:blip xmlns:r="http://schemas.openxmlformats.org/officeDocument/2006/relationships" xmlns:a="http://schemas.openxmlformats.org/drawingml/2006/main" r:embed="R4523768829a441e1"/>
+          <a:blip xmlns:r="http://schemas.openxmlformats.org/officeDocument/2006/relationships" xmlns:a="http://schemas.openxmlformats.org/drawingml/2006/main" r:embed="R440b1d4384d345e5"/>
           <a:stretch xmlns:a="http://schemas.openxmlformats.org/drawingml/2006/main"/>
         </p:blipFill>
         <p:spPr>
@@ -5349,7 +5349,7 @@
     </p:spTree>
     <p:extLst>
       <p:ext uri="{BB962C8B-B14F-4D97-AF65-F5344CB8AC3E}">
-        <p14:creationId xmlns:p14="http://schemas.microsoft.com/office/powerpoint/2010/main" val="438118554"/>
+        <p14:creationId xmlns:p14="http://schemas.microsoft.com/office/powerpoint/2010/main" val="344106528"/>
       </p:ext>
     </p:extLst>
   </p:cSld>
@@ -5377,7 +5377,7 @@
           <p:nvPr/>
         </p:nvPicPr>
         <p:blipFill>
-          <a:blip xmlns:r="http://schemas.openxmlformats.org/officeDocument/2006/relationships" xmlns:a="http://schemas.openxmlformats.org/drawingml/2006/main" r:embed="R138bdff6ecea4a69"/>
+          <a:blip xmlns:r="http://schemas.openxmlformats.org/officeDocument/2006/relationships" xmlns:a="http://schemas.openxmlformats.org/drawingml/2006/main" r:embed="Ref09b451adb94707"/>
           <a:stretch xmlns:a="http://schemas.openxmlformats.org/drawingml/2006/main"/>
         </p:blipFill>
         <p:spPr>
@@ -5393,7 +5393,7 @@
     </p:spTree>
     <p:extLst>
       <p:ext uri="{BB962C8B-B14F-4D97-AF65-F5344CB8AC3E}">
-        <p14:creationId xmlns:p14="http://schemas.microsoft.com/office/powerpoint/2010/main" val="676884188"/>
+        <p14:creationId xmlns:p14="http://schemas.microsoft.com/office/powerpoint/2010/main" val="1833910088"/>
       </p:ext>
     </p:extLst>
   </p:cSld>
@@ -5421,7 +5421,7 @@
           <p:nvPr/>
         </p:nvPicPr>
         <p:blipFill>
-          <a:blip xmlns:r="http://schemas.openxmlformats.org/officeDocument/2006/relationships" xmlns:a="http://schemas.openxmlformats.org/drawingml/2006/main" r:embed="Ra16ce1060ffc47b9"/>
+          <a:blip xmlns:r="http://schemas.openxmlformats.org/officeDocument/2006/relationships" xmlns:a="http://schemas.openxmlformats.org/drawingml/2006/main" r:embed="R0d8e71dc7b0d49ac"/>
           <a:stretch xmlns:a="http://schemas.openxmlformats.org/drawingml/2006/main"/>
         </p:blipFill>
         <p:spPr>
@@ -5437,7 +5437,7 @@
     </p:spTree>
     <p:extLst>
       <p:ext uri="{BB962C8B-B14F-4D97-AF65-F5344CB8AC3E}">
-        <p14:creationId xmlns:p14="http://schemas.microsoft.com/office/powerpoint/2010/main" val="226779528"/>
+        <p14:creationId xmlns:p14="http://schemas.microsoft.com/office/powerpoint/2010/main" val="179134607"/>
       </p:ext>
     </p:extLst>
   </p:cSld>
@@ -5465,7 +5465,7 @@
           <p:nvPr/>
         </p:nvPicPr>
         <p:blipFill>
-          <a:blip xmlns:r="http://schemas.openxmlformats.org/officeDocument/2006/relationships" xmlns:a="http://schemas.openxmlformats.org/drawingml/2006/main" r:embed="R9eb603471c1e41c5"/>
+          <a:blip xmlns:r="http://schemas.openxmlformats.org/officeDocument/2006/relationships" xmlns:a="http://schemas.openxmlformats.org/drawingml/2006/main" r:embed="R44b809c96f8e474f"/>
           <a:stretch xmlns:a="http://schemas.openxmlformats.org/drawingml/2006/main"/>
         </p:blipFill>
         <p:spPr>
@@ -5481,7 +5481,7 @@
     </p:spTree>
     <p:extLst>
       <p:ext uri="{BB962C8B-B14F-4D97-AF65-F5344CB8AC3E}">
-        <p14:creationId xmlns:p14="http://schemas.microsoft.com/office/powerpoint/2010/main" val="1765964440"/>
+        <p14:creationId xmlns:p14="http://schemas.microsoft.com/office/powerpoint/2010/main" val="2044911675"/>
       </p:ext>
     </p:extLst>
   </p:cSld>
@@ -5509,7 +5509,7 @@
           <p:nvPr/>
         </p:nvPicPr>
         <p:blipFill>
-          <a:blip xmlns:r="http://schemas.openxmlformats.org/officeDocument/2006/relationships" xmlns:a="http://schemas.openxmlformats.org/drawingml/2006/main" r:embed="Rf43f04cf41de4a4a"/>
+          <a:blip xmlns:r="http://schemas.openxmlformats.org/officeDocument/2006/relationships" xmlns:a="http://schemas.openxmlformats.org/drawingml/2006/main" r:embed="R07e532ddf58c4943"/>
           <a:stretch xmlns:a="http://schemas.openxmlformats.org/drawingml/2006/main"/>
         </p:blipFill>
         <p:spPr>
@@ -5525,7 +5525,7 @@
     </p:spTree>
     <p:extLst>
       <p:ext uri="{BB962C8B-B14F-4D97-AF65-F5344CB8AC3E}">
-        <p14:creationId xmlns:p14="http://schemas.microsoft.com/office/powerpoint/2010/main" val="1498047098"/>
+        <p14:creationId xmlns:p14="http://schemas.microsoft.com/office/powerpoint/2010/main" val="1565744219"/>
       </p:ext>
     </p:extLst>
   </p:cSld>
@@ -5553,7 +5553,7 @@
           <p:nvPr/>
         </p:nvPicPr>
         <p:blipFill>
-          <a:blip xmlns:r="http://schemas.openxmlformats.org/officeDocument/2006/relationships" xmlns:a="http://schemas.openxmlformats.org/drawingml/2006/main" r:embed="R5335025379b547b2"/>
+          <a:blip xmlns:r="http://schemas.openxmlformats.org/officeDocument/2006/relationships" xmlns:a="http://schemas.openxmlformats.org/drawingml/2006/main" r:embed="R1bc8e1c26d2c4995"/>
           <a:stretch xmlns:a="http://schemas.openxmlformats.org/drawingml/2006/main"/>
         </p:blipFill>
         <p:spPr>
@@ -5569,7 +5569,7 @@
     </p:spTree>
     <p:extLst>
       <p:ext uri="{BB962C8B-B14F-4D97-AF65-F5344CB8AC3E}">
-        <p14:creationId xmlns:p14="http://schemas.microsoft.com/office/powerpoint/2010/main" val="2019384463"/>
+        <p14:creationId xmlns:p14="http://schemas.microsoft.com/office/powerpoint/2010/main" val="776316693"/>
       </p:ext>
     </p:extLst>
   </p:cSld>
@@ -5597,7 +5597,7 @@
           <p:nvPr/>
         </p:nvPicPr>
         <p:blipFill>
-          <a:blip xmlns:r="http://schemas.openxmlformats.org/officeDocument/2006/relationships" xmlns:a="http://schemas.openxmlformats.org/drawingml/2006/main" r:embed="Rf63bc6b030924c7c"/>
+          <a:blip xmlns:r="http://schemas.openxmlformats.org/officeDocument/2006/relationships" xmlns:a="http://schemas.openxmlformats.org/drawingml/2006/main" r:embed="Re1478363513d4df2"/>
           <a:stretch xmlns:a="http://schemas.openxmlformats.org/drawingml/2006/main"/>
         </p:blipFill>
         <p:spPr>
@@ -5613,7 +5613,7 @@
     </p:spTree>
     <p:extLst>
       <p:ext uri="{BB962C8B-B14F-4D97-AF65-F5344CB8AC3E}">
-        <p14:creationId xmlns:p14="http://schemas.microsoft.com/office/powerpoint/2010/main" val="682544403"/>
+        <p14:creationId xmlns:p14="http://schemas.microsoft.com/office/powerpoint/2010/main" val="1955858446"/>
       </p:ext>
     </p:extLst>
   </p:cSld>
@@ -5641,7 +5641,7 @@
           <p:nvPr/>
         </p:nvPicPr>
         <p:blipFill>
-          <a:blip xmlns:r="http://schemas.openxmlformats.org/officeDocument/2006/relationships" xmlns:a="http://schemas.openxmlformats.org/drawingml/2006/main" r:embed="Rf9408cb8e05e4b14"/>
+          <a:blip xmlns:r="http://schemas.openxmlformats.org/officeDocument/2006/relationships" xmlns:a="http://schemas.openxmlformats.org/drawingml/2006/main" r:embed="R820119bbc4af4ecd"/>
           <a:stretch xmlns:a="http://schemas.openxmlformats.org/drawingml/2006/main"/>
         </p:blipFill>
         <p:spPr>
@@ -5657,7 +5657,7 @@
     </p:spTree>
     <p:extLst>
       <p:ext uri="{BB962C8B-B14F-4D97-AF65-F5344CB8AC3E}">
-        <p14:creationId xmlns:p14="http://schemas.microsoft.com/office/powerpoint/2010/main" val="2061230931"/>
+        <p14:creationId xmlns:p14="http://schemas.microsoft.com/office/powerpoint/2010/main" val="1923677008"/>
       </p:ext>
     </p:extLst>
   </p:cSld>
@@ -5685,7 +5685,7 @@
           <p:nvPr/>
         </p:nvPicPr>
         <p:blipFill>
-          <a:blip xmlns:r="http://schemas.openxmlformats.org/officeDocument/2006/relationships" xmlns:a="http://schemas.openxmlformats.org/drawingml/2006/main" r:embed="Rbc60b343d19d4c72"/>
+          <a:blip xmlns:r="http://schemas.openxmlformats.org/officeDocument/2006/relationships" xmlns:a="http://schemas.openxmlformats.org/drawingml/2006/main" r:embed="Rccdbff287a6d4a63"/>
           <a:stretch xmlns:a="http://schemas.openxmlformats.org/drawingml/2006/main"/>
         </p:blipFill>
         <p:spPr>
@@ -5701,7 +5701,7 @@
     </p:spTree>
     <p:extLst>
       <p:ext uri="{BB962C8B-B14F-4D97-AF65-F5344CB8AC3E}">
-        <p14:creationId xmlns:p14="http://schemas.microsoft.com/office/powerpoint/2010/main" val="1357109764"/>
+        <p14:creationId xmlns:p14="http://schemas.microsoft.com/office/powerpoint/2010/main" val="1172310919"/>
       </p:ext>
     </p:extLst>
   </p:cSld>
@@ -5729,7 +5729,7 @@
           <p:nvPr/>
         </p:nvPicPr>
         <p:blipFill>
-          <a:blip xmlns:r="http://schemas.openxmlformats.org/officeDocument/2006/relationships" xmlns:a="http://schemas.openxmlformats.org/drawingml/2006/main" r:embed="Rcef6ee5016984816"/>
+          <a:blip xmlns:r="http://schemas.openxmlformats.org/officeDocument/2006/relationships" xmlns:a="http://schemas.openxmlformats.org/drawingml/2006/main" r:embed="R208e5dcea8cd42da"/>
           <a:stretch xmlns:a="http://schemas.openxmlformats.org/drawingml/2006/main"/>
         </p:blipFill>
         <p:spPr>
@@ -5745,7 +5745,7 @@
     </p:spTree>
     <p:extLst>
       <p:ext uri="{BB962C8B-B14F-4D97-AF65-F5344CB8AC3E}">
-        <p14:creationId xmlns:p14="http://schemas.microsoft.com/office/powerpoint/2010/main" val="1656594818"/>
+        <p14:creationId xmlns:p14="http://schemas.microsoft.com/office/powerpoint/2010/main" val="2126031502"/>
       </p:ext>
     </p:extLst>
   </p:cSld>
@@ -5773,7 +5773,7 @@
           <p:nvPr/>
         </p:nvPicPr>
         <p:blipFill>
-          <a:blip xmlns:r="http://schemas.openxmlformats.org/officeDocument/2006/relationships" xmlns:a="http://schemas.openxmlformats.org/drawingml/2006/main" r:embed="R586c6564186e4bbc"/>
+          <a:blip xmlns:r="http://schemas.openxmlformats.org/officeDocument/2006/relationships" xmlns:a="http://schemas.openxmlformats.org/drawingml/2006/main" r:embed="Rf6f55cf506284a31"/>
           <a:stretch xmlns:a="http://schemas.openxmlformats.org/drawingml/2006/main"/>
         </p:blipFill>
         <p:spPr>
@@ -5789,7 +5789,7 @@
     </p:spTree>
     <p:extLst>
       <p:ext uri="{BB962C8B-B14F-4D97-AF65-F5344CB8AC3E}">
-        <p14:creationId xmlns:p14="http://schemas.microsoft.com/office/powerpoint/2010/main" val="554863795"/>
+        <p14:creationId xmlns:p14="http://schemas.microsoft.com/office/powerpoint/2010/main" val="1899503157"/>
       </p:ext>
     </p:extLst>
   </p:cSld>
@@ -5817,7 +5817,7 @@
           <p:nvPr/>
         </p:nvPicPr>
         <p:blipFill>
-          <a:blip xmlns:r="http://schemas.openxmlformats.org/officeDocument/2006/relationships" xmlns:a="http://schemas.openxmlformats.org/drawingml/2006/main" r:embed="Rd5a2d0ad95cd4086"/>
+          <a:blip xmlns:r="http://schemas.openxmlformats.org/officeDocument/2006/relationships" xmlns:a="http://schemas.openxmlformats.org/drawingml/2006/main" r:embed="Rb1c963625d664060"/>
           <a:stretch xmlns:a="http://schemas.openxmlformats.org/drawingml/2006/main"/>
         </p:blipFill>
         <p:spPr>
@@ -5833,7 +5833,7 @@
     </p:spTree>
     <p:extLst>
       <p:ext uri="{BB962C8B-B14F-4D97-AF65-F5344CB8AC3E}">
-        <p14:creationId xmlns:p14="http://schemas.microsoft.com/office/powerpoint/2010/main" val="1830005852"/>
+        <p14:creationId xmlns:p14="http://schemas.microsoft.com/office/powerpoint/2010/main" val="1770110411"/>
       </p:ext>
     </p:extLst>
   </p:cSld>
@@ -5861,7 +5861,7 @@
           <p:nvPr/>
         </p:nvPicPr>
         <p:blipFill>
-          <a:blip xmlns:r="http://schemas.openxmlformats.org/officeDocument/2006/relationships" xmlns:a="http://schemas.openxmlformats.org/drawingml/2006/main" r:embed="Rc10ee9ff0d37410c"/>
+          <a:blip xmlns:r="http://schemas.openxmlformats.org/officeDocument/2006/relationships" xmlns:a="http://schemas.openxmlformats.org/drawingml/2006/main" r:embed="R776dd8a9684f4825"/>
           <a:stretch xmlns:a="http://schemas.openxmlformats.org/drawingml/2006/main"/>
         </p:blipFill>
         <p:spPr>
@@ -5877,7 +5877,7 @@
     </p:spTree>
     <p:extLst>
       <p:ext uri="{BB962C8B-B14F-4D97-AF65-F5344CB8AC3E}">
-        <p14:creationId xmlns:p14="http://schemas.microsoft.com/office/powerpoint/2010/main" val="1618343768"/>
+        <p14:creationId xmlns:p14="http://schemas.microsoft.com/office/powerpoint/2010/main" val="353345051"/>
       </p:ext>
     </p:extLst>
   </p:cSld>
@@ -5905,7 +5905,7 @@
           <p:nvPr/>
         </p:nvPicPr>
         <p:blipFill>
-          <a:blip xmlns:r="http://schemas.openxmlformats.org/officeDocument/2006/relationships" xmlns:a="http://schemas.openxmlformats.org/drawingml/2006/main" r:embed="R02def4e5a54d4259"/>
+          <a:blip xmlns:r="http://schemas.openxmlformats.org/officeDocument/2006/relationships" xmlns:a="http://schemas.openxmlformats.org/drawingml/2006/main" r:embed="R95bdaf62b1a84ac3"/>
           <a:stretch xmlns:a="http://schemas.openxmlformats.org/drawingml/2006/main"/>
         </p:blipFill>
         <p:spPr>
@@ -5921,7 +5921,7 @@
     </p:spTree>
     <p:extLst>
       <p:ext uri="{BB962C8B-B14F-4D97-AF65-F5344CB8AC3E}">
-        <p14:creationId xmlns:p14="http://schemas.microsoft.com/office/powerpoint/2010/main" val="1946876401"/>
+        <p14:creationId xmlns:p14="http://schemas.microsoft.com/office/powerpoint/2010/main" val="1959441423"/>
       </p:ext>
     </p:extLst>
   </p:cSld>
@@ -5949,7 +5949,7 @@
           <p:nvPr/>
         </p:nvPicPr>
         <p:blipFill>
-          <a:blip xmlns:r="http://schemas.openxmlformats.org/officeDocument/2006/relationships" xmlns:a="http://schemas.openxmlformats.org/drawingml/2006/main" r:embed="Rcb744d8a0b6847f0"/>
+          <a:blip xmlns:r="http://schemas.openxmlformats.org/officeDocument/2006/relationships" xmlns:a="http://schemas.openxmlformats.org/drawingml/2006/main" r:embed="R473d4f9a3093416b"/>
           <a:stretch xmlns:a="http://schemas.openxmlformats.org/drawingml/2006/main"/>
         </p:blipFill>
         <p:spPr>
@@ -5965,7 +5965,7 @@
     </p:spTree>
     <p:extLst>
       <p:ext uri="{BB962C8B-B14F-4D97-AF65-F5344CB8AC3E}">
-        <p14:creationId xmlns:p14="http://schemas.microsoft.com/office/powerpoint/2010/main" val="564399211"/>
+        <p14:creationId xmlns:p14="http://schemas.microsoft.com/office/powerpoint/2010/main" val="1082640706"/>
       </p:ext>
     </p:extLst>
   </p:cSld>
@@ -5993,7 +5993,7 @@
           <p:nvPr/>
         </p:nvPicPr>
         <p:blipFill>
-          <a:blip xmlns:r="http://schemas.openxmlformats.org/officeDocument/2006/relationships" xmlns:a="http://schemas.openxmlformats.org/drawingml/2006/main" r:embed="R13d58500168c4a8a"/>
+          <a:blip xmlns:r="http://schemas.openxmlformats.org/officeDocument/2006/relationships" xmlns:a="http://schemas.openxmlformats.org/drawingml/2006/main" r:embed="Rfd117c48e1de4cb5"/>
           <a:stretch xmlns:a="http://schemas.openxmlformats.org/drawingml/2006/main"/>
         </p:blipFill>
         <p:spPr>
@@ -6009,7 +6009,7 @@
     </p:spTree>
     <p:extLst>
       <p:ext uri="{BB962C8B-B14F-4D97-AF65-F5344CB8AC3E}">
-        <p14:creationId xmlns:p14="http://schemas.microsoft.com/office/powerpoint/2010/main" val="580936685"/>
+        <p14:creationId xmlns:p14="http://schemas.microsoft.com/office/powerpoint/2010/main" val="407264599"/>
       </p:ext>
     </p:extLst>
   </p:cSld>

</xml_diff>

<commit_message>
Retain glossary and welfare explanations in PowerPoint notes
</commit_message>
<xml_diff>
--- a/teaching/macro-applications/downloads/lecture_1.pptx
+++ b/teaching/macro-applications/downloads/lecture_1.pptx
@@ -2,36 +2,36 @@
 <file path=ppt/presentation.xml><?xml version="1.0" encoding="utf-8"?>
 <p:presentation xmlns:p="http://schemas.openxmlformats.org/presentationml/2006/main">
   <p:sldMasterIdLst>
-    <p:sldMasterId xmlns:r="http://schemas.openxmlformats.org/officeDocument/2006/relationships" id="2147483648" r:id="Rb5cd981c17154364"/>
+    <p:sldMasterId xmlns:r="http://schemas.openxmlformats.org/officeDocument/2006/relationships" id="2147483648" r:id="R06c554389b9a4698"/>
   </p:sldMasterIdLst>
   <p:notesMasterIdLst>
-    <p:notesMasterId xmlns:r="http://schemas.openxmlformats.org/officeDocument/2006/relationships" r:id="R57aad9d8a0a84b9e"/>
+    <p:notesMasterId xmlns:r="http://schemas.openxmlformats.org/officeDocument/2006/relationships" r:id="R46b5b3197a2e4ebe"/>
   </p:notesMasterIdLst>
   <p:sldIdLst>
-    <p:sldId xmlns:r="http://schemas.openxmlformats.org/officeDocument/2006/relationships" id="256" r:id="Rc879a78fdc574a2c"/>
-    <p:sldId xmlns:r="http://schemas.openxmlformats.org/officeDocument/2006/relationships" id="257" r:id="R5e41a607a64e423f"/>
-    <p:sldId xmlns:r="http://schemas.openxmlformats.org/officeDocument/2006/relationships" id="258" r:id="Rf1341625b8934263"/>
-    <p:sldId xmlns:r="http://schemas.openxmlformats.org/officeDocument/2006/relationships" id="259" r:id="R301ac119edd041e2"/>
-    <p:sldId xmlns:r="http://schemas.openxmlformats.org/officeDocument/2006/relationships" id="260" r:id="R9e6d5f375cbd4af1"/>
-    <p:sldId xmlns:r="http://schemas.openxmlformats.org/officeDocument/2006/relationships" id="261" r:id="R1323949005ae41c0"/>
-    <p:sldId xmlns:r="http://schemas.openxmlformats.org/officeDocument/2006/relationships" id="262" r:id="Rdba06af3d3ed4cc6"/>
-    <p:sldId xmlns:r="http://schemas.openxmlformats.org/officeDocument/2006/relationships" id="263" r:id="Rf42597044061420b"/>
-    <p:sldId xmlns:r="http://schemas.openxmlformats.org/officeDocument/2006/relationships" id="264" r:id="Rf319d869f93e444e"/>
-    <p:sldId xmlns:r="http://schemas.openxmlformats.org/officeDocument/2006/relationships" id="265" r:id="Rde4baf65a5da4985"/>
-    <p:sldId xmlns:r="http://schemas.openxmlformats.org/officeDocument/2006/relationships" id="266" r:id="R71c53eb1b7e548b4"/>
-    <p:sldId xmlns:r="http://schemas.openxmlformats.org/officeDocument/2006/relationships" id="267" r:id="R84c358cccd7b4869"/>
-    <p:sldId xmlns:r="http://schemas.openxmlformats.org/officeDocument/2006/relationships" id="268" r:id="Rf10d423c5d1d4a76"/>
-    <p:sldId xmlns:r="http://schemas.openxmlformats.org/officeDocument/2006/relationships" id="269" r:id="Ra52f2f3f221c4bc4"/>
-    <p:sldId xmlns:r="http://schemas.openxmlformats.org/officeDocument/2006/relationships" id="270" r:id="R376538035bfe4e9d"/>
-    <p:sldId xmlns:r="http://schemas.openxmlformats.org/officeDocument/2006/relationships" id="271" r:id="R456052b6995b4808"/>
-    <p:sldId xmlns:r="http://schemas.openxmlformats.org/officeDocument/2006/relationships" id="272" r:id="Rccf4e3be0cc7447b"/>
-    <p:sldId xmlns:r="http://schemas.openxmlformats.org/officeDocument/2006/relationships" id="273" r:id="R54c15c5fdec64fd8"/>
-    <p:sldId xmlns:r="http://schemas.openxmlformats.org/officeDocument/2006/relationships" id="274" r:id="R1c3feed6073740db"/>
-    <p:sldId xmlns:r="http://schemas.openxmlformats.org/officeDocument/2006/relationships" id="275" r:id="Rffe97fe00e5a40d6"/>
-    <p:sldId xmlns:r="http://schemas.openxmlformats.org/officeDocument/2006/relationships" id="276" r:id="R4767c7678d644634"/>
-    <p:sldId xmlns:r="http://schemas.openxmlformats.org/officeDocument/2006/relationships" id="277" r:id="R626d9f4b452b4fdd"/>
-    <p:sldId xmlns:r="http://schemas.openxmlformats.org/officeDocument/2006/relationships" id="278" r:id="R0dc9411c246e4955"/>
-    <p:sldId xmlns:r="http://schemas.openxmlformats.org/officeDocument/2006/relationships" id="279" r:id="R28b0b3427814494f"/>
+    <p:sldId xmlns:r="http://schemas.openxmlformats.org/officeDocument/2006/relationships" id="256" r:id="R0a3444d9338c4305"/>
+    <p:sldId xmlns:r="http://schemas.openxmlformats.org/officeDocument/2006/relationships" id="257" r:id="R566b40449c204f8e"/>
+    <p:sldId xmlns:r="http://schemas.openxmlformats.org/officeDocument/2006/relationships" id="258" r:id="R00c1595c21fa407b"/>
+    <p:sldId xmlns:r="http://schemas.openxmlformats.org/officeDocument/2006/relationships" id="259" r:id="R2b52d4a3b3be4920"/>
+    <p:sldId xmlns:r="http://schemas.openxmlformats.org/officeDocument/2006/relationships" id="260" r:id="R808c5a4eb6a34920"/>
+    <p:sldId xmlns:r="http://schemas.openxmlformats.org/officeDocument/2006/relationships" id="261" r:id="R7356ddd65cd44fa4"/>
+    <p:sldId xmlns:r="http://schemas.openxmlformats.org/officeDocument/2006/relationships" id="262" r:id="Ra8eb8263361a45bc"/>
+    <p:sldId xmlns:r="http://schemas.openxmlformats.org/officeDocument/2006/relationships" id="263" r:id="R7a3149780c0747bd"/>
+    <p:sldId xmlns:r="http://schemas.openxmlformats.org/officeDocument/2006/relationships" id="264" r:id="Rf7c10c49251d4b8a"/>
+    <p:sldId xmlns:r="http://schemas.openxmlformats.org/officeDocument/2006/relationships" id="265" r:id="R0072d969d1764423"/>
+    <p:sldId xmlns:r="http://schemas.openxmlformats.org/officeDocument/2006/relationships" id="266" r:id="Ra37bb4c92fdb44f8"/>
+    <p:sldId xmlns:r="http://schemas.openxmlformats.org/officeDocument/2006/relationships" id="267" r:id="R00e91d0eb5f64e15"/>
+    <p:sldId xmlns:r="http://schemas.openxmlformats.org/officeDocument/2006/relationships" id="268" r:id="Rfc84e918fa134a7d"/>
+    <p:sldId xmlns:r="http://schemas.openxmlformats.org/officeDocument/2006/relationships" id="269" r:id="R69471f7f33094e20"/>
+    <p:sldId xmlns:r="http://schemas.openxmlformats.org/officeDocument/2006/relationships" id="270" r:id="R327c23df0b2444c7"/>
+    <p:sldId xmlns:r="http://schemas.openxmlformats.org/officeDocument/2006/relationships" id="271" r:id="Rddf12c7e239548c8"/>
+    <p:sldId xmlns:r="http://schemas.openxmlformats.org/officeDocument/2006/relationships" id="272" r:id="R8f06d31604364fdf"/>
+    <p:sldId xmlns:r="http://schemas.openxmlformats.org/officeDocument/2006/relationships" id="273" r:id="R29b04a439fe74780"/>
+    <p:sldId xmlns:r="http://schemas.openxmlformats.org/officeDocument/2006/relationships" id="274" r:id="Rd93dd114253f4c00"/>
+    <p:sldId xmlns:r="http://schemas.openxmlformats.org/officeDocument/2006/relationships" id="275" r:id="Rd9027e0958714f52"/>
+    <p:sldId xmlns:r="http://schemas.openxmlformats.org/officeDocument/2006/relationships" id="276" r:id="Rcbb8a97418e4496f"/>
+    <p:sldId xmlns:r="http://schemas.openxmlformats.org/officeDocument/2006/relationships" id="277" r:id="R5f057cee83eb49e6"/>
+    <p:sldId xmlns:r="http://schemas.openxmlformats.org/officeDocument/2006/relationships" id="278" r:id="R1239ecd1a3eb4f46"/>
+    <p:sldId xmlns:r="http://schemas.openxmlformats.org/officeDocument/2006/relationships" id="279" r:id="Rb270406dc453411c"/>
   </p:sldIdLst>
   <p:sldSz cx="12192000" cy="6858000"/>
   <p:notesSz cx="6858000" cy="9144000"/>
@@ -513,6 +513,16 @@
               <a:t/>
             </a:r>
           </a:p>
+          <a:p xmlns:a="http://schemas.openxmlformats.org/drawingml/2006/main">
+            <a:r>
+              <a:t/>
+            </a:r>
+          </a:p>
+          <a:p xmlns:a="http://schemas.openxmlformats.org/drawingml/2006/main">
+            <a:r>
+              <a:t/>
+            </a:r>
+          </a:p>
         </p:txBody>
       </p:sp>
       <p:sp>
@@ -628,6 +638,16 @@
               <a:t/>
             </a:r>
           </a:p>
+          <a:p xmlns:a="http://schemas.openxmlformats.org/drawingml/2006/main">
+            <a:r>
+              <a:t/>
+            </a:r>
+          </a:p>
+          <a:p xmlns:a="http://schemas.openxmlformats.org/drawingml/2006/main">
+            <a:r>
+              <a:t/>
+            </a:r>
+          </a:p>
         </p:txBody>
       </p:sp>
       <p:sp>
@@ -743,6 +763,16 @@
               <a:t/>
             </a:r>
           </a:p>
+          <a:p xmlns:a="http://schemas.openxmlformats.org/drawingml/2006/main">
+            <a:r>
+              <a:t/>
+            </a:r>
+          </a:p>
+          <a:p xmlns:a="http://schemas.openxmlformats.org/drawingml/2006/main">
+            <a:r>
+              <a:t/>
+            </a:r>
+          </a:p>
         </p:txBody>
       </p:sp>
       <p:sp>
@@ -845,6 +875,31 @@
           </a:p>
           <a:p xmlns:a="http://schemas.openxmlformats.org/drawingml/2006/main">
             <a:r>
+              <a:t>OEEC: Organisation for European Economic Co-operation</a:t>
+            </a:r>
+          </a:p>
+          <a:p xmlns:a="http://schemas.openxmlformats.org/drawingml/2006/main">
+            <a:r>
+              <a:t>OECD: Organisation for Economic Co-operation and Development</a:t>
+            </a:r>
+          </a:p>
+          <a:p xmlns:a="http://schemas.openxmlformats.org/drawingml/2006/main">
+            <a:r>
+              <a:t>EPU: European Payments Union</a:t>
+            </a:r>
+          </a:p>
+          <a:p xmlns:a="http://schemas.openxmlformats.org/drawingml/2006/main">
+            <a:r>
+              <a:t>GDP: Gross domestic product</a:t>
+            </a:r>
+          </a:p>
+          <a:p xmlns:a="http://schemas.openxmlformats.org/drawingml/2006/main">
+            <a:r>
+              <a:t/>
+            </a:r>
+          </a:p>
+          <a:p xmlns:a="http://schemas.openxmlformats.org/drawingml/2006/main">
+            <a:r>
               <a:t/>
             </a:r>
           </a:p>
@@ -960,6 +1015,31 @@
           </a:p>
           <a:p xmlns:a="http://schemas.openxmlformats.org/drawingml/2006/main">
             <a:r>
+              <a:t>OEEC: Organisation for European Economic Co-operation</a:t>
+            </a:r>
+          </a:p>
+          <a:p xmlns:a="http://schemas.openxmlformats.org/drawingml/2006/main">
+            <a:r>
+              <a:t>EFTA: European Free Trade Association</a:t>
+            </a:r>
+          </a:p>
+          <a:p xmlns:a="http://schemas.openxmlformats.org/drawingml/2006/main">
+            <a:r>
+              <a:t>ECSC: European Coal and Steel Community</a:t>
+            </a:r>
+          </a:p>
+          <a:p xmlns:a="http://schemas.openxmlformats.org/drawingml/2006/main">
+            <a:r>
+              <a:t>EEC: European Economic Community</a:t>
+            </a:r>
+          </a:p>
+          <a:p xmlns:a="http://schemas.openxmlformats.org/drawingml/2006/main">
+            <a:r>
+              <a:t/>
+            </a:r>
+          </a:p>
+          <a:p xmlns:a="http://schemas.openxmlformats.org/drawingml/2006/main">
+            <a:r>
               <a:t/>
             </a:r>
           </a:p>
@@ -1088,6 +1168,16 @@
               <a:t/>
             </a:r>
           </a:p>
+          <a:p xmlns:a="http://schemas.openxmlformats.org/drawingml/2006/main">
+            <a:r>
+              <a:t/>
+            </a:r>
+          </a:p>
+          <a:p xmlns:a="http://schemas.openxmlformats.org/drawingml/2006/main">
+            <a:r>
+              <a:t/>
+            </a:r>
+          </a:p>
         </p:txBody>
       </p:sp>
       <p:sp>
@@ -1190,6 +1280,26 @@
           </a:p>
           <a:p xmlns:a="http://schemas.openxmlformats.org/drawingml/2006/main">
             <a:r>
+              <a:t>EEC: European Economic Community</a:t>
+            </a:r>
+          </a:p>
+          <a:p xmlns:a="http://schemas.openxmlformats.org/drawingml/2006/main">
+            <a:r>
+              <a:t>EFTA: European Free Trade Association</a:t>
+            </a:r>
+          </a:p>
+          <a:p xmlns:a="http://schemas.openxmlformats.org/drawingml/2006/main">
+            <a:r>
+              <a:t>EFTA: European Free Trade Association</a:t>
+            </a:r>
+          </a:p>
+          <a:p xmlns:a="http://schemas.openxmlformats.org/drawingml/2006/main">
+            <a:r>
+              <a:t/>
+            </a:r>
+          </a:p>
+          <a:p xmlns:a="http://schemas.openxmlformats.org/drawingml/2006/main">
+            <a:r>
               <a:t/>
             </a:r>
           </a:p>
@@ -1315,6 +1425,41 @@
           </a:p>
           <a:p xmlns:a="http://schemas.openxmlformats.org/drawingml/2006/main">
             <a:r>
+              <a:t>EEC: European Economic Community</a:t>
+            </a:r>
+          </a:p>
+          <a:p xmlns:a="http://schemas.openxmlformats.org/drawingml/2006/main">
+            <a:r>
+              <a:t>GDP: Gross domestic product</a:t>
+            </a:r>
+          </a:p>
+          <a:p xmlns:a="http://schemas.openxmlformats.org/drawingml/2006/main">
+            <a:r>
+              <a:t>EEC: European Economic Community</a:t>
+            </a:r>
+          </a:p>
+          <a:p xmlns:a="http://schemas.openxmlformats.org/drawingml/2006/main">
+            <a:r>
+              <a:t>EFTA: European Free Trade Association</a:t>
+            </a:r>
+          </a:p>
+          <a:p xmlns:a="http://schemas.openxmlformats.org/drawingml/2006/main">
+            <a:r>
+              <a:t>EEC: European Economic Community</a:t>
+            </a:r>
+          </a:p>
+          <a:p xmlns:a="http://schemas.openxmlformats.org/drawingml/2006/main">
+            <a:r>
+              <a:t>EFTA: European Free Trade Association</a:t>
+            </a:r>
+          </a:p>
+          <a:p xmlns:a="http://schemas.openxmlformats.org/drawingml/2006/main">
+            <a:r>
+              <a:t/>
+            </a:r>
+          </a:p>
+          <a:p xmlns:a="http://schemas.openxmlformats.org/drawingml/2006/main">
+            <a:r>
               <a:t/>
             </a:r>
           </a:p>
@@ -1455,6 +1600,16 @@
           </a:p>
           <a:p xmlns:a="http://schemas.openxmlformats.org/drawingml/2006/main">
             <a:r>
+              <a:t/>
+            </a:r>
+          </a:p>
+          <a:p xmlns:a="http://schemas.openxmlformats.org/drawingml/2006/main">
+            <a:r>
+              <a:t/>
+            </a:r>
+          </a:p>
+          <a:p xmlns:a="http://schemas.openxmlformats.org/drawingml/2006/main">
+            <a:r>
               <a:t>https://time.com/5714602/david-hasselhoff-berlin-wall-fall/</a:t>
             </a:r>
           </a:p>
@@ -1560,6 +1715,16 @@
           </a:p>
           <a:p xmlns:a="http://schemas.openxmlformats.org/drawingml/2006/main">
             <a:r>
+              <a:t>VAT: Value added tax</a:t>
+            </a:r>
+          </a:p>
+          <a:p xmlns:a="http://schemas.openxmlformats.org/drawingml/2006/main">
+            <a:r>
+              <a:t/>
+            </a:r>
+          </a:p>
+          <a:p xmlns:a="http://schemas.openxmlformats.org/drawingml/2006/main">
+            <a:r>
               <a:t/>
             </a:r>
           </a:p>
@@ -1675,6 +1840,26 @@
           </a:p>
           <a:p xmlns:a="http://schemas.openxmlformats.org/drawingml/2006/main">
             <a:r>
+              <a:t>EU12: European Union of twelve member states</a:t>
+            </a:r>
+          </a:p>
+          <a:p xmlns:a="http://schemas.openxmlformats.org/drawingml/2006/main">
+            <a:r>
+              <a:t>EU: European Union</a:t>
+            </a:r>
+          </a:p>
+          <a:p xmlns:a="http://schemas.openxmlformats.org/drawingml/2006/main">
+            <a:r>
+              <a:t>EU: European Union</a:t>
+            </a:r>
+          </a:p>
+          <a:p xmlns:a="http://schemas.openxmlformats.org/drawingml/2006/main">
+            <a:r>
+              <a:t/>
+            </a:r>
+          </a:p>
+          <a:p xmlns:a="http://schemas.openxmlformats.org/drawingml/2006/main">
+            <a:r>
               <a:t/>
             </a:r>
           </a:p>
@@ -1803,6 +1988,16 @@
               <a:t/>
             </a:r>
           </a:p>
+          <a:p xmlns:a="http://schemas.openxmlformats.org/drawingml/2006/main">
+            <a:r>
+              <a:t/>
+            </a:r>
+          </a:p>
+          <a:p xmlns:a="http://schemas.openxmlformats.org/drawingml/2006/main">
+            <a:r>
+              <a:t/>
+            </a:r>
+          </a:p>
         </p:txBody>
       </p:sp>
       <p:sp>
@@ -1918,6 +2113,16 @@
               <a:t/>
             </a:r>
           </a:p>
+          <a:p xmlns:a="http://schemas.openxmlformats.org/drawingml/2006/main">
+            <a:r>
+              <a:t/>
+            </a:r>
+          </a:p>
+          <a:p xmlns:a="http://schemas.openxmlformats.org/drawingml/2006/main">
+            <a:r>
+              <a:t/>
+            </a:r>
+          </a:p>
         </p:txBody>
       </p:sp>
       <p:sp>
@@ -2033,6 +2238,16 @@
               <a:t/>
             </a:r>
           </a:p>
+          <a:p xmlns:a="http://schemas.openxmlformats.org/drawingml/2006/main">
+            <a:r>
+              <a:t/>
+            </a:r>
+          </a:p>
+          <a:p xmlns:a="http://schemas.openxmlformats.org/drawingml/2006/main">
+            <a:r>
+              <a:t/>
+            </a:r>
+          </a:p>
         </p:txBody>
       </p:sp>
       <p:sp>
@@ -2148,6 +2363,16 @@
               <a:t/>
             </a:r>
           </a:p>
+          <a:p xmlns:a="http://schemas.openxmlformats.org/drawingml/2006/main">
+            <a:r>
+              <a:t/>
+            </a:r>
+          </a:p>
+          <a:p xmlns:a="http://schemas.openxmlformats.org/drawingml/2006/main">
+            <a:r>
+              <a:t/>
+            </a:r>
+          </a:p>
         </p:txBody>
       </p:sp>
       <p:sp>
@@ -2263,6 +2488,16 @@
               <a:t/>
             </a:r>
           </a:p>
+          <a:p xmlns:a="http://schemas.openxmlformats.org/drawingml/2006/main">
+            <a:r>
+              <a:t/>
+            </a:r>
+          </a:p>
+          <a:p xmlns:a="http://schemas.openxmlformats.org/drawingml/2006/main">
+            <a:r>
+              <a:t/>
+            </a:r>
+          </a:p>
         </p:txBody>
       </p:sp>
       <p:sp>
@@ -2375,6 +2610,16 @@
           </a:p>
           <a:p xmlns:a="http://schemas.openxmlformats.org/drawingml/2006/main">
             <a:r>
+              <a:t/>
+            </a:r>
+          </a:p>
+          <a:p xmlns:a="http://schemas.openxmlformats.org/drawingml/2006/main">
+            <a:r>
+              <a:t/>
+            </a:r>
+          </a:p>
+          <a:p xmlns:a="http://schemas.openxmlformats.org/drawingml/2006/main">
+            <a:r>
               <a:t>https://durham.rl.talis.com/lists/d85d1ad3-e9ac-4daf-aa66-e3ddfcf902d7.html</a:t>
             </a:r>
           </a:p>
@@ -2493,6 +2738,16 @@
               <a:t/>
             </a:r>
           </a:p>
+          <a:p xmlns:a="http://schemas.openxmlformats.org/drawingml/2006/main">
+            <a:r>
+              <a:t/>
+            </a:r>
+          </a:p>
+          <a:p xmlns:a="http://schemas.openxmlformats.org/drawingml/2006/main">
+            <a:r>
+              <a:t/>
+            </a:r>
+          </a:p>
         </p:txBody>
       </p:sp>
       <p:sp>
@@ -2608,6 +2863,16 @@
               <a:t/>
             </a:r>
           </a:p>
+          <a:p xmlns:a="http://schemas.openxmlformats.org/drawingml/2006/main">
+            <a:r>
+              <a:t/>
+            </a:r>
+          </a:p>
+          <a:p xmlns:a="http://schemas.openxmlformats.org/drawingml/2006/main">
+            <a:r>
+              <a:t/>
+            </a:r>
+          </a:p>
         </p:txBody>
       </p:sp>
       <p:sp>
@@ -2710,6 +2975,16 @@
           </a:p>
           <a:p xmlns:a="http://schemas.openxmlformats.org/drawingml/2006/main">
             <a:r>
+              <a:t>EU: European Union</a:t>
+            </a:r>
+          </a:p>
+          <a:p xmlns:a="http://schemas.openxmlformats.org/drawingml/2006/main">
+            <a:r>
+              <a:t/>
+            </a:r>
+          </a:p>
+          <a:p xmlns:a="http://schemas.openxmlformats.org/drawingml/2006/main">
+            <a:r>
               <a:t/>
             </a:r>
           </a:p>
@@ -2838,6 +3113,16 @@
               <a:t/>
             </a:r>
           </a:p>
+          <a:p xmlns:a="http://schemas.openxmlformats.org/drawingml/2006/main">
+            <a:r>
+              <a:t/>
+            </a:r>
+          </a:p>
+          <a:p xmlns:a="http://schemas.openxmlformats.org/drawingml/2006/main">
+            <a:r>
+              <a:t/>
+            </a:r>
+          </a:p>
         </p:txBody>
       </p:sp>
       <p:sp>
@@ -2940,6 +3225,31 @@
           </a:p>
           <a:p xmlns:a="http://schemas.openxmlformats.org/drawingml/2006/main">
             <a:r>
+              <a:t>GDP: Gross domestic product</a:t>
+            </a:r>
+          </a:p>
+          <a:p xmlns:a="http://schemas.openxmlformats.org/drawingml/2006/main">
+            <a:r>
+              <a:t>GDP: Gross domestic product</a:t>
+            </a:r>
+          </a:p>
+          <a:p xmlns:a="http://schemas.openxmlformats.org/drawingml/2006/main">
+            <a:r>
+              <a:t>GDP: Gross domestic product</a:t>
+            </a:r>
+          </a:p>
+          <a:p xmlns:a="http://schemas.openxmlformats.org/drawingml/2006/main">
+            <a:r>
+              <a:t>GDP: Gross domestic product</a:t>
+            </a:r>
+          </a:p>
+          <a:p xmlns:a="http://schemas.openxmlformats.org/drawingml/2006/main">
+            <a:r>
+              <a:t/>
+            </a:r>
+          </a:p>
+          <a:p xmlns:a="http://schemas.openxmlformats.org/drawingml/2006/main">
+            <a:r>
               <a:t/>
             </a:r>
           </a:p>
@@ -3068,6 +3378,16 @@
               <a:t/>
             </a:r>
           </a:p>
+          <a:p xmlns:a="http://schemas.openxmlformats.org/drawingml/2006/main">
+            <a:r>
+              <a:t/>
+            </a:r>
+          </a:p>
+          <a:p xmlns:a="http://schemas.openxmlformats.org/drawingml/2006/main">
+            <a:r>
+              <a:t/>
+            </a:r>
+          </a:p>
         </p:txBody>
       </p:sp>
       <p:sp>
@@ -3170,6 +3490,16 @@
           </a:p>
           <a:p xmlns:a="http://schemas.openxmlformats.org/drawingml/2006/main">
             <a:r>
+              <a:t>NATO: North Atlantic Treaty Organization</a:t>
+            </a:r>
+          </a:p>
+          <a:p xmlns:a="http://schemas.openxmlformats.org/drawingml/2006/main">
+            <a:r>
+              <a:t/>
+            </a:r>
+          </a:p>
+          <a:p xmlns:a="http://schemas.openxmlformats.org/drawingml/2006/main">
+            <a:r>
               <a:t/>
             </a:r>
           </a:p>
@@ -3232,7 +3562,7 @@
           <p:cNvPr id="3" name="Title">
             <a:extLst xmlns:a="http://schemas.openxmlformats.org/drawingml/2006/main">
               <a:ext uri="{FF2B5EF4-FFF2-40B4-BE49-F238E27FC236}">
-                <a16:creationId xmlns:a16="http://schemas.microsoft.com/office/drawing/2014/main" id="{AC68EC88-945F-40E5-8DF1-5E01A16E49B6}"/>
+                <a16:creationId xmlns:a16="http://schemas.microsoft.com/office/drawing/2014/main" id="{4973D4F8-F70B-4DC5-8FBB-A1764F4166D4}"/>
               </a:ext>
             </a:extLst>
           </p:cNvPr>
@@ -3461,7 +3791,7 @@
           <p:cNvPr id="2" name="Subtitle">
             <a:extLst xmlns:a="http://schemas.openxmlformats.org/drawingml/2006/main">
               <a:ext uri="{FF2B5EF4-FFF2-40B4-BE49-F238E27FC236}">
-                <a16:creationId xmlns:a16="http://schemas.microsoft.com/office/drawing/2014/main" id="{9FDED75B-FCAC-49EC-8E39-C5E6461FC264}"/>
+                <a16:creationId xmlns:a16="http://schemas.microsoft.com/office/drawing/2014/main" id="{89257A22-7F1C-4074-AD51-A3AE7C879DE3}"/>
               </a:ext>
             </a:extLst>
           </p:cNvPr>
@@ -3707,7 +4037,7 @@
           <p:cNvPr id="2" name="Section title">
             <a:extLst xmlns:a="http://schemas.openxmlformats.org/drawingml/2006/main">
               <a:ext uri="{FF2B5EF4-FFF2-40B4-BE49-F238E27FC236}">
-                <a16:creationId xmlns:a16="http://schemas.microsoft.com/office/drawing/2014/main" id="{FC3CA95B-456B-4B4E-9EFD-F9852E84BD4D}"/>
+                <a16:creationId xmlns:a16="http://schemas.microsoft.com/office/drawing/2014/main" id="{1A0F9B47-F2B0-4BC8-9CC7-67167CBBE7F0}"/>
               </a:ext>
             </a:extLst>
           </p:cNvPr>
@@ -3953,7 +4283,7 @@
           <p:cNvPr id="3" name="Title">
             <a:extLst xmlns:a="http://schemas.openxmlformats.org/drawingml/2006/main">
               <a:ext uri="{FF2B5EF4-FFF2-40B4-BE49-F238E27FC236}">
-                <a16:creationId xmlns:a16="http://schemas.microsoft.com/office/drawing/2014/main" id="{F74B1533-3257-497D-A54B-E5BA9C8033E3}"/>
+                <a16:creationId xmlns:a16="http://schemas.microsoft.com/office/drawing/2014/main" id="{9BE032CE-EC15-4A10-B454-774200320A92}"/>
               </a:ext>
             </a:extLst>
           </p:cNvPr>
@@ -4182,7 +4512,7 @@
           <p:cNvPr id="2" name="Body">
             <a:extLst xmlns:a="http://schemas.openxmlformats.org/drawingml/2006/main">
               <a:ext uri="{FF2B5EF4-FFF2-40B4-BE49-F238E27FC236}">
-                <a16:creationId xmlns:a16="http://schemas.microsoft.com/office/drawing/2014/main" id="{1A1363A1-7A69-48F5-A0E9-0D49DDF0FB20}"/>
+                <a16:creationId xmlns:a16="http://schemas.microsoft.com/office/drawing/2014/main" id="{9877AC2A-F160-4198-A02E-79DB341FF9C3}"/>
               </a:ext>
             </a:extLst>
           </p:cNvPr>
@@ -4428,7 +4758,7 @@
           <p:cNvPr id="4" name="Title">
             <a:extLst xmlns:a="http://schemas.openxmlformats.org/drawingml/2006/main">
               <a:ext uri="{FF2B5EF4-FFF2-40B4-BE49-F238E27FC236}">
-                <a16:creationId xmlns:a16="http://schemas.microsoft.com/office/drawing/2014/main" id="{E6829CAE-44F1-47B9-A7E4-A5CCC61AF134}"/>
+                <a16:creationId xmlns:a16="http://schemas.microsoft.com/office/drawing/2014/main" id="{B9EF3581-94C7-40AB-8BDA-FE0A1B56216B}"/>
               </a:ext>
             </a:extLst>
           </p:cNvPr>
@@ -4657,7 +4987,7 @@
           <p:cNvPr id="2" name="Left column">
             <a:extLst xmlns:a="http://schemas.openxmlformats.org/drawingml/2006/main">
               <a:ext uri="{FF2B5EF4-FFF2-40B4-BE49-F238E27FC236}">
-                <a16:creationId xmlns:a16="http://schemas.microsoft.com/office/drawing/2014/main" id="{9052C9D8-1643-4F99-AF03-A7FF8B2E6435}"/>
+                <a16:creationId xmlns:a16="http://schemas.microsoft.com/office/drawing/2014/main" id="{7E9855E6-9AAC-4794-9A92-416BB749DC2E}"/>
               </a:ext>
             </a:extLst>
           </p:cNvPr>
@@ -4886,7 +5216,7 @@
           <p:cNvPr id="3" name="Right column">
             <a:extLst xmlns:a="http://schemas.openxmlformats.org/drawingml/2006/main">
               <a:ext uri="{FF2B5EF4-FFF2-40B4-BE49-F238E27FC236}">
-                <a16:creationId xmlns:a16="http://schemas.microsoft.com/office/drawing/2014/main" id="{881C02DC-ED16-40A6-833C-4326797E63E8}"/>
+                <a16:creationId xmlns:a16="http://schemas.microsoft.com/office/drawing/2014/main" id="{F7A23485-ED74-40B0-BFEE-6A68A2E2FEB5}"/>
               </a:ext>
             </a:extLst>
           </p:cNvPr>
@@ -5132,7 +5462,7 @@
           <p:cNvPr id="3" name="Title">
             <a:extLst xmlns:a="http://schemas.openxmlformats.org/drawingml/2006/main">
               <a:ext uri="{FF2B5EF4-FFF2-40B4-BE49-F238E27FC236}">
-                <a16:creationId xmlns:a16="http://schemas.microsoft.com/office/drawing/2014/main" id="{EE4D4881-F39A-4C30-A251-3C4D42467753}"/>
+                <a16:creationId xmlns:a16="http://schemas.microsoft.com/office/drawing/2014/main" id="{F67820EA-C610-463E-8B02-CB6C0B585788}"/>
               </a:ext>
             </a:extLst>
           </p:cNvPr>
@@ -5361,7 +5691,7 @@
           <p:cNvPr id="2" name="Left column">
             <a:extLst xmlns:a="http://schemas.openxmlformats.org/drawingml/2006/main">
               <a:ext uri="{FF2B5EF4-FFF2-40B4-BE49-F238E27FC236}">
-                <a16:creationId xmlns:a16="http://schemas.microsoft.com/office/drawing/2014/main" id="{0059F990-D0CA-40E4-B7CC-7B9B570B83BF}"/>
+                <a16:creationId xmlns:a16="http://schemas.microsoft.com/office/drawing/2014/main" id="{A8675566-B2D7-4566-B85B-7F32CBFA3121}"/>
               </a:ext>
             </a:extLst>
           </p:cNvPr>
@@ -5628,12 +5958,12 @@
   </p:cSld>
   <p:clrMap bg1="lt1" tx1="dk1" bg2="lt2" tx2="dk2" accent1="accent1" accent2="accent2" accent3="accent3" accent4="accent4" accent5="accent5" accent6="accent6" hlink="hlink" folHlink="folHlink"/>
   <p:sldLayoutIdLst>
-    <p:sldLayoutId xmlns:r="http://schemas.openxmlformats.org/officeDocument/2006/relationships" id="2147483649" r:id="R605a9b5d3def45b2"/>
-    <p:sldLayoutId xmlns:r="http://schemas.openxmlformats.org/officeDocument/2006/relationships" id="2147483650" r:id="R36ae85bd844347df"/>
-    <p:sldLayoutId xmlns:r="http://schemas.openxmlformats.org/officeDocument/2006/relationships" id="2147483651" r:id="R76e10f6325bf473f"/>
-    <p:sldLayoutId xmlns:r="http://schemas.openxmlformats.org/officeDocument/2006/relationships" id="2147483652" r:id="Rb0c3a39967e5459e"/>
-    <p:sldLayoutId xmlns:r="http://schemas.openxmlformats.org/officeDocument/2006/relationships" id="2147483653" r:id="R24682d2eafaa4881"/>
-    <p:sldLayoutId xmlns:r="http://schemas.openxmlformats.org/officeDocument/2006/relationships" id="2147483654" r:id="Re23ec7b3d95748e7"/>
+    <p:sldLayoutId xmlns:r="http://schemas.openxmlformats.org/officeDocument/2006/relationships" id="2147483649" r:id="Rd406ae0e0d3647c2"/>
+    <p:sldLayoutId xmlns:r="http://schemas.openxmlformats.org/officeDocument/2006/relationships" id="2147483650" r:id="Rb334be3ebeb7411c"/>
+    <p:sldLayoutId xmlns:r="http://schemas.openxmlformats.org/officeDocument/2006/relationships" id="2147483651" r:id="Rc88704efa16e44fe"/>
+    <p:sldLayoutId xmlns:r="http://schemas.openxmlformats.org/officeDocument/2006/relationships" id="2147483652" r:id="R2463606b139d4675"/>
+    <p:sldLayoutId xmlns:r="http://schemas.openxmlformats.org/officeDocument/2006/relationships" id="2147483653" r:id="R39c97735083f48ed"/>
+    <p:sldLayoutId xmlns:r="http://schemas.openxmlformats.org/officeDocument/2006/relationships" id="2147483654" r:id="Red11974b8d6f4057"/>
   </p:sldLayoutIdLst>
   <p:txStyles>
     <p:titleStyle>
@@ -6177,7 +6507,7 @@
           <p:cNvPr id="2" name="">
             <a:extLst xmlns:a="http://schemas.openxmlformats.org/drawingml/2006/main">
               <a:ext uri="{FF2B5EF4-FFF2-40B4-BE49-F238E27FC236}">
-                <a16:creationId xmlns:a16="http://schemas.microsoft.com/office/drawing/2014/main" id="{505FD07E-71B4-4933-AFA4-72855CDAF0A9}"/>
+                <a16:creationId xmlns:a16="http://schemas.microsoft.com/office/drawing/2014/main" id="{103F6F0B-2AE7-4754-B36E-0555A4F9F32F}"/>
               </a:ext>
             </a:extLst>
           </p:cNvPr>
@@ -6187,7 +6517,7 @@
           <p:nvPr/>
         </p:nvPicPr>
         <p:blipFill>
-          <a:blip xmlns:r="http://schemas.openxmlformats.org/officeDocument/2006/relationships" xmlns:a="http://schemas.openxmlformats.org/drawingml/2006/main" r:embed="R217530dd4b714ba3"/>
+          <a:blip xmlns:r="http://schemas.openxmlformats.org/officeDocument/2006/relationships" xmlns:a="http://schemas.openxmlformats.org/drawingml/2006/main" r:embed="R56af8a7e91db48da"/>
           <a:stretch xmlns:a="http://schemas.openxmlformats.org/drawingml/2006/main"/>
         </p:blipFill>
         <p:spPr>
@@ -6203,7 +6533,7 @@
     </p:spTree>
     <p:extLst>
       <p:ext uri="{BB962C8B-B14F-4D97-AF65-F5344CB8AC3E}">
-        <p14:creationId xmlns:p14="http://schemas.microsoft.com/office/powerpoint/2010/main" val="41609218"/>
+        <p14:creationId xmlns:p14="http://schemas.microsoft.com/office/powerpoint/2010/main" val="36372692"/>
       </p:ext>
     </p:extLst>
   </p:cSld>
@@ -6227,7 +6557,7 @@
           <p:cNvPr id="2" name="">
             <a:extLst xmlns:a="http://schemas.openxmlformats.org/drawingml/2006/main">
               <a:ext uri="{FF2B5EF4-FFF2-40B4-BE49-F238E27FC236}">
-                <a16:creationId xmlns:a16="http://schemas.microsoft.com/office/drawing/2014/main" id="{3D4A0FFC-37D7-4AEA-A85E-4C24D2874810}"/>
+                <a16:creationId xmlns:a16="http://schemas.microsoft.com/office/drawing/2014/main" id="{3A3097AE-4C97-42ED-B0FA-155C071ACC0D}"/>
               </a:ext>
             </a:extLst>
           </p:cNvPr>
@@ -6237,7 +6567,7 @@
           <p:nvPr/>
         </p:nvPicPr>
         <p:blipFill>
-          <a:blip xmlns:r="http://schemas.openxmlformats.org/officeDocument/2006/relationships" xmlns:a="http://schemas.openxmlformats.org/drawingml/2006/main" r:embed="Rcb37333f8e904568"/>
+          <a:blip xmlns:r="http://schemas.openxmlformats.org/officeDocument/2006/relationships" xmlns:a="http://schemas.openxmlformats.org/drawingml/2006/main" r:embed="Rc9691afcf7244608"/>
           <a:stretch xmlns:a="http://schemas.openxmlformats.org/drawingml/2006/main"/>
         </p:blipFill>
         <p:spPr>
@@ -6253,7 +6583,7 @@
     </p:spTree>
     <p:extLst>
       <p:ext uri="{BB962C8B-B14F-4D97-AF65-F5344CB8AC3E}">
-        <p14:creationId xmlns:p14="http://schemas.microsoft.com/office/powerpoint/2010/main" val="1001869089"/>
+        <p14:creationId xmlns:p14="http://schemas.microsoft.com/office/powerpoint/2010/main" val="1118764301"/>
       </p:ext>
     </p:extLst>
   </p:cSld>
@@ -6277,7 +6607,7 @@
           <p:cNvPr id="2" name="">
             <a:extLst xmlns:a="http://schemas.openxmlformats.org/drawingml/2006/main">
               <a:ext uri="{FF2B5EF4-FFF2-40B4-BE49-F238E27FC236}">
-                <a16:creationId xmlns:a16="http://schemas.microsoft.com/office/drawing/2014/main" id="{EF724361-9E4E-4015-BF5C-DF617422869C}"/>
+                <a16:creationId xmlns:a16="http://schemas.microsoft.com/office/drawing/2014/main" id="{CBB57EDF-4941-488D-A3AF-A61E3E3C6E9C}"/>
               </a:ext>
             </a:extLst>
           </p:cNvPr>
@@ -6287,7 +6617,7 @@
           <p:nvPr/>
         </p:nvPicPr>
         <p:blipFill>
-          <a:blip xmlns:r="http://schemas.openxmlformats.org/officeDocument/2006/relationships" xmlns:a="http://schemas.openxmlformats.org/drawingml/2006/main" r:embed="R26e0ff9698a74438"/>
+          <a:blip xmlns:r="http://schemas.openxmlformats.org/officeDocument/2006/relationships" xmlns:a="http://schemas.openxmlformats.org/drawingml/2006/main" r:embed="R0cb093e0a6de4e82"/>
           <a:stretch xmlns:a="http://schemas.openxmlformats.org/drawingml/2006/main"/>
         </p:blipFill>
         <p:spPr>
@@ -6303,7 +6633,7 @@
     </p:spTree>
     <p:extLst>
       <p:ext uri="{BB962C8B-B14F-4D97-AF65-F5344CB8AC3E}">
-        <p14:creationId xmlns:p14="http://schemas.microsoft.com/office/powerpoint/2010/main" val="333077972"/>
+        <p14:creationId xmlns:p14="http://schemas.microsoft.com/office/powerpoint/2010/main" val="1070343045"/>
       </p:ext>
     </p:extLst>
   </p:cSld>
@@ -6327,7 +6657,7 @@
           <p:cNvPr id="2" name="">
             <a:extLst xmlns:a="http://schemas.openxmlformats.org/drawingml/2006/main">
               <a:ext uri="{FF2B5EF4-FFF2-40B4-BE49-F238E27FC236}">
-                <a16:creationId xmlns:a16="http://schemas.microsoft.com/office/drawing/2014/main" id="{B1D45B8A-F5E6-43C3-BDC6-E4B1C73AAD40}"/>
+                <a16:creationId xmlns:a16="http://schemas.microsoft.com/office/drawing/2014/main" id="{94ECD9F0-FB37-43D7-ABE1-8F554D155167}"/>
               </a:ext>
             </a:extLst>
           </p:cNvPr>
@@ -6337,7 +6667,7 @@
           <p:nvPr/>
         </p:nvPicPr>
         <p:blipFill>
-          <a:blip xmlns:r="http://schemas.openxmlformats.org/officeDocument/2006/relationships" xmlns:a="http://schemas.openxmlformats.org/drawingml/2006/main" r:embed="R1931db7c75714c8a"/>
+          <a:blip xmlns:r="http://schemas.openxmlformats.org/officeDocument/2006/relationships" xmlns:a="http://schemas.openxmlformats.org/drawingml/2006/main" r:embed="R70f0389e17dd44e3"/>
           <a:stretch xmlns:a="http://schemas.openxmlformats.org/drawingml/2006/main"/>
         </p:blipFill>
         <p:spPr>
@@ -6353,7 +6683,7 @@
     </p:spTree>
     <p:extLst>
       <p:ext uri="{BB962C8B-B14F-4D97-AF65-F5344CB8AC3E}">
-        <p14:creationId xmlns:p14="http://schemas.microsoft.com/office/powerpoint/2010/main" val="2083994279"/>
+        <p14:creationId xmlns:p14="http://schemas.microsoft.com/office/powerpoint/2010/main" val="728295851"/>
       </p:ext>
     </p:extLst>
   </p:cSld>
@@ -6377,7 +6707,7 @@
           <p:cNvPr id="2" name="">
             <a:extLst xmlns:a="http://schemas.openxmlformats.org/drawingml/2006/main">
               <a:ext uri="{FF2B5EF4-FFF2-40B4-BE49-F238E27FC236}">
-                <a16:creationId xmlns:a16="http://schemas.microsoft.com/office/drawing/2014/main" id="{A0A0B688-9B43-47C6-9B31-38955F1B35EC}"/>
+                <a16:creationId xmlns:a16="http://schemas.microsoft.com/office/drawing/2014/main" id="{616E32B6-1F27-4A83-B122-2AEB1C56C750}"/>
               </a:ext>
             </a:extLst>
           </p:cNvPr>
@@ -6387,7 +6717,7 @@
           <p:nvPr/>
         </p:nvPicPr>
         <p:blipFill>
-          <a:blip xmlns:r="http://schemas.openxmlformats.org/officeDocument/2006/relationships" xmlns:a="http://schemas.openxmlformats.org/drawingml/2006/main" r:embed="Rcb0772bcf1c8404f"/>
+          <a:blip xmlns:r="http://schemas.openxmlformats.org/officeDocument/2006/relationships" xmlns:a="http://schemas.openxmlformats.org/drawingml/2006/main" r:embed="Ree765bf7cadf4a00"/>
           <a:stretch xmlns:a="http://schemas.openxmlformats.org/drawingml/2006/main"/>
         </p:blipFill>
         <p:spPr>
@@ -6403,7 +6733,7 @@
     </p:spTree>
     <p:extLst>
       <p:ext uri="{BB962C8B-B14F-4D97-AF65-F5344CB8AC3E}">
-        <p14:creationId xmlns:p14="http://schemas.microsoft.com/office/powerpoint/2010/main" val="1051850658"/>
+        <p14:creationId xmlns:p14="http://schemas.microsoft.com/office/powerpoint/2010/main" val="1555799439"/>
       </p:ext>
     </p:extLst>
   </p:cSld>
@@ -6427,7 +6757,7 @@
           <p:cNvPr id="2" name="">
             <a:extLst xmlns:a="http://schemas.openxmlformats.org/drawingml/2006/main">
               <a:ext uri="{FF2B5EF4-FFF2-40B4-BE49-F238E27FC236}">
-                <a16:creationId xmlns:a16="http://schemas.microsoft.com/office/drawing/2014/main" id="{3232098C-4D8C-41A3-AF86-DDD54F82C6AE}"/>
+                <a16:creationId xmlns:a16="http://schemas.microsoft.com/office/drawing/2014/main" id="{12C2AD52-CC3E-4F68-ADC4-060527A7B7CC}"/>
               </a:ext>
             </a:extLst>
           </p:cNvPr>
@@ -6437,7 +6767,7 @@
           <p:nvPr/>
         </p:nvPicPr>
         <p:blipFill>
-          <a:blip xmlns:r="http://schemas.openxmlformats.org/officeDocument/2006/relationships" xmlns:a="http://schemas.openxmlformats.org/drawingml/2006/main" r:embed="R46205b3753c8405f"/>
+          <a:blip xmlns:r="http://schemas.openxmlformats.org/officeDocument/2006/relationships" xmlns:a="http://schemas.openxmlformats.org/drawingml/2006/main" r:embed="R1c3b011b33c8401c"/>
           <a:stretch xmlns:a="http://schemas.openxmlformats.org/drawingml/2006/main"/>
         </p:blipFill>
         <p:spPr>
@@ -6453,7 +6783,7 @@
     </p:spTree>
     <p:extLst>
       <p:ext uri="{BB962C8B-B14F-4D97-AF65-F5344CB8AC3E}">
-        <p14:creationId xmlns:p14="http://schemas.microsoft.com/office/powerpoint/2010/main" val="1833211998"/>
+        <p14:creationId xmlns:p14="http://schemas.microsoft.com/office/powerpoint/2010/main" val="638580899"/>
       </p:ext>
     </p:extLst>
   </p:cSld>
@@ -6477,7 +6807,7 @@
           <p:cNvPr id="2" name="">
             <a:extLst xmlns:a="http://schemas.openxmlformats.org/drawingml/2006/main">
               <a:ext uri="{FF2B5EF4-FFF2-40B4-BE49-F238E27FC236}">
-                <a16:creationId xmlns:a16="http://schemas.microsoft.com/office/drawing/2014/main" id="{DCA2A51A-4981-4A2D-9670-3EC099EF7A8F}"/>
+                <a16:creationId xmlns:a16="http://schemas.microsoft.com/office/drawing/2014/main" id="{F314CC10-AFD5-4805-A94C-237840FD3850}"/>
               </a:ext>
             </a:extLst>
           </p:cNvPr>
@@ -6487,7 +6817,7 @@
           <p:nvPr/>
         </p:nvPicPr>
         <p:blipFill>
-          <a:blip xmlns:r="http://schemas.openxmlformats.org/officeDocument/2006/relationships" xmlns:a="http://schemas.openxmlformats.org/drawingml/2006/main" r:embed="Rc831e86b145546fd"/>
+          <a:blip xmlns:r="http://schemas.openxmlformats.org/officeDocument/2006/relationships" xmlns:a="http://schemas.openxmlformats.org/drawingml/2006/main" r:embed="R6ddbe0f76d00448e"/>
           <a:stretch xmlns:a="http://schemas.openxmlformats.org/drawingml/2006/main"/>
         </p:blipFill>
         <p:spPr>
@@ -6503,7 +6833,7 @@
     </p:spTree>
     <p:extLst>
       <p:ext uri="{BB962C8B-B14F-4D97-AF65-F5344CB8AC3E}">
-        <p14:creationId xmlns:p14="http://schemas.microsoft.com/office/powerpoint/2010/main" val="1451442442"/>
+        <p14:creationId xmlns:p14="http://schemas.microsoft.com/office/powerpoint/2010/main" val="94017022"/>
       </p:ext>
     </p:extLst>
   </p:cSld>
@@ -6527,7 +6857,7 @@
           <p:cNvPr id="2" name="">
             <a:extLst xmlns:a="http://schemas.openxmlformats.org/drawingml/2006/main">
               <a:ext uri="{FF2B5EF4-FFF2-40B4-BE49-F238E27FC236}">
-                <a16:creationId xmlns:a16="http://schemas.microsoft.com/office/drawing/2014/main" id="{F72CD349-FD2E-427D-8326-BEA2C39674F5}"/>
+                <a16:creationId xmlns:a16="http://schemas.microsoft.com/office/drawing/2014/main" id="{07F1E229-ED33-465D-88DA-5A3B8A4D9E07}"/>
               </a:ext>
             </a:extLst>
           </p:cNvPr>
@@ -6537,7 +6867,7 @@
           <p:nvPr/>
         </p:nvPicPr>
         <p:blipFill>
-          <a:blip xmlns:r="http://schemas.openxmlformats.org/officeDocument/2006/relationships" xmlns:a="http://schemas.openxmlformats.org/drawingml/2006/main" r:embed="Rcd423bfa0eb04465"/>
+          <a:blip xmlns:r="http://schemas.openxmlformats.org/officeDocument/2006/relationships" xmlns:a="http://schemas.openxmlformats.org/drawingml/2006/main" r:embed="Ra11857114dfd4d7d"/>
           <a:stretch xmlns:a="http://schemas.openxmlformats.org/drawingml/2006/main"/>
         </p:blipFill>
         <p:spPr>
@@ -6553,7 +6883,7 @@
     </p:spTree>
     <p:extLst>
       <p:ext uri="{BB962C8B-B14F-4D97-AF65-F5344CB8AC3E}">
-        <p14:creationId xmlns:p14="http://schemas.microsoft.com/office/powerpoint/2010/main" val="587939140"/>
+        <p14:creationId xmlns:p14="http://schemas.microsoft.com/office/powerpoint/2010/main" val="677357899"/>
       </p:ext>
     </p:extLst>
   </p:cSld>
@@ -6577,7 +6907,7 @@
           <p:cNvPr id="2" name="">
             <a:extLst xmlns:a="http://schemas.openxmlformats.org/drawingml/2006/main">
               <a:ext uri="{FF2B5EF4-FFF2-40B4-BE49-F238E27FC236}">
-                <a16:creationId xmlns:a16="http://schemas.microsoft.com/office/drawing/2014/main" id="{2159839A-EE21-431F-A80B-8591067227D3}"/>
+                <a16:creationId xmlns:a16="http://schemas.microsoft.com/office/drawing/2014/main" id="{5CA71FEB-44D6-41A7-B022-CD8BCAB0A07E}"/>
               </a:ext>
             </a:extLst>
           </p:cNvPr>
@@ -6587,7 +6917,7 @@
           <p:nvPr/>
         </p:nvPicPr>
         <p:blipFill>
-          <a:blip xmlns:r="http://schemas.openxmlformats.org/officeDocument/2006/relationships" xmlns:a="http://schemas.openxmlformats.org/drawingml/2006/main" r:embed="Rc4694a82c00841bd"/>
+          <a:blip xmlns:r="http://schemas.openxmlformats.org/officeDocument/2006/relationships" xmlns:a="http://schemas.openxmlformats.org/drawingml/2006/main" r:embed="R62a2389bb41f487e"/>
           <a:stretch xmlns:a="http://schemas.openxmlformats.org/drawingml/2006/main"/>
         </p:blipFill>
         <p:spPr>
@@ -6603,7 +6933,7 @@
     </p:spTree>
     <p:extLst>
       <p:ext uri="{BB962C8B-B14F-4D97-AF65-F5344CB8AC3E}">
-        <p14:creationId xmlns:p14="http://schemas.microsoft.com/office/powerpoint/2010/main" val="1196780379"/>
+        <p14:creationId xmlns:p14="http://schemas.microsoft.com/office/powerpoint/2010/main" val="917912552"/>
       </p:ext>
     </p:extLst>
   </p:cSld>
@@ -6627,7 +6957,7 @@
           <p:cNvPr id="2" name="">
             <a:extLst xmlns:a="http://schemas.openxmlformats.org/drawingml/2006/main">
               <a:ext uri="{FF2B5EF4-FFF2-40B4-BE49-F238E27FC236}">
-                <a16:creationId xmlns:a16="http://schemas.microsoft.com/office/drawing/2014/main" id="{6A2E9580-63B3-40E8-81AB-E89F011FB1FD}"/>
+                <a16:creationId xmlns:a16="http://schemas.microsoft.com/office/drawing/2014/main" id="{8241682E-2862-4A47-9B1A-A8AB8AB1B6B9}"/>
               </a:ext>
             </a:extLst>
           </p:cNvPr>
@@ -6637,7 +6967,7 @@
           <p:nvPr/>
         </p:nvPicPr>
         <p:blipFill>
-          <a:blip xmlns:r="http://schemas.openxmlformats.org/officeDocument/2006/relationships" xmlns:a="http://schemas.openxmlformats.org/drawingml/2006/main" r:embed="R86aba114f1ff4058"/>
+          <a:blip xmlns:r="http://schemas.openxmlformats.org/officeDocument/2006/relationships" xmlns:a="http://schemas.openxmlformats.org/drawingml/2006/main" r:embed="Rc8ffa5d6f6174122"/>
           <a:stretch xmlns:a="http://schemas.openxmlformats.org/drawingml/2006/main"/>
         </p:blipFill>
         <p:spPr>
@@ -6653,7 +6983,7 @@
     </p:spTree>
     <p:extLst>
       <p:ext uri="{BB962C8B-B14F-4D97-AF65-F5344CB8AC3E}">
-        <p14:creationId xmlns:p14="http://schemas.microsoft.com/office/powerpoint/2010/main" val="1709163010"/>
+        <p14:creationId xmlns:p14="http://schemas.microsoft.com/office/powerpoint/2010/main" val="947110220"/>
       </p:ext>
     </p:extLst>
   </p:cSld>
@@ -6677,7 +7007,7 @@
           <p:cNvPr id="2" name="">
             <a:extLst xmlns:a="http://schemas.openxmlformats.org/drawingml/2006/main">
               <a:ext uri="{FF2B5EF4-FFF2-40B4-BE49-F238E27FC236}">
-                <a16:creationId xmlns:a16="http://schemas.microsoft.com/office/drawing/2014/main" id="{596C2E50-04D1-47A9-AC56-CF3F1FC60192}"/>
+                <a16:creationId xmlns:a16="http://schemas.microsoft.com/office/drawing/2014/main" id="{B5D34F57-BEEA-4E8A-9819-6B10409BAA0D}"/>
               </a:ext>
             </a:extLst>
           </p:cNvPr>
@@ -6687,7 +7017,7 @@
           <p:nvPr/>
         </p:nvPicPr>
         <p:blipFill>
-          <a:blip xmlns:r="http://schemas.openxmlformats.org/officeDocument/2006/relationships" xmlns:a="http://schemas.openxmlformats.org/drawingml/2006/main" r:embed="R5f53993e71aa430d"/>
+          <a:blip xmlns:r="http://schemas.openxmlformats.org/officeDocument/2006/relationships" xmlns:a="http://schemas.openxmlformats.org/drawingml/2006/main" r:embed="R048c8e49df5743be"/>
           <a:stretch xmlns:a="http://schemas.openxmlformats.org/drawingml/2006/main"/>
         </p:blipFill>
         <p:spPr>
@@ -6703,7 +7033,7 @@
     </p:spTree>
     <p:extLst>
       <p:ext uri="{BB962C8B-B14F-4D97-AF65-F5344CB8AC3E}">
-        <p14:creationId xmlns:p14="http://schemas.microsoft.com/office/powerpoint/2010/main" val="777999129"/>
+        <p14:creationId xmlns:p14="http://schemas.microsoft.com/office/powerpoint/2010/main" val="355203127"/>
       </p:ext>
     </p:extLst>
   </p:cSld>
@@ -6727,7 +7057,7 @@
           <p:cNvPr id="2" name="">
             <a:extLst xmlns:a="http://schemas.openxmlformats.org/drawingml/2006/main">
               <a:ext uri="{FF2B5EF4-FFF2-40B4-BE49-F238E27FC236}">
-                <a16:creationId xmlns:a16="http://schemas.microsoft.com/office/drawing/2014/main" id="{1EDA6F3C-2B60-40C1-A605-F66C8BA08962}"/>
+                <a16:creationId xmlns:a16="http://schemas.microsoft.com/office/drawing/2014/main" id="{FB9A703F-AEBE-4546-8E54-697A755D5B65}"/>
               </a:ext>
             </a:extLst>
           </p:cNvPr>
@@ -6737,7 +7067,7 @@
           <p:nvPr/>
         </p:nvPicPr>
         <p:blipFill>
-          <a:blip xmlns:r="http://schemas.openxmlformats.org/officeDocument/2006/relationships" xmlns:a="http://schemas.openxmlformats.org/drawingml/2006/main" r:embed="R521c4fd93c414574"/>
+          <a:blip xmlns:r="http://schemas.openxmlformats.org/officeDocument/2006/relationships" xmlns:a="http://schemas.openxmlformats.org/drawingml/2006/main" r:embed="R200b7272e1e94d72"/>
           <a:stretch xmlns:a="http://schemas.openxmlformats.org/drawingml/2006/main"/>
         </p:blipFill>
         <p:spPr>
@@ -6753,7 +7083,7 @@
     </p:spTree>
     <p:extLst>
       <p:ext uri="{BB962C8B-B14F-4D97-AF65-F5344CB8AC3E}">
-        <p14:creationId xmlns:p14="http://schemas.microsoft.com/office/powerpoint/2010/main" val="911868140"/>
+        <p14:creationId xmlns:p14="http://schemas.microsoft.com/office/powerpoint/2010/main" val="322659744"/>
       </p:ext>
     </p:extLst>
   </p:cSld>
@@ -6777,7 +7107,7 @@
           <p:cNvPr id="2" name="">
             <a:extLst xmlns:a="http://schemas.openxmlformats.org/drawingml/2006/main">
               <a:ext uri="{FF2B5EF4-FFF2-40B4-BE49-F238E27FC236}">
-                <a16:creationId xmlns:a16="http://schemas.microsoft.com/office/drawing/2014/main" id="{7A7996CA-00D9-4AB2-A2E6-8967A9A72529}"/>
+                <a16:creationId xmlns:a16="http://schemas.microsoft.com/office/drawing/2014/main" id="{CC0349BE-073E-49AF-90EA-3E46B1F6A22E}"/>
               </a:ext>
             </a:extLst>
           </p:cNvPr>
@@ -6787,7 +7117,7 @@
           <p:nvPr/>
         </p:nvPicPr>
         <p:blipFill>
-          <a:blip xmlns:r="http://schemas.openxmlformats.org/officeDocument/2006/relationships" xmlns:a="http://schemas.openxmlformats.org/drawingml/2006/main" r:embed="R5bba0dde852a4731"/>
+          <a:blip xmlns:r="http://schemas.openxmlformats.org/officeDocument/2006/relationships" xmlns:a="http://schemas.openxmlformats.org/drawingml/2006/main" r:embed="Rebf2450bfcbe4ab4"/>
           <a:stretch xmlns:a="http://schemas.openxmlformats.org/drawingml/2006/main"/>
         </p:blipFill>
         <p:spPr>
@@ -6803,7 +7133,7 @@
     </p:spTree>
     <p:extLst>
       <p:ext uri="{BB962C8B-B14F-4D97-AF65-F5344CB8AC3E}">
-        <p14:creationId xmlns:p14="http://schemas.microsoft.com/office/powerpoint/2010/main" val="563202003"/>
+        <p14:creationId xmlns:p14="http://schemas.microsoft.com/office/powerpoint/2010/main" val="108092758"/>
       </p:ext>
     </p:extLst>
   </p:cSld>
@@ -6827,7 +7157,7 @@
           <p:cNvPr id="2" name="">
             <a:extLst xmlns:a="http://schemas.openxmlformats.org/drawingml/2006/main">
               <a:ext uri="{FF2B5EF4-FFF2-40B4-BE49-F238E27FC236}">
-                <a16:creationId xmlns:a16="http://schemas.microsoft.com/office/drawing/2014/main" id="{2D21750E-1354-4ACB-A5E5-C3E85FF63AC1}"/>
+                <a16:creationId xmlns:a16="http://schemas.microsoft.com/office/drawing/2014/main" id="{C9E2896C-3AD4-4EA2-BDB3-6CCC49BAD1B9}"/>
               </a:ext>
             </a:extLst>
           </p:cNvPr>
@@ -6837,7 +7167,7 @@
           <p:nvPr/>
         </p:nvPicPr>
         <p:blipFill>
-          <a:blip xmlns:r="http://schemas.openxmlformats.org/officeDocument/2006/relationships" xmlns:a="http://schemas.openxmlformats.org/drawingml/2006/main" r:embed="Rdc5ffa24d46b43fd"/>
+          <a:blip xmlns:r="http://schemas.openxmlformats.org/officeDocument/2006/relationships" xmlns:a="http://schemas.openxmlformats.org/drawingml/2006/main" r:embed="Rf52c7b5ae2114126"/>
           <a:stretch xmlns:a="http://schemas.openxmlformats.org/drawingml/2006/main"/>
         </p:blipFill>
         <p:spPr>
@@ -6853,7 +7183,7 @@
     </p:spTree>
     <p:extLst>
       <p:ext uri="{BB962C8B-B14F-4D97-AF65-F5344CB8AC3E}">
-        <p14:creationId xmlns:p14="http://schemas.microsoft.com/office/powerpoint/2010/main" val="949173102"/>
+        <p14:creationId xmlns:p14="http://schemas.microsoft.com/office/powerpoint/2010/main" val="895648588"/>
       </p:ext>
     </p:extLst>
   </p:cSld>
@@ -6877,7 +7207,7 @@
           <p:cNvPr id="2" name="">
             <a:extLst xmlns:a="http://schemas.openxmlformats.org/drawingml/2006/main">
               <a:ext uri="{FF2B5EF4-FFF2-40B4-BE49-F238E27FC236}">
-                <a16:creationId xmlns:a16="http://schemas.microsoft.com/office/drawing/2014/main" id="{BF64F1A2-8282-465F-8171-8032FE2206D1}"/>
+                <a16:creationId xmlns:a16="http://schemas.microsoft.com/office/drawing/2014/main" id="{DCDA769E-2DE8-44A3-97CD-42FE48B4DFFF}"/>
               </a:ext>
             </a:extLst>
           </p:cNvPr>
@@ -6887,7 +7217,7 @@
           <p:nvPr/>
         </p:nvPicPr>
         <p:blipFill>
-          <a:blip xmlns:r="http://schemas.openxmlformats.org/officeDocument/2006/relationships" xmlns:a="http://schemas.openxmlformats.org/drawingml/2006/main" r:embed="R92a2151270114069"/>
+          <a:blip xmlns:r="http://schemas.openxmlformats.org/officeDocument/2006/relationships" xmlns:a="http://schemas.openxmlformats.org/drawingml/2006/main" r:embed="R826d150c80504bdb"/>
           <a:stretch xmlns:a="http://schemas.openxmlformats.org/drawingml/2006/main"/>
         </p:blipFill>
         <p:spPr>
@@ -6903,7 +7233,7 @@
     </p:spTree>
     <p:extLst>
       <p:ext uri="{BB962C8B-B14F-4D97-AF65-F5344CB8AC3E}">
-        <p14:creationId xmlns:p14="http://schemas.microsoft.com/office/powerpoint/2010/main" val="688619871"/>
+        <p14:creationId xmlns:p14="http://schemas.microsoft.com/office/powerpoint/2010/main" val="432762197"/>
       </p:ext>
     </p:extLst>
   </p:cSld>
@@ -6927,7 +7257,7 @@
           <p:cNvPr id="2" name="">
             <a:extLst xmlns:a="http://schemas.openxmlformats.org/drawingml/2006/main">
               <a:ext uri="{FF2B5EF4-FFF2-40B4-BE49-F238E27FC236}">
-                <a16:creationId xmlns:a16="http://schemas.microsoft.com/office/drawing/2014/main" id="{651E246B-9B1C-43EF-9C1E-FA93517BAD53}"/>
+                <a16:creationId xmlns:a16="http://schemas.microsoft.com/office/drawing/2014/main" id="{7E2C0511-7663-4B90-98E5-5C6C628DAF86}"/>
               </a:ext>
             </a:extLst>
           </p:cNvPr>
@@ -6937,7 +7267,7 @@
           <p:nvPr/>
         </p:nvPicPr>
         <p:blipFill>
-          <a:blip xmlns:r="http://schemas.openxmlformats.org/officeDocument/2006/relationships" xmlns:a="http://schemas.openxmlformats.org/drawingml/2006/main" r:embed="R8c4c874543a2402e"/>
+          <a:blip xmlns:r="http://schemas.openxmlformats.org/officeDocument/2006/relationships" xmlns:a="http://schemas.openxmlformats.org/drawingml/2006/main" r:embed="Rbc2be640a09c4258"/>
           <a:stretch xmlns:a="http://schemas.openxmlformats.org/drawingml/2006/main"/>
         </p:blipFill>
         <p:spPr>
@@ -6953,7 +7283,7 @@
     </p:spTree>
     <p:extLst>
       <p:ext uri="{BB962C8B-B14F-4D97-AF65-F5344CB8AC3E}">
-        <p14:creationId xmlns:p14="http://schemas.microsoft.com/office/powerpoint/2010/main" val="2036484561"/>
+        <p14:creationId xmlns:p14="http://schemas.microsoft.com/office/powerpoint/2010/main" val="279282295"/>
       </p:ext>
     </p:extLst>
   </p:cSld>
@@ -6977,7 +7307,7 @@
           <p:cNvPr id="2" name="">
             <a:extLst xmlns:a="http://schemas.openxmlformats.org/drawingml/2006/main">
               <a:ext uri="{FF2B5EF4-FFF2-40B4-BE49-F238E27FC236}">
-                <a16:creationId xmlns:a16="http://schemas.microsoft.com/office/drawing/2014/main" id="{00AAC485-B817-42C2-9306-B0397886F86B}"/>
+                <a16:creationId xmlns:a16="http://schemas.microsoft.com/office/drawing/2014/main" id="{3C9E284E-2942-459E-AB11-50E558F6D972}"/>
               </a:ext>
             </a:extLst>
           </p:cNvPr>
@@ -6987,7 +7317,7 @@
           <p:nvPr/>
         </p:nvPicPr>
         <p:blipFill>
-          <a:blip xmlns:r="http://schemas.openxmlformats.org/officeDocument/2006/relationships" xmlns:a="http://schemas.openxmlformats.org/drawingml/2006/main" r:embed="R60f19f1ff5174747"/>
+          <a:blip xmlns:r="http://schemas.openxmlformats.org/officeDocument/2006/relationships" xmlns:a="http://schemas.openxmlformats.org/drawingml/2006/main" r:embed="R0e70ca23cf824b2f"/>
           <a:stretch xmlns:a="http://schemas.openxmlformats.org/drawingml/2006/main"/>
         </p:blipFill>
         <p:spPr>
@@ -7003,7 +7333,7 @@
     </p:spTree>
     <p:extLst>
       <p:ext uri="{BB962C8B-B14F-4D97-AF65-F5344CB8AC3E}">
-        <p14:creationId xmlns:p14="http://schemas.microsoft.com/office/powerpoint/2010/main" val="1331692861"/>
+        <p14:creationId xmlns:p14="http://schemas.microsoft.com/office/powerpoint/2010/main" val="1124854932"/>
       </p:ext>
     </p:extLst>
   </p:cSld>
@@ -7027,7 +7357,7 @@
           <p:cNvPr id="2" name="">
             <a:extLst xmlns:a="http://schemas.openxmlformats.org/drawingml/2006/main">
               <a:ext uri="{FF2B5EF4-FFF2-40B4-BE49-F238E27FC236}">
-                <a16:creationId xmlns:a16="http://schemas.microsoft.com/office/drawing/2014/main" id="{B6CE7FEF-93E4-4FF3-9A3A-56D8EA50AEBD}"/>
+                <a16:creationId xmlns:a16="http://schemas.microsoft.com/office/drawing/2014/main" id="{9496DB2C-552A-49B9-8A38-1147C7237646}"/>
               </a:ext>
             </a:extLst>
           </p:cNvPr>
@@ -7037,7 +7367,7 @@
           <p:nvPr/>
         </p:nvPicPr>
         <p:blipFill>
-          <a:blip xmlns:r="http://schemas.openxmlformats.org/officeDocument/2006/relationships" xmlns:a="http://schemas.openxmlformats.org/drawingml/2006/main" r:embed="Raed9d575b2e94fdd"/>
+          <a:blip xmlns:r="http://schemas.openxmlformats.org/officeDocument/2006/relationships" xmlns:a="http://schemas.openxmlformats.org/drawingml/2006/main" r:embed="Reed5d1af6aa14fb5"/>
           <a:stretch xmlns:a="http://schemas.openxmlformats.org/drawingml/2006/main"/>
         </p:blipFill>
         <p:spPr>
@@ -7053,7 +7383,7 @@
     </p:spTree>
     <p:extLst>
       <p:ext uri="{BB962C8B-B14F-4D97-AF65-F5344CB8AC3E}">
-        <p14:creationId xmlns:p14="http://schemas.microsoft.com/office/powerpoint/2010/main" val="1334961910"/>
+        <p14:creationId xmlns:p14="http://schemas.microsoft.com/office/powerpoint/2010/main" val="310956039"/>
       </p:ext>
     </p:extLst>
   </p:cSld>
@@ -7077,7 +7407,7 @@
           <p:cNvPr id="2" name="">
             <a:extLst xmlns:a="http://schemas.openxmlformats.org/drawingml/2006/main">
               <a:ext uri="{FF2B5EF4-FFF2-40B4-BE49-F238E27FC236}">
-                <a16:creationId xmlns:a16="http://schemas.microsoft.com/office/drawing/2014/main" id="{CDC4E45D-EC6D-4D91-87FF-9AD3D106AD34}"/>
+                <a16:creationId xmlns:a16="http://schemas.microsoft.com/office/drawing/2014/main" id="{1FC75536-38F5-4B5C-9F9E-52174E8880F2}"/>
               </a:ext>
             </a:extLst>
           </p:cNvPr>
@@ -7087,7 +7417,7 @@
           <p:nvPr/>
         </p:nvPicPr>
         <p:blipFill>
-          <a:blip xmlns:r="http://schemas.openxmlformats.org/officeDocument/2006/relationships" xmlns:a="http://schemas.openxmlformats.org/drawingml/2006/main" r:embed="Rb9b3347fd63d4e61"/>
+          <a:blip xmlns:r="http://schemas.openxmlformats.org/officeDocument/2006/relationships" xmlns:a="http://schemas.openxmlformats.org/drawingml/2006/main" r:embed="Rfe9ece25e43a4c9b"/>
           <a:stretch xmlns:a="http://schemas.openxmlformats.org/drawingml/2006/main"/>
         </p:blipFill>
         <p:spPr>
@@ -7103,7 +7433,7 @@
     </p:spTree>
     <p:extLst>
       <p:ext uri="{BB962C8B-B14F-4D97-AF65-F5344CB8AC3E}">
-        <p14:creationId xmlns:p14="http://schemas.microsoft.com/office/powerpoint/2010/main" val="2001814812"/>
+        <p14:creationId xmlns:p14="http://schemas.microsoft.com/office/powerpoint/2010/main" val="222575129"/>
       </p:ext>
     </p:extLst>
   </p:cSld>
@@ -7127,7 +7457,7 @@
           <p:cNvPr id="2" name="">
             <a:extLst xmlns:a="http://schemas.openxmlformats.org/drawingml/2006/main">
               <a:ext uri="{FF2B5EF4-FFF2-40B4-BE49-F238E27FC236}">
-                <a16:creationId xmlns:a16="http://schemas.microsoft.com/office/drawing/2014/main" id="{720442CC-A2C3-418A-AF5B-AD7F134120E2}"/>
+                <a16:creationId xmlns:a16="http://schemas.microsoft.com/office/drawing/2014/main" id="{DCA17DF1-05D4-44D9-A6D8-10D187C8C58D}"/>
               </a:ext>
             </a:extLst>
           </p:cNvPr>
@@ -7137,7 +7467,7 @@
           <p:nvPr/>
         </p:nvPicPr>
         <p:blipFill>
-          <a:blip xmlns:r="http://schemas.openxmlformats.org/officeDocument/2006/relationships" xmlns:a="http://schemas.openxmlformats.org/drawingml/2006/main" r:embed="R41e246d2146d4fcc"/>
+          <a:blip xmlns:r="http://schemas.openxmlformats.org/officeDocument/2006/relationships" xmlns:a="http://schemas.openxmlformats.org/drawingml/2006/main" r:embed="R488cf2ac3c0f4b49"/>
           <a:stretch xmlns:a="http://schemas.openxmlformats.org/drawingml/2006/main"/>
         </p:blipFill>
         <p:spPr>
@@ -7153,7 +7483,7 @@
     </p:spTree>
     <p:extLst>
       <p:ext uri="{BB962C8B-B14F-4D97-AF65-F5344CB8AC3E}">
-        <p14:creationId xmlns:p14="http://schemas.microsoft.com/office/powerpoint/2010/main" val="591427894"/>
+        <p14:creationId xmlns:p14="http://schemas.microsoft.com/office/powerpoint/2010/main" val="1914769114"/>
       </p:ext>
     </p:extLst>
   </p:cSld>
@@ -7177,7 +7507,7 @@
           <p:cNvPr id="2" name="">
             <a:extLst xmlns:a="http://schemas.openxmlformats.org/drawingml/2006/main">
               <a:ext uri="{FF2B5EF4-FFF2-40B4-BE49-F238E27FC236}">
-                <a16:creationId xmlns:a16="http://schemas.microsoft.com/office/drawing/2014/main" id="{CC87C9A4-8B73-4966-B235-1C8B3F7CEF98}"/>
+                <a16:creationId xmlns:a16="http://schemas.microsoft.com/office/drawing/2014/main" id="{416B7FEC-73CA-4233-BF72-30EAC2CE6FE8}"/>
               </a:ext>
             </a:extLst>
           </p:cNvPr>
@@ -7187,7 +7517,7 @@
           <p:nvPr/>
         </p:nvPicPr>
         <p:blipFill>
-          <a:blip xmlns:r="http://schemas.openxmlformats.org/officeDocument/2006/relationships" xmlns:a="http://schemas.openxmlformats.org/drawingml/2006/main" r:embed="R131f45c7b10b44d7"/>
+          <a:blip xmlns:r="http://schemas.openxmlformats.org/officeDocument/2006/relationships" xmlns:a="http://schemas.openxmlformats.org/drawingml/2006/main" r:embed="R9696f7b3586347ac"/>
           <a:stretch xmlns:a="http://schemas.openxmlformats.org/drawingml/2006/main"/>
         </p:blipFill>
         <p:spPr>
@@ -7203,7 +7533,7 @@
     </p:spTree>
     <p:extLst>
       <p:ext uri="{BB962C8B-B14F-4D97-AF65-F5344CB8AC3E}">
-        <p14:creationId xmlns:p14="http://schemas.microsoft.com/office/powerpoint/2010/main" val="934718150"/>
+        <p14:creationId xmlns:p14="http://schemas.microsoft.com/office/powerpoint/2010/main" val="44045819"/>
       </p:ext>
     </p:extLst>
   </p:cSld>
@@ -7227,7 +7557,7 @@
           <p:cNvPr id="2" name="">
             <a:extLst xmlns:a="http://schemas.openxmlformats.org/drawingml/2006/main">
               <a:ext uri="{FF2B5EF4-FFF2-40B4-BE49-F238E27FC236}">
-                <a16:creationId xmlns:a16="http://schemas.microsoft.com/office/drawing/2014/main" id="{F37392A0-C4B5-49D7-AFFE-4E5CD035D265}"/>
+                <a16:creationId xmlns:a16="http://schemas.microsoft.com/office/drawing/2014/main" id="{31BDC87D-D383-455D-A091-CB90DBDCC20E}"/>
               </a:ext>
             </a:extLst>
           </p:cNvPr>
@@ -7237,7 +7567,7 @@
           <p:nvPr/>
         </p:nvPicPr>
         <p:blipFill>
-          <a:blip xmlns:r="http://schemas.openxmlformats.org/officeDocument/2006/relationships" xmlns:a="http://schemas.openxmlformats.org/drawingml/2006/main" r:embed="R06a672df74ea445e"/>
+          <a:blip xmlns:r="http://schemas.openxmlformats.org/officeDocument/2006/relationships" xmlns:a="http://schemas.openxmlformats.org/drawingml/2006/main" r:embed="Re8b2ae227a414ee5"/>
           <a:stretch xmlns:a="http://schemas.openxmlformats.org/drawingml/2006/main"/>
         </p:blipFill>
         <p:spPr>
@@ -7253,7 +7583,7 @@
     </p:spTree>
     <p:extLst>
       <p:ext uri="{BB962C8B-B14F-4D97-AF65-F5344CB8AC3E}">
-        <p14:creationId xmlns:p14="http://schemas.microsoft.com/office/powerpoint/2010/main" val="82360096"/>
+        <p14:creationId xmlns:p14="http://schemas.microsoft.com/office/powerpoint/2010/main" val="1238158450"/>
       </p:ext>
     </p:extLst>
   </p:cSld>
@@ -7277,7 +7607,7 @@
           <p:cNvPr id="2" name="">
             <a:extLst xmlns:a="http://schemas.openxmlformats.org/drawingml/2006/main">
               <a:ext uri="{FF2B5EF4-FFF2-40B4-BE49-F238E27FC236}">
-                <a16:creationId xmlns:a16="http://schemas.microsoft.com/office/drawing/2014/main" id="{93F0FF82-1E1C-4D30-8E4F-329567BE291B}"/>
+                <a16:creationId xmlns:a16="http://schemas.microsoft.com/office/drawing/2014/main" id="{90876252-2947-405D-81F3-77411598A848}"/>
               </a:ext>
             </a:extLst>
           </p:cNvPr>
@@ -7287,7 +7617,7 @@
           <p:nvPr/>
         </p:nvPicPr>
         <p:blipFill>
-          <a:blip xmlns:r="http://schemas.openxmlformats.org/officeDocument/2006/relationships" xmlns:a="http://schemas.openxmlformats.org/drawingml/2006/main" r:embed="Ra2c13c966efe4eef"/>
+          <a:blip xmlns:r="http://schemas.openxmlformats.org/officeDocument/2006/relationships" xmlns:a="http://schemas.openxmlformats.org/drawingml/2006/main" r:embed="R4df5b32e60704e2e"/>
           <a:stretch xmlns:a="http://schemas.openxmlformats.org/drawingml/2006/main"/>
         </p:blipFill>
         <p:spPr>
@@ -7303,7 +7633,7 @@
     </p:spTree>
     <p:extLst>
       <p:ext uri="{BB962C8B-B14F-4D97-AF65-F5344CB8AC3E}">
-        <p14:creationId xmlns:p14="http://schemas.microsoft.com/office/powerpoint/2010/main" val="1768190643"/>
+        <p14:creationId xmlns:p14="http://schemas.microsoft.com/office/powerpoint/2010/main" val="2079571808"/>
       </p:ext>
     </p:extLst>
   </p:cSld>
@@ -7327,7 +7657,7 @@
           <p:cNvPr id="2" name="">
             <a:extLst xmlns:a="http://schemas.openxmlformats.org/drawingml/2006/main">
               <a:ext uri="{FF2B5EF4-FFF2-40B4-BE49-F238E27FC236}">
-                <a16:creationId xmlns:a16="http://schemas.microsoft.com/office/drawing/2014/main" id="{80235E6F-8B93-4576-A186-343646226A2E}"/>
+                <a16:creationId xmlns:a16="http://schemas.microsoft.com/office/drawing/2014/main" id="{73F307BE-9EA4-4EDF-A67E-501DDE8FEC6F}"/>
               </a:ext>
             </a:extLst>
           </p:cNvPr>
@@ -7337,7 +7667,7 @@
           <p:nvPr/>
         </p:nvPicPr>
         <p:blipFill>
-          <a:blip xmlns:r="http://schemas.openxmlformats.org/officeDocument/2006/relationships" xmlns:a="http://schemas.openxmlformats.org/drawingml/2006/main" r:embed="Rcecd601b06464512"/>
+          <a:blip xmlns:r="http://schemas.openxmlformats.org/officeDocument/2006/relationships" xmlns:a="http://schemas.openxmlformats.org/drawingml/2006/main" r:embed="R48bb88322c7c4270"/>
           <a:stretch xmlns:a="http://schemas.openxmlformats.org/drawingml/2006/main"/>
         </p:blipFill>
         <p:spPr>
@@ -7353,7 +7683,7 @@
     </p:spTree>
     <p:extLst>
       <p:ext uri="{BB962C8B-B14F-4D97-AF65-F5344CB8AC3E}">
-        <p14:creationId xmlns:p14="http://schemas.microsoft.com/office/powerpoint/2010/main" val="1107883870"/>
+        <p14:creationId xmlns:p14="http://schemas.microsoft.com/office/powerpoint/2010/main" val="1067840794"/>
       </p:ext>
     </p:extLst>
   </p:cSld>

</xml_diff>